<commit_message>
Sync documentation with demo evolution: per-utility device model + DER assets + combo CA patterns (TDD v1.2, BRFplus v1.2 w/ msg 053 medical dynamic-pricing block, workbook, Runtime v1.1, SDD note, deck URLs/personas); tools canonical for generators
Co-Authored-By: Claude Fable 5 <noreply@anthropic.com>
</commit_message>
<xml_diff>
--- a/Enrollment Center/Enrollment Center - Client Presentation v1.0.pptx
+++ b/Enrollment Center/Enrollment Center - Client Presentation v1.0.pptx
@@ -6043,7 +6043,7 @@
                 </a:solidFill>
                 <a:latin typeface="Arial"/>
               </a:rPr>
-              <a:t>Demo: nammi2011.github.io/enrollment-center-demo   ·   Full design set available for review</a:t>
+              <a:t>Demo: demo.svgbs.com   ·   Full design set available for review</a:t>
             </a:r>
           </a:p>
         </p:txBody>
@@ -8075,7 +8075,7 @@
                 </a:solidFill>
                 <a:latin typeface="Arial"/>
               </a:rPr>
-              <a:t>nammi2011.github.io/enrollment-center-demo/</a:t>
+              <a:t>demo.svgbs.com  (pending DNS; live: sri-varahi-global-business-services-llc.github.io/enrollment-center-demo)</a:t>
             </a:r>
           </a:p>
         </p:txBody>
@@ -8193,7 +8193,7 @@
                 </a:solidFill>
                 <a:latin typeface="Arial"/>
               </a:rPr>
-              <a:t>4 customer personas, 28 programs</a:t>
+              <a:t>7 eligibility personas · 28 programs</a:t>
             </a:r>
           </a:p>
         </p:txBody>
@@ -8228,7 +8228,7 @@
                 </a:solidFill>
                 <a:latin typeface="Arial"/>
               </a:rPr>
-              <a:t>…/enrollment-center-demo/workcenter.html</a:t>
+              <a:t>demo.svgbs.com/workcenter.html</a:t>
             </a:r>
           </a:p>
         </p:txBody>
@@ -8381,7 +8381,7 @@
                 </a:solidFill>
                 <a:latin typeface="Arial"/>
               </a:rPr>
-              <a:t>…/enrollment-center-demo/movein.html</a:t>
+              <a:t>demo.svgbs.com/movein.html</a:t>
             </a:r>
           </a:p>
         </p:txBody>
@@ -8558,7 +8558,7 @@
                 </a:solidFill>
                 <a:latin typeface="Arial"/>
               </a:rPr>
-              <a:t>Switch personas — credit, medical,</a:t>
+              <a:t>Switch among 7 personas — non-AMI,</a:t>
             </a:r>
           </a:p>
           <a:p>
@@ -8574,7 +8574,7 @@
                 </a:solidFill>
                 <a:latin typeface="Arial"/>
               </a:rPr>
-              <a:t>commercial rules change live</a:t>
+              <a:t>medical, prepay, commercial — rules change live</a:t>
             </a:r>
           </a:p>
         </p:txBody>

</xml_diff>

<commit_message>
Incorporate AI/ML scope: AI-ML Roadmap v1.0 (7 use cases, governance, phasing), SDD Appendix B, deck AI slide, demo AI features generator
Co-Authored-By: Claude Fable 5 <noreply@anthropic.com>
</commit_message>
<xml_diff>
--- a/Enrollment Center/Enrollment Center - Client Presentation v1.0.pptx
+++ b/Enrollment Center/Enrollment Center - Client Presentation v1.0.pptx
@@ -15,6 +15,7 @@
     <p:sldId id="263" r:id="rId14"/>
     <p:sldId id="264" r:id="rId15"/>
     <p:sldId id="265" r:id="rId16"/>
+    <p:sldId id="269" r:id="rId20"/>
     <p:sldId id="266" r:id="rId17"/>
     <p:sldId id="267" r:id="rId18"/>
     <p:sldId id="268" r:id="rId19"/>
@@ -6044,6 +6045,757 @@
                 <a:latin typeface="Arial"/>
               </a:rPr>
               <a:t>Demo: demo.svgbs.com   ·   Full design set available for review</a:t>
+            </a:r>
+          </a:p>
+        </p:txBody>
+      </p:sp>
+    </p:spTree>
+  </p:cSld>
+  <p:clrMapOvr>
+    <a:masterClrMapping/>
+  </p:clrMapOvr>
+</p:sld>
+</file>
+
+<file path=ppt/slides/slide14.xml><?xml version="1.0" encoding="utf-8"?>
+<p:sld xmlns:a="http://schemas.openxmlformats.org/drawingml/2006/main" xmlns:p="http://schemas.openxmlformats.org/presentationml/2006/main" xmlns:r="http://schemas.openxmlformats.org/officeDocument/2006/relationships">
+  <p:cSld>
+    <p:bg>
+      <p:bgPr>
+        <a:solidFill>
+          <a:srgbClr val="FFFFFF"/>
+        </a:solidFill>
+        <a:effectLst/>
+      </p:bgPr>
+    </p:bg>
+    <p:spTree>
+      <p:nvGrpSpPr>
+        <p:cNvPr id="1" name=""/>
+        <p:cNvGrpSpPr/>
+        <p:nvPr/>
+      </p:nvGrpSpPr>
+      <p:grpSpPr/>
+      <p:sp>
+        <p:nvSpPr>
+          <p:cNvPr id="2" name="TextBox 1"/>
+          <p:cNvSpPr txBox="1"/>
+          <p:nvPr/>
+        </p:nvSpPr>
+        <p:spPr>
+          <a:xfrm>
+            <a:off x="548640" y="347472"/>
+            <a:ext cx="11064240" cy="685800"/>
+          </a:xfrm>
+          <a:prstGeom prst="rect">
+            <a:avLst/>
+          </a:prstGeom>
+          <a:noFill/>
+        </p:spPr>
+        <p:txBody>
+          <a:bodyPr wrap="square" lIns="0" rIns="0" tIns="0" bIns="0">
+            <a:spAutoFit/>
+          </a:bodyPr>
+          <a:lstStyle/>
+          <a:p>
+            <a:pPr algn="l"/>
+            <a:r>
+              <a:rPr sz="3000" b="1">
+                <a:solidFill>
+                  <a:srgbClr val="1D2D3E"/>
+                </a:solidFill>
+                <a:latin typeface="Arial"/>
+              </a:rPr>
+              <a:t>AI on top of the rules</a:t>
+            </a:r>
+          </a:p>
+        </p:txBody>
+      </p:sp>
+      <p:sp>
+        <p:nvSpPr>
+          <p:cNvPr id="3" name="TextBox 2"/>
+          <p:cNvSpPr txBox="1"/>
+          <p:nvPr/>
+        </p:nvSpPr>
+        <p:spPr>
+          <a:xfrm>
+            <a:off x="548640" y="932688"/>
+            <a:ext cx="11064240" cy="365760"/>
+          </a:xfrm>
+          <a:prstGeom prst="rect">
+            <a:avLst/>
+          </a:prstGeom>
+          <a:noFill/>
+        </p:spPr>
+        <p:txBody>
+          <a:bodyPr wrap="square" lIns="0" rIns="0" tIns="0" bIns="0">
+            <a:spAutoFit/>
+          </a:bodyPr>
+          <a:lstStyle/>
+          <a:p>
+            <a:pPr algn="l"/>
+            <a:r>
+              <a:rPr sz="1400" b="0">
+                <a:solidFill>
+                  <a:srgbClr val="556B82"/>
+                </a:solidFill>
+                <a:latin typeface="Arial"/>
+              </a:rPr>
+              <a:t>Machine learning recommends — the rules engine decides. Full portfolio in the AI/ML Roadmap.</a:t>
+            </a:r>
+          </a:p>
+        </p:txBody>
+      </p:sp>
+      <p:sp>
+        <p:nvSpPr>
+          <p:cNvPr id="4" name="Rounded Rectangle 3"/>
+          <p:cNvSpPr/>
+          <p:nvPr/>
+        </p:nvSpPr>
+        <p:spPr>
+          <a:xfrm>
+            <a:off x="548640" y="1645920"/>
+            <a:ext cx="5440680" cy="1463040"/>
+          </a:xfrm>
+          <a:prstGeom prst="roundRect">
+            <a:avLst>
+              <a:gd name="adj" fmla="val 8000"/>
+            </a:avLst>
+          </a:prstGeom>
+          <a:solidFill>
+            <a:srgbClr val="F5F6F7"/>
+          </a:solidFill>
+          <a:ln w="9525">
+            <a:solidFill>
+              <a:srgbClr val="D9D9D9"/>
+            </a:solidFill>
+          </a:ln>
+          <a:effectLst/>
+        </p:spPr>
+        <p:style>
+          <a:lnRef idx="1">
+            <a:schemeClr val="accent1"/>
+          </a:lnRef>
+          <a:fillRef idx="3">
+            <a:schemeClr val="accent1"/>
+          </a:fillRef>
+          <a:effectRef idx="2">
+            <a:schemeClr val="accent1"/>
+          </a:effectRef>
+          <a:fontRef idx="minor">
+            <a:schemeClr val="lt1"/>
+          </a:fontRef>
+        </p:style>
+        <p:txBody>
+          <a:bodyPr rtlCol="0" anchor="ctr"/>
+          <a:lstStyle/>
+          <a:p>
+            <a:pPr algn="ctr"/>
+          </a:p>
+        </p:txBody>
+      </p:sp>
+      <p:sp>
+        <p:nvSpPr>
+          <p:cNvPr id="5" name="Rounded Rectangle 4"/>
+          <p:cNvSpPr/>
+          <p:nvPr/>
+        </p:nvSpPr>
+        <p:spPr>
+          <a:xfrm>
+            <a:off x="822959" y="1847088"/>
+            <a:ext cx="2103120" cy="310896"/>
+          </a:xfrm>
+          <a:prstGeom prst="roundRect">
+            <a:avLst>
+              <a:gd name="adj" fmla="val 50000"/>
+            </a:avLst>
+          </a:prstGeom>
+          <a:solidFill>
+            <a:srgbClr val="F0EAFD"/>
+          </a:solidFill>
+          <a:ln>
+            <a:noFill/>
+          </a:ln>
+          <a:effectLst/>
+        </p:spPr>
+        <p:style>
+          <a:lnRef idx="1">
+            <a:schemeClr val="accent1"/>
+          </a:lnRef>
+          <a:fillRef idx="3">
+            <a:schemeClr val="accent1"/>
+          </a:fillRef>
+          <a:effectRef idx="2">
+            <a:schemeClr val="accent1"/>
+          </a:effectRef>
+          <a:fontRef idx="minor">
+            <a:schemeClr val="lt1"/>
+          </a:fontRef>
+        </p:style>
+        <p:txBody>
+          <a:bodyPr rtlCol="0" anchor="ctr" lIns="18288" rIns="18288" tIns="0" bIns="0"/>
+          <a:lstStyle/>
+          <a:p>
+            <a:pPr algn="ctr"/>
+            <a:r>
+              <a:rPr sz="1150" b="1">
+                <a:solidFill>
+                  <a:srgbClr val="6C32A9"/>
+                </a:solidFill>
+                <a:latin typeface="Arial"/>
+              </a:rPr>
+              <a:t>AI-1 · Recommend</a:t>
+            </a:r>
+          </a:p>
+        </p:txBody>
+      </p:sp>
+      <p:sp>
+        <p:nvSpPr>
+          <p:cNvPr id="6" name="TextBox 5"/>
+          <p:cNvSpPr txBox="1"/>
+          <p:nvPr/>
+        </p:nvSpPr>
+        <p:spPr>
+          <a:xfrm>
+            <a:off x="822959" y="2267712"/>
+            <a:ext cx="4937760" cy="777240"/>
+          </a:xfrm>
+          <a:prstGeom prst="rect">
+            <a:avLst/>
+          </a:prstGeom>
+          <a:noFill/>
+        </p:spPr>
+        <p:txBody>
+          <a:bodyPr wrap="square" lIns="0" rIns="0" tIns="0" bIns="0">
+            <a:spAutoFit/>
+          </a:bodyPr>
+          <a:lstStyle/>
+          <a:p>
+            <a:pPr algn="l">
+              <a:lnSpc>
+                <a:spcPct val="112000"/>
+              </a:lnSpc>
+            </a:pPr>
+            <a:r>
+              <a:rPr sz="1200" b="0">
+                <a:solidFill>
+                  <a:srgbClr val="556B82"/>
+                </a:solidFill>
+                <a:latin typeface="Arial"/>
+              </a:rPr>
+              <a:t>Next-best-program ranking with reasons — agents pitch the right program first (live in the demo)</a:t>
+            </a:r>
+          </a:p>
+        </p:txBody>
+      </p:sp>
+      <p:sp>
+        <p:nvSpPr>
+          <p:cNvPr id="7" name="Rounded Rectangle 6"/>
+          <p:cNvSpPr/>
+          <p:nvPr/>
+        </p:nvSpPr>
+        <p:spPr>
+          <a:xfrm>
+            <a:off x="6172200" y="1645920"/>
+            <a:ext cx="5440680" cy="1463040"/>
+          </a:xfrm>
+          <a:prstGeom prst="roundRect">
+            <a:avLst>
+              <a:gd name="adj" fmla="val 8000"/>
+            </a:avLst>
+          </a:prstGeom>
+          <a:solidFill>
+            <a:srgbClr val="F5F6F7"/>
+          </a:solidFill>
+          <a:ln w="9525">
+            <a:solidFill>
+              <a:srgbClr val="D9D9D9"/>
+            </a:solidFill>
+          </a:ln>
+          <a:effectLst/>
+        </p:spPr>
+        <p:style>
+          <a:lnRef idx="1">
+            <a:schemeClr val="accent1"/>
+          </a:lnRef>
+          <a:fillRef idx="3">
+            <a:schemeClr val="accent1"/>
+          </a:fillRef>
+          <a:effectRef idx="2">
+            <a:schemeClr val="accent1"/>
+          </a:effectRef>
+          <a:fontRef idx="minor">
+            <a:schemeClr val="lt1"/>
+          </a:fontRef>
+        </p:style>
+        <p:txBody>
+          <a:bodyPr rtlCol="0" anchor="ctr"/>
+          <a:lstStyle/>
+          <a:p>
+            <a:pPr algn="ctr"/>
+          </a:p>
+        </p:txBody>
+      </p:sp>
+      <p:sp>
+        <p:nvSpPr>
+          <p:cNvPr id="8" name="Rounded Rectangle 7"/>
+          <p:cNvSpPr/>
+          <p:nvPr/>
+        </p:nvSpPr>
+        <p:spPr>
+          <a:xfrm>
+            <a:off x="6446520" y="1847088"/>
+            <a:ext cx="2103120" cy="310896"/>
+          </a:xfrm>
+          <a:prstGeom prst="roundRect">
+            <a:avLst>
+              <a:gd name="adj" fmla="val 50000"/>
+            </a:avLst>
+          </a:prstGeom>
+          <a:solidFill>
+            <a:srgbClr val="E3F0FF"/>
+          </a:solidFill>
+          <a:ln>
+            <a:noFill/>
+          </a:ln>
+          <a:effectLst/>
+        </p:spPr>
+        <p:style>
+          <a:lnRef idx="1">
+            <a:schemeClr val="accent1"/>
+          </a:lnRef>
+          <a:fillRef idx="3">
+            <a:schemeClr val="accent1"/>
+          </a:fillRef>
+          <a:effectRef idx="2">
+            <a:schemeClr val="accent1"/>
+          </a:effectRef>
+          <a:fontRef idx="minor">
+            <a:schemeClr val="lt1"/>
+          </a:fontRef>
+        </p:style>
+        <p:txBody>
+          <a:bodyPr rtlCol="0" anchor="ctr" lIns="18288" rIns="18288" tIns="0" bIns="0"/>
+          <a:lstStyle/>
+          <a:p>
+            <a:pPr algn="ctr"/>
+            <a:r>
+              <a:rPr sz="1150" b="1">
+                <a:solidFill>
+                  <a:srgbClr val="0057D2"/>
+                </a:solidFill>
+                <a:latin typeface="Arial"/>
+              </a:rPr>
+              <a:t>AI-2 · Explain</a:t>
+            </a:r>
+          </a:p>
+        </p:txBody>
+      </p:sp>
+      <p:sp>
+        <p:nvSpPr>
+          <p:cNvPr id="9" name="TextBox 8"/>
+          <p:cNvSpPr txBox="1"/>
+          <p:nvPr/>
+        </p:nvSpPr>
+        <p:spPr>
+          <a:xfrm>
+            <a:off x="6446520" y="2267712"/>
+            <a:ext cx="4937760" cy="777240"/>
+          </a:xfrm>
+          <a:prstGeom prst="rect">
+            <a:avLst/>
+          </a:prstGeom>
+          <a:noFill/>
+        </p:spPr>
+        <p:txBody>
+          <a:bodyPr wrap="square" lIns="0" rIns="0" tIns="0" bIns="0">
+            <a:spAutoFit/>
+          </a:bodyPr>
+          <a:lstStyle/>
+          <a:p>
+            <a:pPr algn="l">
+              <a:lnSpc>
+                <a:spcPct val="112000"/>
+              </a:lnSpc>
+            </a:pPr>
+            <a:r>
+              <a:rPr sz="1200" b="0">
+                <a:solidFill>
+                  <a:srgbClr val="556B82"/>
+                </a:solidFill>
+                <a:latin typeface="Arial"/>
+              </a:rPr>
+              <a:t>Plain-language program explanations for THIS customer, grounded on the catalog (live in the demo)</a:t>
+            </a:r>
+          </a:p>
+        </p:txBody>
+      </p:sp>
+      <p:sp>
+        <p:nvSpPr>
+          <p:cNvPr id="10" name="Rounded Rectangle 9"/>
+          <p:cNvSpPr/>
+          <p:nvPr/>
+        </p:nvSpPr>
+        <p:spPr>
+          <a:xfrm>
+            <a:off x="548640" y="3246120"/>
+            <a:ext cx="5440680" cy="1463040"/>
+          </a:xfrm>
+          <a:prstGeom prst="roundRect">
+            <a:avLst>
+              <a:gd name="adj" fmla="val 8000"/>
+            </a:avLst>
+          </a:prstGeom>
+          <a:solidFill>
+            <a:srgbClr val="F5F6F7"/>
+          </a:solidFill>
+          <a:ln w="9525">
+            <a:solidFill>
+              <a:srgbClr val="D9D9D9"/>
+            </a:solidFill>
+          </a:ln>
+          <a:effectLst/>
+        </p:spPr>
+        <p:style>
+          <a:lnRef idx="1">
+            <a:schemeClr val="accent1"/>
+          </a:lnRef>
+          <a:fillRef idx="3">
+            <a:schemeClr val="accent1"/>
+          </a:fillRef>
+          <a:effectRef idx="2">
+            <a:schemeClr val="accent1"/>
+          </a:effectRef>
+          <a:fontRef idx="minor">
+            <a:schemeClr val="lt1"/>
+          </a:fontRef>
+        </p:style>
+        <p:txBody>
+          <a:bodyPr rtlCol="0" anchor="ctr"/>
+          <a:lstStyle/>
+          <a:p>
+            <a:pPr algn="ctr"/>
+          </a:p>
+        </p:txBody>
+      </p:sp>
+      <p:sp>
+        <p:nvSpPr>
+          <p:cNvPr id="11" name="Rounded Rectangle 10"/>
+          <p:cNvSpPr/>
+          <p:nvPr/>
+        </p:nvSpPr>
+        <p:spPr>
+          <a:xfrm>
+            <a:off x="822959" y="3447288"/>
+            <a:ext cx="2103120" cy="310896"/>
+          </a:xfrm>
+          <a:prstGeom prst="roundRect">
+            <a:avLst>
+              <a:gd name="adj" fmla="val 50000"/>
+            </a:avLst>
+          </a:prstGeom>
+          <a:solidFill>
+            <a:srgbClr val="EBF5EB"/>
+          </a:solidFill>
+          <a:ln>
+            <a:noFill/>
+          </a:ln>
+          <a:effectLst/>
+        </p:spPr>
+        <p:style>
+          <a:lnRef idx="1">
+            <a:schemeClr val="accent1"/>
+          </a:lnRef>
+          <a:fillRef idx="3">
+            <a:schemeClr val="accent1"/>
+          </a:fillRef>
+          <a:effectRef idx="2">
+            <a:schemeClr val="accent1"/>
+          </a:effectRef>
+          <a:fontRef idx="minor">
+            <a:schemeClr val="lt1"/>
+          </a:fontRef>
+        </p:style>
+        <p:txBody>
+          <a:bodyPr rtlCol="0" anchor="ctr" lIns="18288" rIns="18288" tIns="0" bIns="0"/>
+          <a:lstStyle/>
+          <a:p>
+            <a:pPr algn="ctr"/>
+            <a:r>
+              <a:rPr sz="1150" b="1">
+                <a:solidFill>
+                  <a:srgbClr val="188918"/>
+                </a:solidFill>
+                <a:latin typeface="Arial"/>
+              </a:rPr>
+              <a:t>AI-3 · Verify savings</a:t>
+            </a:r>
+          </a:p>
+        </p:txBody>
+      </p:sp>
+      <p:sp>
+        <p:nvSpPr>
+          <p:cNvPr id="12" name="TextBox 11"/>
+          <p:cNvSpPr txBox="1"/>
+          <p:nvPr/>
+        </p:nvSpPr>
+        <p:spPr>
+          <a:xfrm>
+            <a:off x="822959" y="3867911"/>
+            <a:ext cx="4937760" cy="777240"/>
+          </a:xfrm>
+          <a:prstGeom prst="rect">
+            <a:avLst/>
+          </a:prstGeom>
+          <a:noFill/>
+        </p:spPr>
+        <p:txBody>
+          <a:bodyPr wrap="square" lIns="0" rIns="0" tIns="0" bIns="0">
+            <a:spAutoFit/>
+          </a:bodyPr>
+          <a:lstStyle/>
+          <a:p>
+            <a:pPr algn="l">
+              <a:lnSpc>
+                <a:spcPct val="112000"/>
+              </a:lnSpc>
+            </a:pPr>
+            <a:r>
+              <a:rPr sz="1200" b="0">
+                <a:solidFill>
+                  <a:srgbClr val="556B82"/>
+                </a:solidFill>
+                <a:latin typeface="Arial"/>
+              </a:rPr>
+              <a:t>Bill-impact simulation on interval data before rate enrollment — recommend only when it saves</a:t>
+            </a:r>
+          </a:p>
+        </p:txBody>
+      </p:sp>
+      <p:sp>
+        <p:nvSpPr>
+          <p:cNvPr id="13" name="Rounded Rectangle 12"/>
+          <p:cNvSpPr/>
+          <p:nvPr/>
+        </p:nvSpPr>
+        <p:spPr>
+          <a:xfrm>
+            <a:off x="6172200" y="3246120"/>
+            <a:ext cx="5440680" cy="1463040"/>
+          </a:xfrm>
+          <a:prstGeom prst="roundRect">
+            <a:avLst>
+              <a:gd name="adj" fmla="val 8000"/>
+            </a:avLst>
+          </a:prstGeom>
+          <a:solidFill>
+            <a:srgbClr val="F5F6F7"/>
+          </a:solidFill>
+          <a:ln w="9525">
+            <a:solidFill>
+              <a:srgbClr val="D9D9D9"/>
+            </a:solidFill>
+          </a:ln>
+          <a:effectLst/>
+        </p:spPr>
+        <p:style>
+          <a:lnRef idx="1">
+            <a:schemeClr val="accent1"/>
+          </a:lnRef>
+          <a:fillRef idx="3">
+            <a:schemeClr val="accent1"/>
+          </a:fillRef>
+          <a:effectRef idx="2">
+            <a:schemeClr val="accent1"/>
+          </a:effectRef>
+          <a:fontRef idx="minor">
+            <a:schemeClr val="lt1"/>
+          </a:fontRef>
+        </p:style>
+        <p:txBody>
+          <a:bodyPr rtlCol="0" anchor="ctr"/>
+          <a:lstStyle/>
+          <a:p>
+            <a:pPr algn="ctr"/>
+          </a:p>
+        </p:txBody>
+      </p:sp>
+      <p:sp>
+        <p:nvSpPr>
+          <p:cNvPr id="14" name="Rounded Rectangle 13"/>
+          <p:cNvSpPr/>
+          <p:nvPr/>
+        </p:nvSpPr>
+        <p:spPr>
+          <a:xfrm>
+            <a:off x="6446520" y="3447288"/>
+            <a:ext cx="2103120" cy="310896"/>
+          </a:xfrm>
+          <a:prstGeom prst="roundRect">
+            <a:avLst>
+              <a:gd name="adj" fmla="val 50000"/>
+            </a:avLst>
+          </a:prstGeom>
+          <a:solidFill>
+            <a:srgbClr val="FFB300"/>
+          </a:solidFill>
+          <a:ln>
+            <a:noFill/>
+          </a:ln>
+          <a:effectLst/>
+        </p:spPr>
+        <p:style>
+          <a:lnRef idx="1">
+            <a:schemeClr val="accent1"/>
+          </a:lnRef>
+          <a:fillRef idx="3">
+            <a:schemeClr val="accent1"/>
+          </a:fillRef>
+          <a:effectRef idx="2">
+            <a:schemeClr val="accent1"/>
+          </a:effectRef>
+          <a:fontRef idx="minor">
+            <a:schemeClr val="lt1"/>
+          </a:fontRef>
+        </p:style>
+        <p:txBody>
+          <a:bodyPr rtlCol="0" anchor="ctr" lIns="18288" rIns="18288" tIns="0" bIns="0"/>
+          <a:lstStyle/>
+          <a:p>
+            <a:pPr algn="ctr"/>
+            <a:r>
+              <a:rPr sz="1150" b="1">
+                <a:solidFill>
+                  <a:srgbClr val="3B2A00"/>
+                </a:solidFill>
+                <a:latin typeface="Arial"/>
+              </a:rPr>
+              <a:t>AI-4 · Protect</a:t>
+            </a:r>
+          </a:p>
+        </p:txBody>
+      </p:sp>
+      <p:sp>
+        <p:nvSpPr>
+          <p:cNvPr id="15" name="TextBox 14"/>
+          <p:cNvSpPr txBox="1"/>
+          <p:nvPr/>
+        </p:nvSpPr>
+        <p:spPr>
+          <a:xfrm>
+            <a:off x="6446520" y="3867911"/>
+            <a:ext cx="4937760" cy="777240"/>
+          </a:xfrm>
+          <a:prstGeom prst="rect">
+            <a:avLst/>
+          </a:prstGeom>
+          <a:noFill/>
+        </p:spPr>
+        <p:txBody>
+          <a:bodyPr wrap="square" lIns="0" rIns="0" tIns="0" bIns="0">
+            <a:spAutoFit/>
+          </a:bodyPr>
+          <a:lstStyle/>
+          <a:p>
+            <a:pPr algn="l">
+              <a:lnSpc>
+                <a:spcPct val="112000"/>
+              </a:lnSpc>
+            </a:pPr>
+            <a:r>
+              <a:rPr sz="1200" b="0">
+                <a:solidFill>
+                  <a:srgbClr val="556B82"/>
+                </a:solidFill>
+                <a:latin typeface="Arial"/>
+              </a:rPr>
+              <a:t>Payment-plan default prediction, document intelligence for assistance programs, exception triage</a:t>
+            </a:r>
+          </a:p>
+        </p:txBody>
+      </p:sp>
+      <p:sp>
+        <p:nvSpPr>
+          <p:cNvPr id="16" name="Rounded Rectangle 15"/>
+          <p:cNvSpPr/>
+          <p:nvPr/>
+        </p:nvSpPr>
+        <p:spPr>
+          <a:xfrm>
+            <a:off x="548640" y="4937760"/>
+            <a:ext cx="11064240" cy="1234440"/>
+          </a:xfrm>
+          <a:prstGeom prst="roundRect">
+            <a:avLst>
+              <a:gd name="adj" fmla="val 8000"/>
+            </a:avLst>
+          </a:prstGeom>
+          <a:solidFill>
+            <a:srgbClr val="12233F"/>
+          </a:solidFill>
+          <a:ln w="9525">
+            <a:solidFill>
+              <a:srgbClr val="12233F"/>
+            </a:solidFill>
+          </a:ln>
+          <a:effectLst/>
+        </p:spPr>
+        <p:style>
+          <a:lnRef idx="1">
+            <a:schemeClr val="accent1"/>
+          </a:lnRef>
+          <a:fillRef idx="3">
+            <a:schemeClr val="accent1"/>
+          </a:fillRef>
+          <a:effectRef idx="2">
+            <a:schemeClr val="accent1"/>
+          </a:effectRef>
+          <a:fontRef idx="minor">
+            <a:schemeClr val="lt1"/>
+          </a:fontRef>
+        </p:style>
+        <p:txBody>
+          <a:bodyPr rtlCol="0" anchor="ctr"/>
+          <a:lstStyle/>
+          <a:p>
+            <a:pPr algn="ctr"/>
+          </a:p>
+        </p:txBody>
+      </p:sp>
+      <p:sp>
+        <p:nvSpPr>
+          <p:cNvPr id="17" name="TextBox 16"/>
+          <p:cNvSpPr txBox="1"/>
+          <p:nvPr/>
+        </p:nvSpPr>
+        <p:spPr>
+          <a:xfrm>
+            <a:off x="822960" y="5120640"/>
+            <a:ext cx="10515600" cy="868680"/>
+          </a:xfrm>
+          <a:prstGeom prst="rect">
+            <a:avLst/>
+          </a:prstGeom>
+          <a:noFill/>
+        </p:spPr>
+        <p:txBody>
+          <a:bodyPr wrap="square" lIns="0" rIns="0" tIns="0" bIns="0">
+            <a:spAutoFit/>
+          </a:bodyPr>
+          <a:lstStyle/>
+          <a:p>
+            <a:pPr algn="l">
+              <a:lnSpc>
+                <a:spcPct val="115000"/>
+              </a:lnSpc>
+            </a:pPr>
+            <a:r>
+              <a:rPr sz="1300" b="0">
+                <a:solidFill>
+                  <a:srgbClr val="CADCFC"/>
+                </a:solidFill>
+                <a:latin typeface="Arial"/>
+              </a:rPr>
+              <a:t>Governance: hard eligibility stays in auditable BRFplus decision tables — no model can enroll, reject or override. AI ranks, explains, predicts and drafts, always labeled, always with the agent in the loop.</a:t>
             </a:r>
           </a:p>
         </p:txBody>

</xml_diff>

<commit_message>
Client deck: add 'How the AI score is calculated' slide (6-step pipeline, calibration, cold start, governance) after the AI slide
Co-Authored-By: Claude Fable 5 <noreply@anthropic.com>
</commit_message>
<xml_diff>
--- a/Enrollment Center/Enrollment Center - Client Presentation v1.0.pptx
+++ b/Enrollment Center/Enrollment Center - Client Presentation v1.0.pptx
@@ -16,6 +16,7 @@
     <p:sldId id="264" r:id="rId15"/>
     <p:sldId id="265" r:id="rId16"/>
     <p:sldId id="269" r:id="rId20"/>
+    <p:sldId id="270" r:id="rId21"/>
     <p:sldId id="266" r:id="rId17"/>
     <p:sldId id="267" r:id="rId18"/>
     <p:sldId id="268" r:id="rId19"/>
@@ -4148,7 +4149,7 @@
           <a:noFill/>
         </p:spPr>
         <p:txBody>
-          <a:bodyPr wrap="square" anchor="t" lIns="0" rIns="0" tIns="0" bIns="0">
+          <a:bodyPr wrap="square" lIns="0" rIns="0" tIns="0" bIns="0">
             <a:spAutoFit/>
           </a:bodyPr>
           <a:lstStyle/>
@@ -4161,7 +4162,7 @@
                 </a:solidFill>
                 <a:latin typeface="Arial"/>
               </a:rPr>
-              <a:t>What the business gets</a:t>
+              <a:t>AI on top of the rules</a:t>
             </a:r>
           </a:p>
         </p:txBody>
@@ -4183,7 +4184,7 @@
           <a:noFill/>
         </p:spPr>
         <p:txBody>
-          <a:bodyPr wrap="square" anchor="t" lIns="0" rIns="0" tIns="0" bIns="0">
+          <a:bodyPr wrap="square" lIns="0" rIns="0" tIns="0" bIns="0">
             <a:spAutoFit/>
           </a:bodyPr>
           <a:lstStyle/>
@@ -4196,7 +4197,7 @@
                 </a:solidFill>
                 <a:latin typeface="Arial"/>
               </a:rPr>
-              <a:t>Measured against the KPIs your call center already tracks</a:t>
+              <a:t>Machine learning recommends — the rules engine decides. Full portfolio in the AI/ML Roadmap.</a:t>
             </a:r>
           </a:p>
         </p:txBody>
@@ -4209,8 +4210,8 @@
         </p:nvSpPr>
         <p:spPr>
           <a:xfrm>
-            <a:off x="548640" y="1691640"/>
-            <a:ext cx="5440680" cy="1280160"/>
+            <a:off x="548640" y="1645920"/>
+            <a:ext cx="5440680" cy="1463040"/>
           </a:xfrm>
           <a:prstGeom prst="roundRect">
             <a:avLst>
@@ -4218,7 +4219,7 @@
             </a:avLst>
           </a:prstGeom>
           <a:solidFill>
-            <a:srgbClr val="FFFFFF"/>
+            <a:srgbClr val="F5F6F7"/>
           </a:solidFill>
           <a:ln w="9525">
             <a:solidFill>
@@ -4251,35 +4252,55 @@
       </p:sp>
       <p:sp>
         <p:nvSpPr>
-          <p:cNvPr id="5" name="TextBox 4"/>
-          <p:cNvSpPr txBox="1"/>
-          <p:nvPr/>
-        </p:nvSpPr>
-        <p:spPr>
-          <a:xfrm>
-            <a:off x="868680" y="1892808"/>
-            <a:ext cx="1737360" cy="822960"/>
-          </a:xfrm>
-          <a:prstGeom prst="rect">
-            <a:avLst/>
-          </a:prstGeom>
-          <a:noFill/>
-        </p:spPr>
-        <p:txBody>
-          <a:bodyPr wrap="square" anchor="t" lIns="0" rIns="0" tIns="0" bIns="0">
-            <a:spAutoFit/>
-          </a:bodyPr>
-          <a:lstStyle/>
-          <a:p>
-            <a:pPr algn="l"/>
-            <a:r>
-              <a:rPr sz="3600" b="1">
-                <a:solidFill>
-                  <a:srgbClr val="0070F2"/>
-                </a:solidFill>
-                <a:latin typeface="Arial"/>
-              </a:rPr>
-              <a:t>&lt; 3 s</a:t>
+          <p:cNvPr id="5" name="Rounded Rectangle 4"/>
+          <p:cNvSpPr/>
+          <p:nvPr/>
+        </p:nvSpPr>
+        <p:spPr>
+          <a:xfrm>
+            <a:off x="822959" y="1847088"/>
+            <a:ext cx="2103120" cy="310896"/>
+          </a:xfrm>
+          <a:prstGeom prst="roundRect">
+            <a:avLst>
+              <a:gd name="adj" fmla="val 50000"/>
+            </a:avLst>
+          </a:prstGeom>
+          <a:solidFill>
+            <a:srgbClr val="F0EAFD"/>
+          </a:solidFill>
+          <a:ln>
+            <a:noFill/>
+          </a:ln>
+          <a:effectLst/>
+        </p:spPr>
+        <p:style>
+          <a:lnRef idx="1">
+            <a:schemeClr val="accent1"/>
+          </a:lnRef>
+          <a:fillRef idx="3">
+            <a:schemeClr val="accent1"/>
+          </a:fillRef>
+          <a:effectRef idx="2">
+            <a:schemeClr val="accent1"/>
+          </a:effectRef>
+          <a:fontRef idx="minor">
+            <a:schemeClr val="lt1"/>
+          </a:fontRef>
+        </p:style>
+        <p:txBody>
+          <a:bodyPr rtlCol="0" anchor="ctr" lIns="18288" rIns="18288" tIns="0" bIns="0"/>
+          <a:lstStyle/>
+          <a:p>
+            <a:pPr algn="ctr"/>
+            <a:r>
+              <a:rPr sz="1150" b="1">
+                <a:solidFill>
+                  <a:srgbClr val="6C32A9"/>
+                </a:solidFill>
+                <a:latin typeface="Arial"/>
+              </a:rPr>
+              <a:t>AI-1 · Recommend</a:t>
             </a:r>
           </a:p>
         </p:txBody>
@@ -4292,8 +4313,8 @@
         </p:nvSpPr>
         <p:spPr>
           <a:xfrm>
-            <a:off x="2697480" y="1947672"/>
-            <a:ext cx="3063240" cy="914400"/>
+            <a:off x="822959" y="2267712"/>
+            <a:ext cx="4937760" cy="777240"/>
           </a:xfrm>
           <a:prstGeom prst="rect">
             <a:avLst/>
@@ -4301,14 +4322,14 @@
           <a:noFill/>
         </p:spPr>
         <p:txBody>
-          <a:bodyPr wrap="square" anchor="t" lIns="0" rIns="0" tIns="0" bIns="0">
+          <a:bodyPr wrap="square" lIns="0" rIns="0" tIns="0" bIns="0">
             <a:spAutoFit/>
           </a:bodyPr>
           <a:lstStyle/>
           <a:p>
             <a:pPr algn="l">
               <a:lnSpc>
-                <a:spcPct val="110000"/>
+                <a:spcPct val="112000"/>
               </a:lnSpc>
             </a:pPr>
             <a:r>
@@ -4318,7 +4339,7 @@
                 </a:solidFill>
                 <a:latin typeface="Arial"/>
               </a:rPr>
-              <a:t>from opening the Enrollment Center to a complete, eligibility-checked view</a:t>
+              <a:t>Next-best-program ranking with reasons — agents pitch the right program first (live in the demo)</a:t>
             </a:r>
           </a:p>
         </p:txBody>
@@ -4331,8 +4352,8 @@
         </p:nvSpPr>
         <p:spPr>
           <a:xfrm>
-            <a:off x="6172200" y="1691640"/>
-            <a:ext cx="5440680" cy="1280160"/>
+            <a:off x="6172200" y="1645920"/>
+            <a:ext cx="5440680" cy="1463040"/>
           </a:xfrm>
           <a:prstGeom prst="roundRect">
             <a:avLst>
@@ -4340,7 +4361,7 @@
             </a:avLst>
           </a:prstGeom>
           <a:solidFill>
-            <a:srgbClr val="FFFFFF"/>
+            <a:srgbClr val="F5F6F7"/>
           </a:solidFill>
           <a:ln w="9525">
             <a:solidFill>
@@ -4373,35 +4394,55 @@
       </p:sp>
       <p:sp>
         <p:nvSpPr>
-          <p:cNvPr id="8" name="TextBox 7"/>
-          <p:cNvSpPr txBox="1"/>
-          <p:nvPr/>
-        </p:nvSpPr>
-        <p:spPr>
-          <a:xfrm>
-            <a:off x="6492240" y="1892808"/>
-            <a:ext cx="1737360" cy="822960"/>
-          </a:xfrm>
-          <a:prstGeom prst="rect">
-            <a:avLst/>
-          </a:prstGeom>
-          <a:noFill/>
-        </p:spPr>
-        <p:txBody>
-          <a:bodyPr wrap="square" anchor="t" lIns="0" rIns="0" tIns="0" bIns="0">
-            <a:spAutoFit/>
-          </a:bodyPr>
-          <a:lstStyle/>
-          <a:p>
-            <a:pPr algn="l"/>
-            <a:r>
-              <a:rPr sz="3600" b="1">
-                <a:solidFill>
-                  <a:srgbClr val="0070F2"/>
-                </a:solidFill>
-                <a:latin typeface="Arial"/>
-              </a:rPr>
-              <a:t>1 call</a:t>
+          <p:cNvPr id="8" name="Rounded Rectangle 7"/>
+          <p:cNvSpPr/>
+          <p:nvPr/>
+        </p:nvSpPr>
+        <p:spPr>
+          <a:xfrm>
+            <a:off x="6446520" y="1847088"/>
+            <a:ext cx="2103120" cy="310896"/>
+          </a:xfrm>
+          <a:prstGeom prst="roundRect">
+            <a:avLst>
+              <a:gd name="adj" fmla="val 50000"/>
+            </a:avLst>
+          </a:prstGeom>
+          <a:solidFill>
+            <a:srgbClr val="E3F0FF"/>
+          </a:solidFill>
+          <a:ln>
+            <a:noFill/>
+          </a:ln>
+          <a:effectLst/>
+        </p:spPr>
+        <p:style>
+          <a:lnRef idx="1">
+            <a:schemeClr val="accent1"/>
+          </a:lnRef>
+          <a:fillRef idx="3">
+            <a:schemeClr val="accent1"/>
+          </a:fillRef>
+          <a:effectRef idx="2">
+            <a:schemeClr val="accent1"/>
+          </a:effectRef>
+          <a:fontRef idx="minor">
+            <a:schemeClr val="lt1"/>
+          </a:fontRef>
+        </p:style>
+        <p:txBody>
+          <a:bodyPr rtlCol="0" anchor="ctr" lIns="18288" rIns="18288" tIns="0" bIns="0"/>
+          <a:lstStyle/>
+          <a:p>
+            <a:pPr algn="ctr"/>
+            <a:r>
+              <a:rPr sz="1150" b="1">
+                <a:solidFill>
+                  <a:srgbClr val="0057D2"/>
+                </a:solidFill>
+                <a:latin typeface="Arial"/>
+              </a:rPr>
+              <a:t>AI-2 · Explain</a:t>
             </a:r>
           </a:p>
         </p:txBody>
@@ -4414,8 +4455,8 @@
         </p:nvSpPr>
         <p:spPr>
           <a:xfrm>
-            <a:off x="8321040" y="1947672"/>
-            <a:ext cx="3063240" cy="914400"/>
+            <a:off x="6446520" y="2267712"/>
+            <a:ext cx="4937760" cy="777240"/>
           </a:xfrm>
           <a:prstGeom prst="rect">
             <a:avLst/>
@@ -4423,14 +4464,14 @@
           <a:noFill/>
         </p:spPr>
         <p:txBody>
-          <a:bodyPr wrap="square" anchor="t" lIns="0" rIns="0" tIns="0" bIns="0">
+          <a:bodyPr wrap="square" lIns="0" rIns="0" tIns="0" bIns="0">
             <a:spAutoFit/>
           </a:bodyPr>
           <a:lstStyle/>
           <a:p>
             <a:pPr algn="l">
               <a:lnSpc>
-                <a:spcPct val="110000"/>
+                <a:spcPct val="112000"/>
               </a:lnSpc>
             </a:pPr>
             <a:r>
@@ -4440,7 +4481,7 @@
                 </a:solidFill>
                 <a:latin typeface="Arial"/>
               </a:rPr>
-              <a:t>evaluates all 28 programs across every contract account — no per-program prompts</a:t>
+              <a:t>Plain-language program explanations for THIS customer, grounded on the catalog (live in the demo)</a:t>
             </a:r>
           </a:p>
         </p:txBody>
@@ -4453,8 +4494,8 @@
         </p:nvSpPr>
         <p:spPr>
           <a:xfrm>
-            <a:off x="548640" y="3108960"/>
-            <a:ext cx="5440680" cy="1280160"/>
+            <a:off x="548640" y="3246120"/>
+            <a:ext cx="5440680" cy="1463040"/>
           </a:xfrm>
           <a:prstGeom prst="roundRect">
             <a:avLst>
@@ -4462,7 +4503,7 @@
             </a:avLst>
           </a:prstGeom>
           <a:solidFill>
-            <a:srgbClr val="FFFFFF"/>
+            <a:srgbClr val="F5F6F7"/>
           </a:solidFill>
           <a:ln w="9525">
             <a:solidFill>
@@ -4495,35 +4536,55 @@
       </p:sp>
       <p:sp>
         <p:nvSpPr>
-          <p:cNvPr id="11" name="TextBox 10"/>
-          <p:cNvSpPr txBox="1"/>
-          <p:nvPr/>
-        </p:nvSpPr>
-        <p:spPr>
-          <a:xfrm>
-            <a:off x="868680" y="3310128"/>
-            <a:ext cx="1737360" cy="822960"/>
-          </a:xfrm>
-          <a:prstGeom prst="rect">
-            <a:avLst/>
-          </a:prstGeom>
-          <a:noFill/>
-        </p:spPr>
-        <p:txBody>
-          <a:bodyPr wrap="square" anchor="t" lIns="0" rIns="0" tIns="0" bIns="0">
-            <a:spAutoFit/>
-          </a:bodyPr>
-          <a:lstStyle/>
-          <a:p>
-            <a:pPr algn="l"/>
-            <a:r>
-              <a:rPr sz="3600" b="1">
-                <a:solidFill>
-                  <a:srgbClr val="0070F2"/>
-                </a:solidFill>
-                <a:latin typeface="Arial"/>
-              </a:rPr>
-              <a:t>0</a:t>
+          <p:cNvPr id="11" name="Rounded Rectangle 10"/>
+          <p:cNvSpPr/>
+          <p:nvPr/>
+        </p:nvSpPr>
+        <p:spPr>
+          <a:xfrm>
+            <a:off x="822959" y="3447288"/>
+            <a:ext cx="2103120" cy="310896"/>
+          </a:xfrm>
+          <a:prstGeom prst="roundRect">
+            <a:avLst>
+              <a:gd name="adj" fmla="val 50000"/>
+            </a:avLst>
+          </a:prstGeom>
+          <a:solidFill>
+            <a:srgbClr val="EBF5EB"/>
+          </a:solidFill>
+          <a:ln>
+            <a:noFill/>
+          </a:ln>
+          <a:effectLst/>
+        </p:spPr>
+        <p:style>
+          <a:lnRef idx="1">
+            <a:schemeClr val="accent1"/>
+          </a:lnRef>
+          <a:fillRef idx="3">
+            <a:schemeClr val="accent1"/>
+          </a:fillRef>
+          <a:effectRef idx="2">
+            <a:schemeClr val="accent1"/>
+          </a:effectRef>
+          <a:fontRef idx="minor">
+            <a:schemeClr val="lt1"/>
+          </a:fontRef>
+        </p:style>
+        <p:txBody>
+          <a:bodyPr rtlCol="0" anchor="ctr" lIns="18288" rIns="18288" tIns="0" bIns="0"/>
+          <a:lstStyle/>
+          <a:p>
+            <a:pPr algn="ctr"/>
+            <a:r>
+              <a:rPr sz="1150" b="1">
+                <a:solidFill>
+                  <a:srgbClr val="188918"/>
+                </a:solidFill>
+                <a:latin typeface="Arial"/>
+              </a:rPr>
+              <a:t>AI-3 · Verify savings</a:t>
             </a:r>
           </a:p>
         </p:txBody>
@@ -4536,8 +4597,8 @@
         </p:nvSpPr>
         <p:spPr>
           <a:xfrm>
-            <a:off x="2697480" y="3364991"/>
-            <a:ext cx="3063240" cy="914400"/>
+            <a:off x="822959" y="3867911"/>
+            <a:ext cx="4937760" cy="777240"/>
           </a:xfrm>
           <a:prstGeom prst="rect">
             <a:avLst/>
@@ -4545,14 +4606,14 @@
           <a:noFill/>
         </p:spPr>
         <p:txBody>
-          <a:bodyPr wrap="square" anchor="t" lIns="0" rIns="0" tIns="0" bIns="0">
+          <a:bodyPr wrap="square" lIns="0" rIns="0" tIns="0" bIns="0">
             <a:spAutoFit/>
           </a:bodyPr>
           <a:lstStyle/>
           <a:p>
             <a:pPr algn="l">
               <a:lnSpc>
-                <a:spcPct val="110000"/>
+                <a:spcPct val="112000"/>
               </a:lnSpc>
             </a:pPr>
             <a:r>
@@ -4562,7 +4623,7 @@
                 </a:solidFill>
                 <a:latin typeface="Arial"/>
               </a:rPr>
-              <a:t>modifications to the S/4HANA core — clean, upgrade-safe extension</a:t>
+              <a:t>Bill-impact simulation on interval data before rate enrollment — recommend only when it saves</a:t>
             </a:r>
           </a:p>
         </p:txBody>
@@ -4575,8 +4636,8 @@
         </p:nvSpPr>
         <p:spPr>
           <a:xfrm>
-            <a:off x="6172200" y="3108960"/>
-            <a:ext cx="5440680" cy="1280160"/>
+            <a:off x="6172200" y="3246120"/>
+            <a:ext cx="5440680" cy="1463040"/>
           </a:xfrm>
           <a:prstGeom prst="roundRect">
             <a:avLst>
@@ -4584,7 +4645,7 @@
             </a:avLst>
           </a:prstGeom>
           <a:solidFill>
-            <a:srgbClr val="FFFFFF"/>
+            <a:srgbClr val="F5F6F7"/>
           </a:solidFill>
           <a:ln w="9525">
             <a:solidFill>
@@ -4617,35 +4678,55 @@
       </p:sp>
       <p:sp>
         <p:nvSpPr>
-          <p:cNvPr id="14" name="TextBox 13"/>
-          <p:cNvSpPr txBox="1"/>
-          <p:nvPr/>
-        </p:nvSpPr>
-        <p:spPr>
-          <a:xfrm>
-            <a:off x="6492240" y="3310128"/>
-            <a:ext cx="1737360" cy="822960"/>
-          </a:xfrm>
-          <a:prstGeom prst="rect">
-            <a:avLst/>
-          </a:prstGeom>
-          <a:noFill/>
-        </p:spPr>
-        <p:txBody>
-          <a:bodyPr wrap="square" anchor="t" lIns="0" rIns="0" tIns="0" bIns="0">
-            <a:spAutoFit/>
-          </a:bodyPr>
-          <a:lstStyle/>
-          <a:p>
-            <a:pPr algn="l"/>
-            <a:r>
-              <a:rPr sz="3600" b="1">
-                <a:solidFill>
-                  <a:srgbClr val="0070F2"/>
-                </a:solidFill>
-                <a:latin typeface="Arial"/>
-              </a:rPr>
-              <a:t>100 %</a:t>
+          <p:cNvPr id="14" name="Rounded Rectangle 13"/>
+          <p:cNvSpPr/>
+          <p:nvPr/>
+        </p:nvSpPr>
+        <p:spPr>
+          <a:xfrm>
+            <a:off x="6446520" y="3447288"/>
+            <a:ext cx="2103120" cy="310896"/>
+          </a:xfrm>
+          <a:prstGeom prst="roundRect">
+            <a:avLst>
+              <a:gd name="adj" fmla="val 50000"/>
+            </a:avLst>
+          </a:prstGeom>
+          <a:solidFill>
+            <a:srgbClr val="FFB300"/>
+          </a:solidFill>
+          <a:ln>
+            <a:noFill/>
+          </a:ln>
+          <a:effectLst/>
+        </p:spPr>
+        <p:style>
+          <a:lnRef idx="1">
+            <a:schemeClr val="accent1"/>
+          </a:lnRef>
+          <a:fillRef idx="3">
+            <a:schemeClr val="accent1"/>
+          </a:fillRef>
+          <a:effectRef idx="2">
+            <a:schemeClr val="accent1"/>
+          </a:effectRef>
+          <a:fontRef idx="minor">
+            <a:schemeClr val="lt1"/>
+          </a:fontRef>
+        </p:style>
+        <p:txBody>
+          <a:bodyPr rtlCol="0" anchor="ctr" lIns="18288" rIns="18288" tIns="0" bIns="0"/>
+          <a:lstStyle/>
+          <a:p>
+            <a:pPr algn="ctr"/>
+            <a:r>
+              <a:rPr sz="1150" b="1">
+                <a:solidFill>
+                  <a:srgbClr val="3B2A00"/>
+                </a:solidFill>
+                <a:latin typeface="Arial"/>
+              </a:rPr>
+              <a:t>AI-4 · Protect</a:t>
             </a:r>
           </a:p>
         </p:txBody>
@@ -4658,8 +4739,8 @@
         </p:nvSpPr>
         <p:spPr>
           <a:xfrm>
-            <a:off x="8321040" y="3364991"/>
-            <a:ext cx="3063240" cy="914400"/>
+            <a:off x="6446520" y="3867911"/>
+            <a:ext cx="4937760" cy="777240"/>
           </a:xfrm>
           <a:prstGeom prst="rect">
             <a:avLst/>
@@ -4667,14 +4748,14 @@
           <a:noFill/>
         </p:spPr>
         <p:txBody>
-          <a:bodyPr wrap="square" anchor="t" lIns="0" rIns="0" tIns="0" bIns="0">
+          <a:bodyPr wrap="square" lIns="0" rIns="0" tIns="0" bIns="0">
             <a:spAutoFit/>
           </a:bodyPr>
           <a:lstStyle/>
           <a:p>
             <a:pPr algn="l">
               <a:lnSpc>
-                <a:spcPct val="110000"/>
+                <a:spcPct val="112000"/>
               </a:lnSpc>
             </a:pPr>
             <a:r>
@@ -4684,7 +4765,7 @@
                 </a:solidFill>
                 <a:latin typeface="Arial"/>
               </a:rPr>
-              <a:t>of enrollments audited with eligibility basis, consent and actor</a:t>
+              <a:t>Payment-plan default prediction, document intelligence for assistance programs, exception triage</a:t>
             </a:r>
           </a:p>
         </p:txBody>
@@ -4697,8 +4778,8 @@
         </p:nvSpPr>
         <p:spPr>
           <a:xfrm>
-            <a:off x="548640" y="4617720"/>
-            <a:ext cx="11064240" cy="1554480"/>
+            <a:off x="548640" y="4937760"/>
+            <a:ext cx="11064240" cy="1234440"/>
           </a:xfrm>
           <a:prstGeom prst="roundRect">
             <a:avLst>
@@ -4745,8 +4826,8 @@
         </p:nvSpPr>
         <p:spPr>
           <a:xfrm>
-            <a:off x="822960" y="4828032"/>
-            <a:ext cx="10515600" cy="365760"/>
+            <a:off x="822960" y="5120640"/>
+            <a:ext cx="10515600" cy="868680"/>
           </a:xfrm>
           <a:prstGeom prst="rect">
             <a:avLst/>
@@ -4754,42 +4835,7 @@
           <a:noFill/>
         </p:spPr>
         <p:txBody>
-          <a:bodyPr wrap="square" anchor="t" lIns="0" rIns="0" tIns="0" bIns="0">
-            <a:spAutoFit/>
-          </a:bodyPr>
-          <a:lstStyle/>
-          <a:p>
-            <a:pPr algn="l"/>
-            <a:r>
-              <a:rPr sz="1400" b="1">
-                <a:solidFill>
-                  <a:srgbClr val="FFB300"/>
-                </a:solidFill>
-                <a:latin typeface="Arial"/>
-              </a:rPr>
-              <a:t>And the strategic payoff</a:t>
-            </a:r>
-          </a:p>
-        </p:txBody>
-      </p:sp>
-      <p:sp>
-        <p:nvSpPr>
-          <p:cNvPr id="18" name="TextBox 17"/>
-          <p:cNvSpPr txBox="1"/>
-          <p:nvPr/>
-        </p:nvSpPr>
-        <p:spPr>
-          <a:xfrm>
-            <a:off x="822960" y="5257800"/>
-            <a:ext cx="10515600" cy="822960"/>
-          </a:xfrm>
-          <a:prstGeom prst="rect">
-            <a:avLst/>
-          </a:prstGeom>
-          <a:noFill/>
-        </p:spPr>
-        <p:txBody>
-          <a:bodyPr wrap="square" anchor="t" lIns="0" rIns="0" tIns="0" bIns="0">
+          <a:bodyPr wrap="square" lIns="0" rIns="0" tIns="0" bIns="0">
             <a:spAutoFit/>
           </a:bodyPr>
           <a:lstStyle/>
@@ -4806,7 +4852,7 @@
                 </a:solidFill>
                 <a:latin typeface="Arial"/>
               </a:rPr>
-              <a:t>The same eligibility and enrollment services power your next channels — customer self-service, IVR, and the DER platform — without rebuilding. Agents launch it first; the architecture already serves all of them.</a:t>
+              <a:t>Governance: hard eligibility stays in auditable BRFplus decision tables — no model can enroll, reject or override. AI ranks, explains, predicts and drafts, always labeled, always with the agent in the loop.</a:t>
             </a:r>
           </a:p>
         </p:txBody>
@@ -4867,7 +4913,7 @@
                 </a:solidFill>
                 <a:latin typeface="Arial"/>
               </a:rPr>
-              <a:t>Delivery roadmap</a:t>
+              <a:t>What the business gets</a:t>
             </a:r>
           </a:p>
         </p:txBody>
@@ -4902,7 +4948,7 @@
                 </a:solidFill>
                 <a:latin typeface="Arial"/>
               </a:rPr>
-              <a:t>Design is complete and reviewed — build starts with a two-week proof</a:t>
+              <a:t>Measured against the KPIs your call center already tracks</a:t>
             </a:r>
           </a:p>
         </p:txBody>
@@ -4915,8 +4961,8 @@
         </p:nvSpPr>
         <p:spPr>
           <a:xfrm>
-            <a:off x="548640" y="1783080"/>
-            <a:ext cx="3611880" cy="2286000"/>
+            <a:off x="548640" y="1691640"/>
+            <a:ext cx="5440680" cy="1280160"/>
           </a:xfrm>
           <a:prstGeom prst="roundRect">
             <a:avLst>
@@ -4957,55 +5003,35 @@
       </p:sp>
       <p:sp>
         <p:nvSpPr>
-          <p:cNvPr id="5" name="Rounded Rectangle 4"/>
-          <p:cNvSpPr/>
-          <p:nvPr/>
-        </p:nvSpPr>
-        <p:spPr>
-          <a:xfrm>
-            <a:off x="777240" y="2011680"/>
-            <a:ext cx="1737360" cy="329184"/>
-          </a:xfrm>
-          <a:prstGeom prst="roundRect">
-            <a:avLst>
-              <a:gd name="adj" fmla="val 50000"/>
-            </a:avLst>
-          </a:prstGeom>
-          <a:solidFill>
-            <a:srgbClr val="F5F6F7"/>
-          </a:solidFill>
-          <a:ln>
-            <a:noFill/>
-          </a:ln>
-          <a:effectLst/>
-        </p:spPr>
-        <p:style>
-          <a:lnRef idx="1">
-            <a:schemeClr val="accent1"/>
-          </a:lnRef>
-          <a:fillRef idx="3">
-            <a:schemeClr val="accent1"/>
-          </a:fillRef>
-          <a:effectRef idx="2">
-            <a:schemeClr val="accent1"/>
-          </a:effectRef>
-          <a:fontRef idx="minor">
-            <a:schemeClr val="lt1"/>
-          </a:fontRef>
-        </p:style>
-        <p:txBody>
-          <a:bodyPr rtlCol="0" anchor="ctr" wrap="none" lIns="18288" rIns="18288" tIns="0" bIns="0"/>
-          <a:lstStyle/>
-          <a:p>
-            <a:pPr algn="ctr"/>
-            <a:r>
-              <a:rPr sz="1200" b="1">
-                <a:solidFill>
-                  <a:srgbClr val="556B82"/>
-                </a:solidFill>
-                <a:latin typeface="Arial"/>
-              </a:rPr>
-              <a:t>Spike — 2 weeks</a:t>
+          <p:cNvPr id="5" name="TextBox 4"/>
+          <p:cNvSpPr txBox="1"/>
+          <p:nvPr/>
+        </p:nvSpPr>
+        <p:spPr>
+          <a:xfrm>
+            <a:off x="868680" y="1892808"/>
+            <a:ext cx="1737360" cy="822960"/>
+          </a:xfrm>
+          <a:prstGeom prst="rect">
+            <a:avLst/>
+          </a:prstGeom>
+          <a:noFill/>
+        </p:spPr>
+        <p:txBody>
+          <a:bodyPr wrap="square" anchor="t" lIns="0" rIns="0" tIns="0" bIns="0">
+            <a:spAutoFit/>
+          </a:bodyPr>
+          <a:lstStyle/>
+          <a:p>
+            <a:pPr algn="l"/>
+            <a:r>
+              <a:rPr sz="3600" b="1">
+                <a:solidFill>
+                  <a:srgbClr val="0070F2"/>
+                </a:solidFill>
+                <a:latin typeface="Arial"/>
+              </a:rPr>
+              <a:t>&lt; 3 s</a:t>
             </a:r>
           </a:p>
         </p:txBody>
@@ -5018,8 +5044,8 @@
         </p:nvSpPr>
         <p:spPr>
           <a:xfrm>
-            <a:off x="777240" y="2514600"/>
-            <a:ext cx="3154680" cy="1188720"/>
+            <a:off x="2697480" y="1947672"/>
+            <a:ext cx="3063240" cy="914400"/>
           </a:xfrm>
           <a:prstGeom prst="rect">
             <a:avLst/>
@@ -5034,110 +5060,31 @@
           <a:p>
             <a:pPr algn="l">
               <a:lnSpc>
-                <a:spcPct val="115000"/>
+                <a:spcPct val="110000"/>
               </a:lnSpc>
             </a:pPr>
             <a:r>
-              <a:rPr sz="1150" b="0">
+              <a:rPr sz="1200" b="0">
                 <a:solidFill>
                   <a:srgbClr val="556B82"/>
                 </a:solidFill>
                 <a:latin typeface="Arial"/>
               </a:rPr>
-              <a:t>Prove SC V2 embedding (both access points) and principal propagation to S/4HANA</a:t>
-            </a:r>
-          </a:p>
-        </p:txBody>
-      </p:sp>
-      <p:sp>
-        <p:nvSpPr>
-          <p:cNvPr id="7" name="TextBox 6"/>
-          <p:cNvSpPr txBox="1"/>
-          <p:nvPr/>
-        </p:nvSpPr>
-        <p:spPr>
-          <a:xfrm>
-            <a:off x="777240" y="3657600"/>
-            <a:ext cx="3108960" cy="320040"/>
-          </a:xfrm>
-          <a:prstGeom prst="rect">
-            <a:avLst/>
-          </a:prstGeom>
-          <a:noFill/>
-        </p:spPr>
-        <p:txBody>
-          <a:bodyPr wrap="square" anchor="t" lIns="0" rIns="0" tIns="0" bIns="0">
-            <a:spAutoFit/>
-          </a:bodyPr>
-          <a:lstStyle/>
-          <a:p>
-            <a:pPr algn="l"/>
-            <a:r>
-              <a:rPr sz="1200" b="1">
-                <a:solidFill>
-                  <a:srgbClr val="1D2D3E"/>
-                </a:solidFill>
-                <a:latin typeface="Arial"/>
-              </a:rPr>
-              <a:t>Now</a:t>
-            </a:r>
-          </a:p>
-        </p:txBody>
-      </p:sp>
-      <p:sp>
-        <p:nvSpPr>
-          <p:cNvPr id="8" name="Right Arrow 7"/>
+              <a:t>from opening the Enrollment Center to a complete, eligibility-checked view</a:t>
+            </a:r>
+          </a:p>
+        </p:txBody>
+      </p:sp>
+      <p:sp>
+        <p:nvSpPr>
+          <p:cNvPr id="7" name="Rounded Rectangle 6"/>
           <p:cNvSpPr/>
           <p:nvPr/>
         </p:nvSpPr>
         <p:spPr>
           <a:xfrm>
-            <a:off x="4178808" y="2788920"/>
-            <a:ext cx="237744" cy="201168"/>
-          </a:xfrm>
-          <a:prstGeom prst="rightArrow">
-            <a:avLst/>
-          </a:prstGeom>
-          <a:solidFill>
-            <a:srgbClr val="556B82"/>
-          </a:solidFill>
-          <a:ln>
-            <a:noFill/>
-          </a:ln>
-          <a:effectLst/>
-        </p:spPr>
-        <p:style>
-          <a:lnRef idx="1">
-            <a:schemeClr val="accent1"/>
-          </a:lnRef>
-          <a:fillRef idx="3">
-            <a:schemeClr val="accent1"/>
-          </a:fillRef>
-          <a:effectRef idx="2">
-            <a:schemeClr val="accent1"/>
-          </a:effectRef>
-          <a:fontRef idx="minor">
-            <a:schemeClr val="lt1"/>
-          </a:fontRef>
-        </p:style>
-        <p:txBody>
-          <a:bodyPr rtlCol="0" anchor="ctr"/>
-          <a:lstStyle/>
-          <a:p>
-            <a:pPr algn="ctr"/>
-          </a:p>
-        </p:txBody>
-      </p:sp>
-      <p:sp>
-        <p:nvSpPr>
-          <p:cNvPr id="9" name="Rounded Rectangle 8"/>
-          <p:cNvSpPr/>
-          <p:nvPr/>
-        </p:nvSpPr>
-        <p:spPr>
-          <a:xfrm>
-            <a:off x="4379976" y="1783080"/>
-            <a:ext cx="3611880" cy="2286000"/>
+            <a:off x="6172200" y="1691640"/>
+            <a:ext cx="5440680" cy="1280160"/>
           </a:xfrm>
           <a:prstGeom prst="roundRect">
             <a:avLst>
@@ -5178,187 +5125,88 @@
       </p:sp>
       <p:sp>
         <p:nvSpPr>
+          <p:cNvPr id="8" name="TextBox 7"/>
+          <p:cNvSpPr txBox="1"/>
+          <p:nvPr/>
+        </p:nvSpPr>
+        <p:spPr>
+          <a:xfrm>
+            <a:off x="6492240" y="1892808"/>
+            <a:ext cx="1737360" cy="822960"/>
+          </a:xfrm>
+          <a:prstGeom prst="rect">
+            <a:avLst/>
+          </a:prstGeom>
+          <a:noFill/>
+        </p:spPr>
+        <p:txBody>
+          <a:bodyPr wrap="square" anchor="t" lIns="0" rIns="0" tIns="0" bIns="0">
+            <a:spAutoFit/>
+          </a:bodyPr>
+          <a:lstStyle/>
+          <a:p>
+            <a:pPr algn="l"/>
+            <a:r>
+              <a:rPr sz="3600" b="1">
+                <a:solidFill>
+                  <a:srgbClr val="0070F2"/>
+                </a:solidFill>
+                <a:latin typeface="Arial"/>
+              </a:rPr>
+              <a:t>1 call</a:t>
+            </a:r>
+          </a:p>
+        </p:txBody>
+      </p:sp>
+      <p:sp>
+        <p:nvSpPr>
+          <p:cNvPr id="9" name="TextBox 8"/>
+          <p:cNvSpPr txBox="1"/>
+          <p:nvPr/>
+        </p:nvSpPr>
+        <p:spPr>
+          <a:xfrm>
+            <a:off x="8321040" y="1947672"/>
+            <a:ext cx="3063240" cy="914400"/>
+          </a:xfrm>
+          <a:prstGeom prst="rect">
+            <a:avLst/>
+          </a:prstGeom>
+          <a:noFill/>
+        </p:spPr>
+        <p:txBody>
+          <a:bodyPr wrap="square" anchor="t" lIns="0" rIns="0" tIns="0" bIns="0">
+            <a:spAutoFit/>
+          </a:bodyPr>
+          <a:lstStyle/>
+          <a:p>
+            <a:pPr algn="l">
+              <a:lnSpc>
+                <a:spcPct val="110000"/>
+              </a:lnSpc>
+            </a:pPr>
+            <a:r>
+              <a:rPr sz="1200" b="0">
+                <a:solidFill>
+                  <a:srgbClr val="556B82"/>
+                </a:solidFill>
+                <a:latin typeface="Arial"/>
+              </a:rPr>
+              <a:t>evaluates all 28 programs across every contract account — no per-program prompts</a:t>
+            </a:r>
+          </a:p>
+        </p:txBody>
+      </p:sp>
+      <p:sp>
+        <p:nvSpPr>
           <p:cNvPr id="10" name="Rounded Rectangle 9"/>
           <p:cNvSpPr/>
           <p:nvPr/>
         </p:nvSpPr>
         <p:spPr>
           <a:xfrm>
-            <a:off x="4608576" y="2011680"/>
-            <a:ext cx="1737360" cy="329184"/>
-          </a:xfrm>
-          <a:prstGeom prst="roundRect">
-            <a:avLst>
-              <a:gd name="adj" fmla="val 50000"/>
-            </a:avLst>
-          </a:prstGeom>
-          <a:solidFill>
-            <a:srgbClr val="E3F0FF"/>
-          </a:solidFill>
-          <a:ln>
-            <a:noFill/>
-          </a:ln>
-          <a:effectLst/>
-        </p:spPr>
-        <p:style>
-          <a:lnRef idx="1">
-            <a:schemeClr val="accent1"/>
-          </a:lnRef>
-          <a:fillRef idx="3">
-            <a:schemeClr val="accent1"/>
-          </a:fillRef>
-          <a:effectRef idx="2">
-            <a:schemeClr val="accent1"/>
-          </a:effectRef>
-          <a:fontRef idx="minor">
-            <a:schemeClr val="lt1"/>
-          </a:fontRef>
-        </p:style>
-        <p:txBody>
-          <a:bodyPr rtlCol="0" anchor="ctr" wrap="none" lIns="18288" rIns="18288" tIns="0" bIns="0"/>
-          <a:lstStyle/>
-          <a:p>
-            <a:pPr algn="ctr"/>
-            <a:r>
-              <a:rPr sz="1200" b="1">
-                <a:solidFill>
-                  <a:srgbClr val="0057D2"/>
-                </a:solidFill>
-                <a:latin typeface="Arial"/>
-              </a:rPr>
-              <a:t>Increment 1</a:t>
-            </a:r>
-          </a:p>
-        </p:txBody>
-      </p:sp>
-      <p:sp>
-        <p:nvSpPr>
-          <p:cNvPr id="11" name="TextBox 10"/>
-          <p:cNvSpPr txBox="1"/>
-          <p:nvPr/>
-        </p:nvSpPr>
-        <p:spPr>
-          <a:xfrm>
-            <a:off x="4608576" y="2514600"/>
-            <a:ext cx="3154680" cy="1188720"/>
-          </a:xfrm>
-          <a:prstGeom prst="rect">
-            <a:avLst/>
-          </a:prstGeom>
-          <a:noFill/>
-        </p:spPr>
-        <p:txBody>
-          <a:bodyPr wrap="square" anchor="t" lIns="0" rIns="0" tIns="0" bIns="0">
-            <a:spAutoFit/>
-          </a:bodyPr>
-          <a:lstStyle/>
-          <a:p>
-            <a:pPr algn="l">
-              <a:lnSpc>
-                <a:spcPct val="115000"/>
-              </a:lnSpc>
-            </a:pPr>
-            <a:r>
-              <a:rPr sz="1150" b="0">
-                <a:solidFill>
-                  <a:srgbClr val="556B82"/>
-                </a:solidFill>
-                <a:latin typeface="Arial"/>
-              </a:rPr>
-              <a:t>Enrollment Center shell · context &amp; eligibility · first program end-to-end (CSDD) · SC V2 timeline</a:t>
-            </a:r>
-          </a:p>
-        </p:txBody>
-      </p:sp>
-      <p:sp>
-        <p:nvSpPr>
-          <p:cNvPr id="12" name="TextBox 11"/>
-          <p:cNvSpPr txBox="1"/>
-          <p:nvPr/>
-        </p:nvSpPr>
-        <p:spPr>
-          <a:xfrm>
-            <a:off x="4608576" y="3657600"/>
-            <a:ext cx="3108960" cy="320040"/>
-          </a:xfrm>
-          <a:prstGeom prst="rect">
-            <a:avLst/>
-          </a:prstGeom>
-          <a:noFill/>
-        </p:spPr>
-        <p:txBody>
-          <a:bodyPr wrap="square" anchor="t" lIns="0" rIns="0" tIns="0" bIns="0">
-            <a:spAutoFit/>
-          </a:bodyPr>
-          <a:lstStyle/>
-          <a:p>
-            <a:pPr algn="l"/>
-            <a:r>
-              <a:rPr sz="1200" b="1">
-                <a:solidFill>
-                  <a:srgbClr val="1D2D3E"/>
-                </a:solidFill>
-                <a:latin typeface="Arial"/>
-              </a:rPr>
-              <a:t>Wks 3–10</a:t>
-            </a:r>
-          </a:p>
-        </p:txBody>
-      </p:sp>
-      <p:sp>
-        <p:nvSpPr>
-          <p:cNvPr id="13" name="Right Arrow 12"/>
-          <p:cNvSpPr/>
-          <p:nvPr/>
-        </p:nvSpPr>
-        <p:spPr>
-          <a:xfrm>
-            <a:off x="8010144" y="2788920"/>
-            <a:ext cx="237744" cy="201168"/>
-          </a:xfrm>
-          <a:prstGeom prst="rightArrow">
-            <a:avLst/>
-          </a:prstGeom>
-          <a:solidFill>
-            <a:srgbClr val="556B82"/>
-          </a:solidFill>
-          <a:ln>
-            <a:noFill/>
-          </a:ln>
-          <a:effectLst/>
-        </p:spPr>
-        <p:style>
-          <a:lnRef idx="1">
-            <a:schemeClr val="accent1"/>
-          </a:lnRef>
-          <a:fillRef idx="3">
-            <a:schemeClr val="accent1"/>
-          </a:fillRef>
-          <a:effectRef idx="2">
-            <a:schemeClr val="accent1"/>
-          </a:effectRef>
-          <a:fontRef idx="minor">
-            <a:schemeClr val="lt1"/>
-          </a:fontRef>
-        </p:style>
-        <p:txBody>
-          <a:bodyPr rtlCol="0" anchor="ctr"/>
-          <a:lstStyle/>
-          <a:p>
-            <a:pPr algn="ctr"/>
-          </a:p>
-        </p:txBody>
-      </p:sp>
-      <p:sp>
-        <p:nvSpPr>
-          <p:cNvPr id="14" name="Rounded Rectangle 13"/>
-          <p:cNvSpPr/>
-          <p:nvPr/>
-        </p:nvSpPr>
-        <p:spPr>
-          <a:xfrm>
-            <a:off x="8211312" y="1783080"/>
-            <a:ext cx="3611880" cy="2286000"/>
+            <a:off x="548640" y="3108960"/>
+            <a:ext cx="5440680" cy="1280160"/>
           </a:xfrm>
           <a:prstGeom prst="roundRect">
             <a:avLst>
@@ -5399,6 +5247,910 @@
       </p:sp>
       <p:sp>
         <p:nvSpPr>
+          <p:cNvPr id="11" name="TextBox 10"/>
+          <p:cNvSpPr txBox="1"/>
+          <p:nvPr/>
+        </p:nvSpPr>
+        <p:spPr>
+          <a:xfrm>
+            <a:off x="868680" y="3310128"/>
+            <a:ext cx="1737360" cy="822960"/>
+          </a:xfrm>
+          <a:prstGeom prst="rect">
+            <a:avLst/>
+          </a:prstGeom>
+          <a:noFill/>
+        </p:spPr>
+        <p:txBody>
+          <a:bodyPr wrap="square" anchor="t" lIns="0" rIns="0" tIns="0" bIns="0">
+            <a:spAutoFit/>
+          </a:bodyPr>
+          <a:lstStyle/>
+          <a:p>
+            <a:pPr algn="l"/>
+            <a:r>
+              <a:rPr sz="3600" b="1">
+                <a:solidFill>
+                  <a:srgbClr val="0070F2"/>
+                </a:solidFill>
+                <a:latin typeface="Arial"/>
+              </a:rPr>
+              <a:t>0</a:t>
+            </a:r>
+          </a:p>
+        </p:txBody>
+      </p:sp>
+      <p:sp>
+        <p:nvSpPr>
+          <p:cNvPr id="12" name="TextBox 11"/>
+          <p:cNvSpPr txBox="1"/>
+          <p:nvPr/>
+        </p:nvSpPr>
+        <p:spPr>
+          <a:xfrm>
+            <a:off x="2697480" y="3364991"/>
+            <a:ext cx="3063240" cy="914400"/>
+          </a:xfrm>
+          <a:prstGeom prst="rect">
+            <a:avLst/>
+          </a:prstGeom>
+          <a:noFill/>
+        </p:spPr>
+        <p:txBody>
+          <a:bodyPr wrap="square" anchor="t" lIns="0" rIns="0" tIns="0" bIns="0">
+            <a:spAutoFit/>
+          </a:bodyPr>
+          <a:lstStyle/>
+          <a:p>
+            <a:pPr algn="l">
+              <a:lnSpc>
+                <a:spcPct val="110000"/>
+              </a:lnSpc>
+            </a:pPr>
+            <a:r>
+              <a:rPr sz="1200" b="0">
+                <a:solidFill>
+                  <a:srgbClr val="556B82"/>
+                </a:solidFill>
+                <a:latin typeface="Arial"/>
+              </a:rPr>
+              <a:t>modifications to the S/4HANA core — clean, upgrade-safe extension</a:t>
+            </a:r>
+          </a:p>
+        </p:txBody>
+      </p:sp>
+      <p:sp>
+        <p:nvSpPr>
+          <p:cNvPr id="13" name="Rounded Rectangle 12"/>
+          <p:cNvSpPr/>
+          <p:nvPr/>
+        </p:nvSpPr>
+        <p:spPr>
+          <a:xfrm>
+            <a:off x="6172200" y="3108960"/>
+            <a:ext cx="5440680" cy="1280160"/>
+          </a:xfrm>
+          <a:prstGeom prst="roundRect">
+            <a:avLst>
+              <a:gd name="adj" fmla="val 8000"/>
+            </a:avLst>
+          </a:prstGeom>
+          <a:solidFill>
+            <a:srgbClr val="FFFFFF"/>
+          </a:solidFill>
+          <a:ln w="9525">
+            <a:solidFill>
+              <a:srgbClr val="D9D9D9"/>
+            </a:solidFill>
+          </a:ln>
+          <a:effectLst/>
+        </p:spPr>
+        <p:style>
+          <a:lnRef idx="1">
+            <a:schemeClr val="accent1"/>
+          </a:lnRef>
+          <a:fillRef idx="3">
+            <a:schemeClr val="accent1"/>
+          </a:fillRef>
+          <a:effectRef idx="2">
+            <a:schemeClr val="accent1"/>
+          </a:effectRef>
+          <a:fontRef idx="minor">
+            <a:schemeClr val="lt1"/>
+          </a:fontRef>
+        </p:style>
+        <p:txBody>
+          <a:bodyPr rtlCol="0" anchor="ctr"/>
+          <a:lstStyle/>
+          <a:p>
+            <a:pPr algn="ctr"/>
+          </a:p>
+        </p:txBody>
+      </p:sp>
+      <p:sp>
+        <p:nvSpPr>
+          <p:cNvPr id="14" name="TextBox 13"/>
+          <p:cNvSpPr txBox="1"/>
+          <p:nvPr/>
+        </p:nvSpPr>
+        <p:spPr>
+          <a:xfrm>
+            <a:off x="6492240" y="3310128"/>
+            <a:ext cx="1737360" cy="822960"/>
+          </a:xfrm>
+          <a:prstGeom prst="rect">
+            <a:avLst/>
+          </a:prstGeom>
+          <a:noFill/>
+        </p:spPr>
+        <p:txBody>
+          <a:bodyPr wrap="square" anchor="t" lIns="0" rIns="0" tIns="0" bIns="0">
+            <a:spAutoFit/>
+          </a:bodyPr>
+          <a:lstStyle/>
+          <a:p>
+            <a:pPr algn="l"/>
+            <a:r>
+              <a:rPr sz="3600" b="1">
+                <a:solidFill>
+                  <a:srgbClr val="0070F2"/>
+                </a:solidFill>
+                <a:latin typeface="Arial"/>
+              </a:rPr>
+              <a:t>100 %</a:t>
+            </a:r>
+          </a:p>
+        </p:txBody>
+      </p:sp>
+      <p:sp>
+        <p:nvSpPr>
+          <p:cNvPr id="15" name="TextBox 14"/>
+          <p:cNvSpPr txBox="1"/>
+          <p:nvPr/>
+        </p:nvSpPr>
+        <p:spPr>
+          <a:xfrm>
+            <a:off x="8321040" y="3364991"/>
+            <a:ext cx="3063240" cy="914400"/>
+          </a:xfrm>
+          <a:prstGeom prst="rect">
+            <a:avLst/>
+          </a:prstGeom>
+          <a:noFill/>
+        </p:spPr>
+        <p:txBody>
+          <a:bodyPr wrap="square" anchor="t" lIns="0" rIns="0" tIns="0" bIns="0">
+            <a:spAutoFit/>
+          </a:bodyPr>
+          <a:lstStyle/>
+          <a:p>
+            <a:pPr algn="l">
+              <a:lnSpc>
+                <a:spcPct val="110000"/>
+              </a:lnSpc>
+            </a:pPr>
+            <a:r>
+              <a:rPr sz="1200" b="0">
+                <a:solidFill>
+                  <a:srgbClr val="556B82"/>
+                </a:solidFill>
+                <a:latin typeface="Arial"/>
+              </a:rPr>
+              <a:t>of enrollments audited with eligibility basis, consent and actor</a:t>
+            </a:r>
+          </a:p>
+        </p:txBody>
+      </p:sp>
+      <p:sp>
+        <p:nvSpPr>
+          <p:cNvPr id="16" name="Rounded Rectangle 15"/>
+          <p:cNvSpPr/>
+          <p:nvPr/>
+        </p:nvSpPr>
+        <p:spPr>
+          <a:xfrm>
+            <a:off x="548640" y="4617720"/>
+            <a:ext cx="11064240" cy="1554480"/>
+          </a:xfrm>
+          <a:prstGeom prst="roundRect">
+            <a:avLst>
+              <a:gd name="adj" fmla="val 8000"/>
+            </a:avLst>
+          </a:prstGeom>
+          <a:solidFill>
+            <a:srgbClr val="12233F"/>
+          </a:solidFill>
+          <a:ln w="9525">
+            <a:solidFill>
+              <a:srgbClr val="12233F"/>
+            </a:solidFill>
+          </a:ln>
+          <a:effectLst/>
+        </p:spPr>
+        <p:style>
+          <a:lnRef idx="1">
+            <a:schemeClr val="accent1"/>
+          </a:lnRef>
+          <a:fillRef idx="3">
+            <a:schemeClr val="accent1"/>
+          </a:fillRef>
+          <a:effectRef idx="2">
+            <a:schemeClr val="accent1"/>
+          </a:effectRef>
+          <a:fontRef idx="minor">
+            <a:schemeClr val="lt1"/>
+          </a:fontRef>
+        </p:style>
+        <p:txBody>
+          <a:bodyPr rtlCol="0" anchor="ctr"/>
+          <a:lstStyle/>
+          <a:p>
+            <a:pPr algn="ctr"/>
+          </a:p>
+        </p:txBody>
+      </p:sp>
+      <p:sp>
+        <p:nvSpPr>
+          <p:cNvPr id="17" name="TextBox 16"/>
+          <p:cNvSpPr txBox="1"/>
+          <p:nvPr/>
+        </p:nvSpPr>
+        <p:spPr>
+          <a:xfrm>
+            <a:off x="822960" y="4828032"/>
+            <a:ext cx="10515600" cy="365760"/>
+          </a:xfrm>
+          <a:prstGeom prst="rect">
+            <a:avLst/>
+          </a:prstGeom>
+          <a:noFill/>
+        </p:spPr>
+        <p:txBody>
+          <a:bodyPr wrap="square" anchor="t" lIns="0" rIns="0" tIns="0" bIns="0">
+            <a:spAutoFit/>
+          </a:bodyPr>
+          <a:lstStyle/>
+          <a:p>
+            <a:pPr algn="l"/>
+            <a:r>
+              <a:rPr sz="1400" b="1">
+                <a:solidFill>
+                  <a:srgbClr val="FFB300"/>
+                </a:solidFill>
+                <a:latin typeface="Arial"/>
+              </a:rPr>
+              <a:t>And the strategic payoff</a:t>
+            </a:r>
+          </a:p>
+        </p:txBody>
+      </p:sp>
+      <p:sp>
+        <p:nvSpPr>
+          <p:cNvPr id="18" name="TextBox 17"/>
+          <p:cNvSpPr txBox="1"/>
+          <p:nvPr/>
+        </p:nvSpPr>
+        <p:spPr>
+          <a:xfrm>
+            <a:off x="822960" y="5257800"/>
+            <a:ext cx="10515600" cy="822960"/>
+          </a:xfrm>
+          <a:prstGeom prst="rect">
+            <a:avLst/>
+          </a:prstGeom>
+          <a:noFill/>
+        </p:spPr>
+        <p:txBody>
+          <a:bodyPr wrap="square" anchor="t" lIns="0" rIns="0" tIns="0" bIns="0">
+            <a:spAutoFit/>
+          </a:bodyPr>
+          <a:lstStyle/>
+          <a:p>
+            <a:pPr algn="l">
+              <a:lnSpc>
+                <a:spcPct val="115000"/>
+              </a:lnSpc>
+            </a:pPr>
+            <a:r>
+              <a:rPr sz="1300" b="0">
+                <a:solidFill>
+                  <a:srgbClr val="CADCFC"/>
+                </a:solidFill>
+                <a:latin typeface="Arial"/>
+              </a:rPr>
+              <a:t>The same eligibility and enrollment services power your next channels — customer self-service, IVR, and the DER platform — without rebuilding. Agents launch it first; the architecture already serves all of them.</a:t>
+            </a:r>
+          </a:p>
+        </p:txBody>
+      </p:sp>
+    </p:spTree>
+  </p:cSld>
+  <p:clrMapOvr>
+    <a:masterClrMapping/>
+  </p:clrMapOvr>
+</p:sld>
+</file>
+
+<file path=ppt/slides/slide13.xml><?xml version="1.0" encoding="utf-8"?>
+<p:sld xmlns:a="http://schemas.openxmlformats.org/drawingml/2006/main" xmlns:p="http://schemas.openxmlformats.org/presentationml/2006/main" xmlns:r="http://schemas.openxmlformats.org/officeDocument/2006/relationships">
+  <p:cSld>
+    <p:bg>
+      <p:bgPr>
+        <a:solidFill>
+          <a:srgbClr val="FFFFFF"/>
+        </a:solidFill>
+        <a:effectLst/>
+      </p:bgPr>
+    </p:bg>
+    <p:spTree>
+      <p:nvGrpSpPr>
+        <p:cNvPr id="1" name=""/>
+        <p:cNvGrpSpPr/>
+        <p:nvPr/>
+      </p:nvGrpSpPr>
+      <p:grpSpPr/>
+      <p:sp>
+        <p:nvSpPr>
+          <p:cNvPr id="2" name="TextBox 1"/>
+          <p:cNvSpPr txBox="1"/>
+          <p:nvPr/>
+        </p:nvSpPr>
+        <p:spPr>
+          <a:xfrm>
+            <a:off x="548640" y="347472"/>
+            <a:ext cx="11064240" cy="685800"/>
+          </a:xfrm>
+          <a:prstGeom prst="rect">
+            <a:avLst/>
+          </a:prstGeom>
+          <a:noFill/>
+        </p:spPr>
+        <p:txBody>
+          <a:bodyPr wrap="square" anchor="t" lIns="0" rIns="0" tIns="0" bIns="0">
+            <a:spAutoFit/>
+          </a:bodyPr>
+          <a:lstStyle/>
+          <a:p>
+            <a:pPr algn="l"/>
+            <a:r>
+              <a:rPr sz="3000" b="1">
+                <a:solidFill>
+                  <a:srgbClr val="1D2D3E"/>
+                </a:solidFill>
+                <a:latin typeface="Arial"/>
+              </a:rPr>
+              <a:t>Delivery roadmap</a:t>
+            </a:r>
+          </a:p>
+        </p:txBody>
+      </p:sp>
+      <p:sp>
+        <p:nvSpPr>
+          <p:cNvPr id="3" name="TextBox 2"/>
+          <p:cNvSpPr txBox="1"/>
+          <p:nvPr/>
+        </p:nvSpPr>
+        <p:spPr>
+          <a:xfrm>
+            <a:off x="548640" y="932688"/>
+            <a:ext cx="11064240" cy="365760"/>
+          </a:xfrm>
+          <a:prstGeom prst="rect">
+            <a:avLst/>
+          </a:prstGeom>
+          <a:noFill/>
+        </p:spPr>
+        <p:txBody>
+          <a:bodyPr wrap="square" anchor="t" lIns="0" rIns="0" tIns="0" bIns="0">
+            <a:spAutoFit/>
+          </a:bodyPr>
+          <a:lstStyle/>
+          <a:p>
+            <a:pPr algn="l"/>
+            <a:r>
+              <a:rPr sz="1400" b="0">
+                <a:solidFill>
+                  <a:srgbClr val="556B82"/>
+                </a:solidFill>
+                <a:latin typeface="Arial"/>
+              </a:rPr>
+              <a:t>Design is complete and reviewed — build starts with a two-week proof</a:t>
+            </a:r>
+          </a:p>
+        </p:txBody>
+      </p:sp>
+      <p:sp>
+        <p:nvSpPr>
+          <p:cNvPr id="4" name="Rounded Rectangle 3"/>
+          <p:cNvSpPr/>
+          <p:nvPr/>
+        </p:nvSpPr>
+        <p:spPr>
+          <a:xfrm>
+            <a:off x="548640" y="1783080"/>
+            <a:ext cx="3611880" cy="2286000"/>
+          </a:xfrm>
+          <a:prstGeom prst="roundRect">
+            <a:avLst>
+              <a:gd name="adj" fmla="val 8000"/>
+            </a:avLst>
+          </a:prstGeom>
+          <a:solidFill>
+            <a:srgbClr val="FFFFFF"/>
+          </a:solidFill>
+          <a:ln w="9525">
+            <a:solidFill>
+              <a:srgbClr val="D9D9D9"/>
+            </a:solidFill>
+          </a:ln>
+          <a:effectLst/>
+        </p:spPr>
+        <p:style>
+          <a:lnRef idx="1">
+            <a:schemeClr val="accent1"/>
+          </a:lnRef>
+          <a:fillRef idx="3">
+            <a:schemeClr val="accent1"/>
+          </a:fillRef>
+          <a:effectRef idx="2">
+            <a:schemeClr val="accent1"/>
+          </a:effectRef>
+          <a:fontRef idx="minor">
+            <a:schemeClr val="lt1"/>
+          </a:fontRef>
+        </p:style>
+        <p:txBody>
+          <a:bodyPr rtlCol="0" anchor="ctr"/>
+          <a:lstStyle/>
+          <a:p>
+            <a:pPr algn="ctr"/>
+          </a:p>
+        </p:txBody>
+      </p:sp>
+      <p:sp>
+        <p:nvSpPr>
+          <p:cNvPr id="5" name="Rounded Rectangle 4"/>
+          <p:cNvSpPr/>
+          <p:nvPr/>
+        </p:nvSpPr>
+        <p:spPr>
+          <a:xfrm>
+            <a:off x="777240" y="2011680"/>
+            <a:ext cx="1737360" cy="329184"/>
+          </a:xfrm>
+          <a:prstGeom prst="roundRect">
+            <a:avLst>
+              <a:gd name="adj" fmla="val 50000"/>
+            </a:avLst>
+          </a:prstGeom>
+          <a:solidFill>
+            <a:srgbClr val="F5F6F7"/>
+          </a:solidFill>
+          <a:ln>
+            <a:noFill/>
+          </a:ln>
+          <a:effectLst/>
+        </p:spPr>
+        <p:style>
+          <a:lnRef idx="1">
+            <a:schemeClr val="accent1"/>
+          </a:lnRef>
+          <a:fillRef idx="3">
+            <a:schemeClr val="accent1"/>
+          </a:fillRef>
+          <a:effectRef idx="2">
+            <a:schemeClr val="accent1"/>
+          </a:effectRef>
+          <a:fontRef idx="minor">
+            <a:schemeClr val="lt1"/>
+          </a:fontRef>
+        </p:style>
+        <p:txBody>
+          <a:bodyPr rtlCol="0" anchor="ctr" wrap="none" lIns="18288" rIns="18288" tIns="0" bIns="0"/>
+          <a:lstStyle/>
+          <a:p>
+            <a:pPr algn="ctr"/>
+            <a:r>
+              <a:rPr sz="1200" b="1">
+                <a:solidFill>
+                  <a:srgbClr val="556B82"/>
+                </a:solidFill>
+                <a:latin typeface="Arial"/>
+              </a:rPr>
+              <a:t>Spike — 2 weeks</a:t>
+            </a:r>
+          </a:p>
+        </p:txBody>
+      </p:sp>
+      <p:sp>
+        <p:nvSpPr>
+          <p:cNvPr id="6" name="TextBox 5"/>
+          <p:cNvSpPr txBox="1"/>
+          <p:nvPr/>
+        </p:nvSpPr>
+        <p:spPr>
+          <a:xfrm>
+            <a:off x="777240" y="2514600"/>
+            <a:ext cx="3154680" cy="1188720"/>
+          </a:xfrm>
+          <a:prstGeom prst="rect">
+            <a:avLst/>
+          </a:prstGeom>
+          <a:noFill/>
+        </p:spPr>
+        <p:txBody>
+          <a:bodyPr wrap="square" anchor="t" lIns="0" rIns="0" tIns="0" bIns="0">
+            <a:spAutoFit/>
+          </a:bodyPr>
+          <a:lstStyle/>
+          <a:p>
+            <a:pPr algn="l">
+              <a:lnSpc>
+                <a:spcPct val="115000"/>
+              </a:lnSpc>
+            </a:pPr>
+            <a:r>
+              <a:rPr sz="1150" b="0">
+                <a:solidFill>
+                  <a:srgbClr val="556B82"/>
+                </a:solidFill>
+                <a:latin typeface="Arial"/>
+              </a:rPr>
+              <a:t>Prove SC V2 embedding (both access points) and principal propagation to S/4HANA</a:t>
+            </a:r>
+          </a:p>
+        </p:txBody>
+      </p:sp>
+      <p:sp>
+        <p:nvSpPr>
+          <p:cNvPr id="7" name="TextBox 6"/>
+          <p:cNvSpPr txBox="1"/>
+          <p:nvPr/>
+        </p:nvSpPr>
+        <p:spPr>
+          <a:xfrm>
+            <a:off x="777240" y="3657600"/>
+            <a:ext cx="3108960" cy="320040"/>
+          </a:xfrm>
+          <a:prstGeom prst="rect">
+            <a:avLst/>
+          </a:prstGeom>
+          <a:noFill/>
+        </p:spPr>
+        <p:txBody>
+          <a:bodyPr wrap="square" anchor="t" lIns="0" rIns="0" tIns="0" bIns="0">
+            <a:spAutoFit/>
+          </a:bodyPr>
+          <a:lstStyle/>
+          <a:p>
+            <a:pPr algn="l"/>
+            <a:r>
+              <a:rPr sz="1200" b="1">
+                <a:solidFill>
+                  <a:srgbClr val="1D2D3E"/>
+                </a:solidFill>
+                <a:latin typeface="Arial"/>
+              </a:rPr>
+              <a:t>Now</a:t>
+            </a:r>
+          </a:p>
+        </p:txBody>
+      </p:sp>
+      <p:sp>
+        <p:nvSpPr>
+          <p:cNvPr id="8" name="Right Arrow 7"/>
+          <p:cNvSpPr/>
+          <p:nvPr/>
+        </p:nvSpPr>
+        <p:spPr>
+          <a:xfrm>
+            <a:off x="4178808" y="2788920"/>
+            <a:ext cx="237744" cy="201168"/>
+          </a:xfrm>
+          <a:prstGeom prst="rightArrow">
+            <a:avLst/>
+          </a:prstGeom>
+          <a:solidFill>
+            <a:srgbClr val="556B82"/>
+          </a:solidFill>
+          <a:ln>
+            <a:noFill/>
+          </a:ln>
+          <a:effectLst/>
+        </p:spPr>
+        <p:style>
+          <a:lnRef idx="1">
+            <a:schemeClr val="accent1"/>
+          </a:lnRef>
+          <a:fillRef idx="3">
+            <a:schemeClr val="accent1"/>
+          </a:fillRef>
+          <a:effectRef idx="2">
+            <a:schemeClr val="accent1"/>
+          </a:effectRef>
+          <a:fontRef idx="minor">
+            <a:schemeClr val="lt1"/>
+          </a:fontRef>
+        </p:style>
+        <p:txBody>
+          <a:bodyPr rtlCol="0" anchor="ctr"/>
+          <a:lstStyle/>
+          <a:p>
+            <a:pPr algn="ctr"/>
+          </a:p>
+        </p:txBody>
+      </p:sp>
+      <p:sp>
+        <p:nvSpPr>
+          <p:cNvPr id="9" name="Rounded Rectangle 8"/>
+          <p:cNvSpPr/>
+          <p:nvPr/>
+        </p:nvSpPr>
+        <p:spPr>
+          <a:xfrm>
+            <a:off x="4379976" y="1783080"/>
+            <a:ext cx="3611880" cy="2286000"/>
+          </a:xfrm>
+          <a:prstGeom prst="roundRect">
+            <a:avLst>
+              <a:gd name="adj" fmla="val 8000"/>
+            </a:avLst>
+          </a:prstGeom>
+          <a:solidFill>
+            <a:srgbClr val="FFFFFF"/>
+          </a:solidFill>
+          <a:ln w="9525">
+            <a:solidFill>
+              <a:srgbClr val="D9D9D9"/>
+            </a:solidFill>
+          </a:ln>
+          <a:effectLst/>
+        </p:spPr>
+        <p:style>
+          <a:lnRef idx="1">
+            <a:schemeClr val="accent1"/>
+          </a:lnRef>
+          <a:fillRef idx="3">
+            <a:schemeClr val="accent1"/>
+          </a:fillRef>
+          <a:effectRef idx="2">
+            <a:schemeClr val="accent1"/>
+          </a:effectRef>
+          <a:fontRef idx="minor">
+            <a:schemeClr val="lt1"/>
+          </a:fontRef>
+        </p:style>
+        <p:txBody>
+          <a:bodyPr rtlCol="0" anchor="ctr"/>
+          <a:lstStyle/>
+          <a:p>
+            <a:pPr algn="ctr"/>
+          </a:p>
+        </p:txBody>
+      </p:sp>
+      <p:sp>
+        <p:nvSpPr>
+          <p:cNvPr id="10" name="Rounded Rectangle 9"/>
+          <p:cNvSpPr/>
+          <p:nvPr/>
+        </p:nvSpPr>
+        <p:spPr>
+          <a:xfrm>
+            <a:off x="4608576" y="2011680"/>
+            <a:ext cx="1737360" cy="329184"/>
+          </a:xfrm>
+          <a:prstGeom prst="roundRect">
+            <a:avLst>
+              <a:gd name="adj" fmla="val 50000"/>
+            </a:avLst>
+          </a:prstGeom>
+          <a:solidFill>
+            <a:srgbClr val="E3F0FF"/>
+          </a:solidFill>
+          <a:ln>
+            <a:noFill/>
+          </a:ln>
+          <a:effectLst/>
+        </p:spPr>
+        <p:style>
+          <a:lnRef idx="1">
+            <a:schemeClr val="accent1"/>
+          </a:lnRef>
+          <a:fillRef idx="3">
+            <a:schemeClr val="accent1"/>
+          </a:fillRef>
+          <a:effectRef idx="2">
+            <a:schemeClr val="accent1"/>
+          </a:effectRef>
+          <a:fontRef idx="minor">
+            <a:schemeClr val="lt1"/>
+          </a:fontRef>
+        </p:style>
+        <p:txBody>
+          <a:bodyPr rtlCol="0" anchor="ctr" wrap="none" lIns="18288" rIns="18288" tIns="0" bIns="0"/>
+          <a:lstStyle/>
+          <a:p>
+            <a:pPr algn="ctr"/>
+            <a:r>
+              <a:rPr sz="1200" b="1">
+                <a:solidFill>
+                  <a:srgbClr val="0057D2"/>
+                </a:solidFill>
+                <a:latin typeface="Arial"/>
+              </a:rPr>
+              <a:t>Increment 1</a:t>
+            </a:r>
+          </a:p>
+        </p:txBody>
+      </p:sp>
+      <p:sp>
+        <p:nvSpPr>
+          <p:cNvPr id="11" name="TextBox 10"/>
+          <p:cNvSpPr txBox="1"/>
+          <p:nvPr/>
+        </p:nvSpPr>
+        <p:spPr>
+          <a:xfrm>
+            <a:off x="4608576" y="2514600"/>
+            <a:ext cx="3154680" cy="1188720"/>
+          </a:xfrm>
+          <a:prstGeom prst="rect">
+            <a:avLst/>
+          </a:prstGeom>
+          <a:noFill/>
+        </p:spPr>
+        <p:txBody>
+          <a:bodyPr wrap="square" anchor="t" lIns="0" rIns="0" tIns="0" bIns="0">
+            <a:spAutoFit/>
+          </a:bodyPr>
+          <a:lstStyle/>
+          <a:p>
+            <a:pPr algn="l">
+              <a:lnSpc>
+                <a:spcPct val="115000"/>
+              </a:lnSpc>
+            </a:pPr>
+            <a:r>
+              <a:rPr sz="1150" b="0">
+                <a:solidFill>
+                  <a:srgbClr val="556B82"/>
+                </a:solidFill>
+                <a:latin typeface="Arial"/>
+              </a:rPr>
+              <a:t>Enrollment Center shell · context &amp; eligibility · first program end-to-end (CSDD) · SC V2 timeline</a:t>
+            </a:r>
+          </a:p>
+        </p:txBody>
+      </p:sp>
+      <p:sp>
+        <p:nvSpPr>
+          <p:cNvPr id="12" name="TextBox 11"/>
+          <p:cNvSpPr txBox="1"/>
+          <p:nvPr/>
+        </p:nvSpPr>
+        <p:spPr>
+          <a:xfrm>
+            <a:off x="4608576" y="3657600"/>
+            <a:ext cx="3108960" cy="320040"/>
+          </a:xfrm>
+          <a:prstGeom prst="rect">
+            <a:avLst/>
+          </a:prstGeom>
+          <a:noFill/>
+        </p:spPr>
+        <p:txBody>
+          <a:bodyPr wrap="square" anchor="t" lIns="0" rIns="0" tIns="0" bIns="0">
+            <a:spAutoFit/>
+          </a:bodyPr>
+          <a:lstStyle/>
+          <a:p>
+            <a:pPr algn="l"/>
+            <a:r>
+              <a:rPr sz="1200" b="1">
+                <a:solidFill>
+                  <a:srgbClr val="1D2D3E"/>
+                </a:solidFill>
+                <a:latin typeface="Arial"/>
+              </a:rPr>
+              <a:t>Wks 3–10</a:t>
+            </a:r>
+          </a:p>
+        </p:txBody>
+      </p:sp>
+      <p:sp>
+        <p:nvSpPr>
+          <p:cNvPr id="13" name="Right Arrow 12"/>
+          <p:cNvSpPr/>
+          <p:nvPr/>
+        </p:nvSpPr>
+        <p:spPr>
+          <a:xfrm>
+            <a:off x="8010144" y="2788920"/>
+            <a:ext cx="237744" cy="201168"/>
+          </a:xfrm>
+          <a:prstGeom prst="rightArrow">
+            <a:avLst/>
+          </a:prstGeom>
+          <a:solidFill>
+            <a:srgbClr val="556B82"/>
+          </a:solidFill>
+          <a:ln>
+            <a:noFill/>
+          </a:ln>
+          <a:effectLst/>
+        </p:spPr>
+        <p:style>
+          <a:lnRef idx="1">
+            <a:schemeClr val="accent1"/>
+          </a:lnRef>
+          <a:fillRef idx="3">
+            <a:schemeClr val="accent1"/>
+          </a:fillRef>
+          <a:effectRef idx="2">
+            <a:schemeClr val="accent1"/>
+          </a:effectRef>
+          <a:fontRef idx="minor">
+            <a:schemeClr val="lt1"/>
+          </a:fontRef>
+        </p:style>
+        <p:txBody>
+          <a:bodyPr rtlCol="0" anchor="ctr"/>
+          <a:lstStyle/>
+          <a:p>
+            <a:pPr algn="ctr"/>
+          </a:p>
+        </p:txBody>
+      </p:sp>
+      <p:sp>
+        <p:nvSpPr>
+          <p:cNvPr id="14" name="Rounded Rectangle 13"/>
+          <p:cNvSpPr/>
+          <p:nvPr/>
+        </p:nvSpPr>
+        <p:spPr>
+          <a:xfrm>
+            <a:off x="8211312" y="1783080"/>
+            <a:ext cx="3611880" cy="2286000"/>
+          </a:xfrm>
+          <a:prstGeom prst="roundRect">
+            <a:avLst>
+              <a:gd name="adj" fmla="val 8000"/>
+            </a:avLst>
+          </a:prstGeom>
+          <a:solidFill>
+            <a:srgbClr val="FFFFFF"/>
+          </a:solidFill>
+          <a:ln w="9525">
+            <a:solidFill>
+              <a:srgbClr val="D9D9D9"/>
+            </a:solidFill>
+          </a:ln>
+          <a:effectLst/>
+        </p:spPr>
+        <p:style>
+          <a:lnRef idx="1">
+            <a:schemeClr val="accent1"/>
+          </a:lnRef>
+          <a:fillRef idx="3">
+            <a:schemeClr val="accent1"/>
+          </a:fillRef>
+          <a:effectRef idx="2">
+            <a:schemeClr val="accent1"/>
+          </a:effectRef>
+          <a:fontRef idx="minor">
+            <a:schemeClr val="lt1"/>
+          </a:fontRef>
+        </p:style>
+        <p:txBody>
+          <a:bodyPr rtlCol="0" anchor="ctr"/>
+          <a:lstStyle/>
+          <a:p>
+            <a:pPr algn="ctr"/>
+          </a:p>
+        </p:txBody>
+      </p:sp>
+      <p:sp>
+        <p:nvSpPr>
           <p:cNvPr id="15" name="Rounded Rectangle 14"/>
           <p:cNvSpPr/>
           <p:nvPr/>
@@ -5656,7 +6408,7 @@
 </p:sld>
 </file>
 
-<file path=ppt/slides/slide13.xml><?xml version="1.0" encoding="utf-8"?>
+<file path=ppt/slides/slide14.xml><?xml version="1.0" encoding="utf-8"?>
 <p:sld xmlns:a="http://schemas.openxmlformats.org/drawingml/2006/main" xmlns:p="http://schemas.openxmlformats.org/presentationml/2006/main" xmlns:r="http://schemas.openxmlformats.org/officeDocument/2006/relationships">
   <p:cSld>
     <p:bg>
@@ -6057,7 +6809,7 @@
 </p:sld>
 </file>
 
-<file path=ppt/slides/slide14.xml><?xml version="1.0" encoding="utf-8"?>
+<file path=ppt/slides/slide15.xml><?xml version="1.0" encoding="utf-8"?>
 <p:sld xmlns:a="http://schemas.openxmlformats.org/drawingml/2006/main" xmlns:p="http://schemas.openxmlformats.org/presentationml/2006/main" xmlns:r="http://schemas.openxmlformats.org/officeDocument/2006/relationships">
   <p:cSld>
     <p:bg>
@@ -6105,7 +6857,7 @@
                 </a:solidFill>
                 <a:latin typeface="Arial"/>
               </a:rPr>
-              <a:t>AI on top of the rules</a:t>
+              <a:t>How the AI score is calculated</a:t>
             </a:r>
           </a:p>
         </p:txBody>
@@ -6140,7 +6892,7 @@
                 </a:solidFill>
                 <a:latin typeface="Arial"/>
               </a:rPr>
-              <a:t>Machine learning recommends — the rules engine decides. Full portfolio in the AI/ML Roadmap.</a:t>
+              <a:t>The percentage is a calibrated enrollment probability — the likelihood this customer enrolls if the agent offers the program</a:t>
             </a:r>
           </a:p>
         </p:txBody>
@@ -6153,8 +6905,8 @@
         </p:nvSpPr>
         <p:spPr>
           <a:xfrm>
-            <a:off x="548640" y="1645920"/>
-            <a:ext cx="5440680" cy="1463040"/>
+            <a:off x="548640" y="1600200"/>
+            <a:ext cx="3520440" cy="1481328"/>
           </a:xfrm>
           <a:prstGeom prst="roundRect">
             <a:avLst>
@@ -6195,22 +6947,20 @@
       </p:sp>
       <p:sp>
         <p:nvSpPr>
-          <p:cNvPr id="5" name="Rounded Rectangle 4"/>
+          <p:cNvPr id="5" name="Oval 4"/>
           <p:cNvSpPr/>
           <p:nvPr/>
         </p:nvSpPr>
         <p:spPr>
           <a:xfrm>
-            <a:off x="822959" y="1847088"/>
-            <a:ext cx="2103120" cy="310896"/>
-          </a:xfrm>
-          <a:prstGeom prst="roundRect">
-            <a:avLst>
-              <a:gd name="adj" fmla="val 50000"/>
-            </a:avLst>
+            <a:off x="749808" y="1783080"/>
+            <a:ext cx="384048" cy="384048"/>
+          </a:xfrm>
+          <a:prstGeom prst="ellipse">
+            <a:avLst/>
           </a:prstGeom>
           <a:solidFill>
-            <a:srgbClr val="F0EAFD"/>
+            <a:srgbClr val="0070F2"/>
           </a:solidFill>
           <a:ln>
             <a:noFill/>
@@ -6232,18 +6982,18 @@
           </a:fontRef>
         </p:style>
         <p:txBody>
-          <a:bodyPr rtlCol="0" anchor="ctr" lIns="18288" rIns="18288" tIns="0" bIns="0"/>
+          <a:bodyPr rtlCol="0" anchor="ctr" lIns="0" rIns="0" tIns="0" bIns="0"/>
           <a:lstStyle/>
           <a:p>
             <a:pPr algn="ctr"/>
             <a:r>
-              <a:rPr sz="1150" b="1">
-                <a:solidFill>
-                  <a:srgbClr val="6C32A9"/>
-                </a:solidFill>
-                <a:latin typeface="Arial"/>
-              </a:rPr>
-              <a:t>AI-1 · Recommend</a:t>
+              <a:rPr sz="1500" b="1">
+                <a:solidFill>
+                  <a:srgbClr val="FFFFFF"/>
+                </a:solidFill>
+                <a:latin typeface="Arial"/>
+              </a:rPr>
+              <a:t>1</a:t>
             </a:r>
           </a:p>
         </p:txBody>
@@ -6256,8 +7006,8 @@
         </p:nvSpPr>
         <p:spPr>
           <a:xfrm>
-            <a:off x="822959" y="2267712"/>
-            <a:ext cx="4937760" cy="777240"/>
+            <a:off x="1261872" y="1819656"/>
+            <a:ext cx="2697480" cy="320040"/>
           </a:xfrm>
           <a:prstGeom prst="rect">
             <a:avLst/>
@@ -6270,33 +7020,68 @@
           </a:bodyPr>
           <a:lstStyle/>
           <a:p>
+            <a:pPr algn="l"/>
+            <a:r>
+              <a:rPr sz="1400" b="1">
+                <a:solidFill>
+                  <a:srgbClr val="1D2D3E"/>
+                </a:solidFill>
+                <a:latin typeface="Arial"/>
+              </a:rPr>
+              <a:t>Training data</a:t>
+            </a:r>
+          </a:p>
+        </p:txBody>
+      </p:sp>
+      <p:sp>
+        <p:nvSpPr>
+          <p:cNvPr id="7" name="TextBox 6"/>
+          <p:cNvSpPr txBox="1"/>
+          <p:nvPr/>
+        </p:nvSpPr>
+        <p:spPr>
+          <a:xfrm>
+            <a:off x="804672" y="2203704"/>
+            <a:ext cx="3063240" cy="822960"/>
+          </a:xfrm>
+          <a:prstGeom prst="rect">
+            <a:avLst/>
+          </a:prstGeom>
+          <a:noFill/>
+        </p:spPr>
+        <p:txBody>
+          <a:bodyPr wrap="square" lIns="0" rIns="0" tIns="0" bIns="0">
+            <a:spAutoFit/>
+          </a:bodyPr>
+          <a:lstStyle/>
+          <a:p>
             <a:pPr algn="l">
               <a:lnSpc>
-                <a:spcPct val="112000"/>
+                <a:spcPct val="110000"/>
               </a:lnSpc>
             </a:pPr>
             <a:r>
-              <a:rPr sz="1200" b="0">
+              <a:rPr sz="1050" b="0">
                 <a:solidFill>
                   <a:srgbClr val="556B82"/>
                 </a:solidFill>
                 <a:latin typeface="Arial"/>
               </a:rPr>
-              <a:t>Next-best-program ranking with reasons — agents pitch the right program first (live in the demo)</a:t>
-            </a:r>
-          </a:p>
-        </p:txBody>
-      </p:sp>
-      <p:sp>
-        <p:nvSpPr>
-          <p:cNvPr id="7" name="Rounded Rectangle 6"/>
+              <a:t>The system labels its own examples: every offer shown, plus the outcome — enrolled within 30 days or not</a:t>
+            </a:r>
+          </a:p>
+        </p:txBody>
+      </p:sp>
+      <p:sp>
+        <p:nvSpPr>
+          <p:cNvPr id="8" name="Rounded Rectangle 7"/>
           <p:cNvSpPr/>
           <p:nvPr/>
         </p:nvSpPr>
         <p:spPr>
           <a:xfrm>
-            <a:off x="6172200" y="1645920"/>
-            <a:ext cx="5440680" cy="1463040"/>
+            <a:off x="4251960" y="1600200"/>
+            <a:ext cx="3520440" cy="1481328"/>
           </a:xfrm>
           <a:prstGeom prst="roundRect">
             <a:avLst>
@@ -6337,22 +7122,20 @@
       </p:sp>
       <p:sp>
         <p:nvSpPr>
-          <p:cNvPr id="8" name="Rounded Rectangle 7"/>
+          <p:cNvPr id="9" name="Oval 8"/>
           <p:cNvSpPr/>
           <p:nvPr/>
         </p:nvSpPr>
         <p:spPr>
           <a:xfrm>
-            <a:off x="6446520" y="1847088"/>
-            <a:ext cx="2103120" cy="310896"/>
-          </a:xfrm>
-          <a:prstGeom prst="roundRect">
-            <a:avLst>
-              <a:gd name="adj" fmla="val 50000"/>
-            </a:avLst>
+            <a:off x="4453128" y="1783080"/>
+            <a:ext cx="384048" cy="384048"/>
+          </a:xfrm>
+          <a:prstGeom prst="ellipse">
+            <a:avLst/>
           </a:prstGeom>
           <a:solidFill>
-            <a:srgbClr val="E3F0FF"/>
+            <a:srgbClr val="0070F2"/>
           </a:solidFill>
           <a:ln>
             <a:noFill/>
@@ -6374,32 +7157,32 @@
           </a:fontRef>
         </p:style>
         <p:txBody>
-          <a:bodyPr rtlCol="0" anchor="ctr" lIns="18288" rIns="18288" tIns="0" bIns="0"/>
+          <a:bodyPr rtlCol="0" anchor="ctr" lIns="0" rIns="0" tIns="0" bIns="0"/>
           <a:lstStyle/>
           <a:p>
             <a:pPr algn="ctr"/>
             <a:r>
-              <a:rPr sz="1150" b="1">
-                <a:solidFill>
-                  <a:srgbClr val="0057D2"/>
-                </a:solidFill>
-                <a:latin typeface="Arial"/>
-              </a:rPr>
-              <a:t>AI-2 · Explain</a:t>
-            </a:r>
-          </a:p>
-        </p:txBody>
-      </p:sp>
-      <p:sp>
-        <p:nvSpPr>
-          <p:cNvPr id="9" name="TextBox 8"/>
+              <a:rPr sz="1500" b="1">
+                <a:solidFill>
+                  <a:srgbClr val="FFFFFF"/>
+                </a:solidFill>
+                <a:latin typeface="Arial"/>
+              </a:rPr>
+              <a:t>2</a:t>
+            </a:r>
+          </a:p>
+        </p:txBody>
+      </p:sp>
+      <p:sp>
+        <p:nvSpPr>
+          <p:cNvPr id="10" name="TextBox 9"/>
           <p:cNvSpPr txBox="1"/>
           <p:nvPr/>
         </p:nvSpPr>
         <p:spPr>
           <a:xfrm>
-            <a:off x="6446520" y="2267712"/>
-            <a:ext cx="4937760" cy="777240"/>
+            <a:off x="4965192" y="1819656"/>
+            <a:ext cx="2697480" cy="320040"/>
           </a:xfrm>
           <a:prstGeom prst="rect">
             <a:avLst/>
@@ -6412,33 +7195,68 @@
           </a:bodyPr>
           <a:lstStyle/>
           <a:p>
+            <a:pPr algn="l"/>
+            <a:r>
+              <a:rPr sz="1400" b="1">
+                <a:solidFill>
+                  <a:srgbClr val="1D2D3E"/>
+                </a:solidFill>
+                <a:latin typeface="Arial"/>
+              </a:rPr>
+              <a:t>Features</a:t>
+            </a:r>
+          </a:p>
+        </p:txBody>
+      </p:sp>
+      <p:sp>
+        <p:nvSpPr>
+          <p:cNvPr id="11" name="TextBox 10"/>
+          <p:cNvSpPr txBox="1"/>
+          <p:nvPr/>
+        </p:nvSpPr>
+        <p:spPr>
+          <a:xfrm>
+            <a:off x="4507992" y="2203704"/>
+            <a:ext cx="3063240" cy="822960"/>
+          </a:xfrm>
+          <a:prstGeom prst="rect">
+            <a:avLst/>
+          </a:prstGeom>
+          <a:noFill/>
+        </p:spPr>
+        <p:txBody>
+          <a:bodyPr wrap="square" lIns="0" rIns="0" tIns="0" bIns="0">
+            <a:spAutoFit/>
+          </a:bodyPr>
+          <a:lstStyle/>
+          <a:p>
             <a:pPr algn="l">
               <a:lnSpc>
-                <a:spcPct val="112000"/>
+                <a:spcPct val="110000"/>
               </a:lnSpc>
             </a:pPr>
             <a:r>
-              <a:rPr sz="1200" b="0">
+              <a:rPr sz="1050" b="0">
                 <a:solidFill>
                   <a:srgbClr val="556B82"/>
                 </a:solidFill>
                 <a:latin typeface="Arial"/>
               </a:rPr>
-              <a:t>Plain-language program explanations for THIS customer, grounded on the catalog (live in the demo)</a:t>
-            </a:r>
-          </a:p>
-        </p:txBody>
-      </p:sp>
-      <p:sp>
-        <p:nvSpPr>
-          <p:cNvPr id="10" name="Rounded Rectangle 9"/>
+              <a:t>The context already on screen: meter type and status, DER equipment, payment behavior, program history, usage</a:t>
+            </a:r>
+          </a:p>
+        </p:txBody>
+      </p:sp>
+      <p:sp>
+        <p:nvSpPr>
+          <p:cNvPr id="12" name="Rounded Rectangle 11"/>
           <p:cNvSpPr/>
           <p:nvPr/>
         </p:nvSpPr>
         <p:spPr>
           <a:xfrm>
-            <a:off x="548640" y="3246120"/>
-            <a:ext cx="5440680" cy="1463040"/>
+            <a:off x="7955279" y="1600200"/>
+            <a:ext cx="3520440" cy="1481328"/>
           </a:xfrm>
           <a:prstGeom prst="roundRect">
             <a:avLst>
@@ -6479,22 +7297,20 @@
       </p:sp>
       <p:sp>
         <p:nvSpPr>
-          <p:cNvPr id="11" name="Rounded Rectangle 10"/>
+          <p:cNvPr id="13" name="Oval 12"/>
           <p:cNvSpPr/>
           <p:nvPr/>
         </p:nvSpPr>
         <p:spPr>
           <a:xfrm>
-            <a:off x="822959" y="3447288"/>
-            <a:ext cx="2103120" cy="310896"/>
-          </a:xfrm>
-          <a:prstGeom prst="roundRect">
-            <a:avLst>
-              <a:gd name="adj" fmla="val 50000"/>
-            </a:avLst>
+            <a:off x="8156448" y="1783080"/>
+            <a:ext cx="384048" cy="384048"/>
+          </a:xfrm>
+          <a:prstGeom prst="ellipse">
+            <a:avLst/>
           </a:prstGeom>
           <a:solidFill>
-            <a:srgbClr val="EBF5EB"/>
+            <a:srgbClr val="0070F2"/>
           </a:solidFill>
           <a:ln>
             <a:noFill/>
@@ -6516,32 +7332,32 @@
           </a:fontRef>
         </p:style>
         <p:txBody>
-          <a:bodyPr rtlCol="0" anchor="ctr" lIns="18288" rIns="18288" tIns="0" bIns="0"/>
+          <a:bodyPr rtlCol="0" anchor="ctr" lIns="0" rIns="0" tIns="0" bIns="0"/>
           <a:lstStyle/>
           <a:p>
             <a:pPr algn="ctr"/>
             <a:r>
-              <a:rPr sz="1150" b="1">
-                <a:solidFill>
-                  <a:srgbClr val="188918"/>
-                </a:solidFill>
-                <a:latin typeface="Arial"/>
-              </a:rPr>
-              <a:t>AI-3 · Verify savings</a:t>
-            </a:r>
-          </a:p>
-        </p:txBody>
-      </p:sp>
-      <p:sp>
-        <p:nvSpPr>
-          <p:cNvPr id="12" name="TextBox 11"/>
+              <a:rPr sz="1500" b="1">
+                <a:solidFill>
+                  <a:srgbClr val="FFFFFF"/>
+                </a:solidFill>
+                <a:latin typeface="Arial"/>
+              </a:rPr>
+              <a:t>3</a:t>
+            </a:r>
+          </a:p>
+        </p:txBody>
+      </p:sp>
+      <p:sp>
+        <p:nvSpPr>
+          <p:cNvPr id="14" name="TextBox 13"/>
           <p:cNvSpPr txBox="1"/>
           <p:nvPr/>
         </p:nvSpPr>
         <p:spPr>
           <a:xfrm>
-            <a:off x="822959" y="3867911"/>
-            <a:ext cx="4937760" cy="777240"/>
+            <a:off x="8668511" y="1819656"/>
+            <a:ext cx="2697480" cy="320040"/>
           </a:xfrm>
           <a:prstGeom prst="rect">
             <a:avLst/>
@@ -6554,33 +7370,68 @@
           </a:bodyPr>
           <a:lstStyle/>
           <a:p>
+            <a:pPr algn="l"/>
+            <a:r>
+              <a:rPr sz="1400" b="1">
+                <a:solidFill>
+                  <a:srgbClr val="1D2D3E"/>
+                </a:solidFill>
+                <a:latin typeface="Arial"/>
+              </a:rPr>
+              <a:t>Model</a:t>
+            </a:r>
+          </a:p>
+        </p:txBody>
+      </p:sp>
+      <p:sp>
+        <p:nvSpPr>
+          <p:cNvPr id="15" name="TextBox 14"/>
+          <p:cNvSpPr txBox="1"/>
+          <p:nvPr/>
+        </p:nvSpPr>
+        <p:spPr>
+          <a:xfrm>
+            <a:off x="8211311" y="2203704"/>
+            <a:ext cx="3063240" cy="822960"/>
+          </a:xfrm>
+          <a:prstGeom prst="rect">
+            <a:avLst/>
+          </a:prstGeom>
+          <a:noFill/>
+        </p:spPr>
+        <p:txBody>
+          <a:bodyPr wrap="square" lIns="0" rIns="0" tIns="0" bIns="0">
+            <a:spAutoFit/>
+          </a:bodyPr>
+          <a:lstStyle/>
+          <a:p>
             <a:pPr algn="l">
               <a:lnSpc>
-                <a:spcPct val="112000"/>
+                <a:spcPct val="110000"/>
               </a:lnSpc>
             </a:pPr>
             <a:r>
-              <a:rPr sz="1200" b="0">
+              <a:rPr sz="1050" b="0">
                 <a:solidFill>
                   <a:srgbClr val="556B82"/>
                 </a:solidFill>
                 <a:latin typeface="Arial"/>
               </a:rPr>
-              <a:t>Bill-impact simulation on interval data before rate enrollment — recommend only when it saves</a:t>
-            </a:r>
-          </a:p>
-        </p:txBody>
-      </p:sp>
-      <p:sp>
-        <p:nvSpPr>
-          <p:cNvPr id="13" name="Rounded Rectangle 12"/>
+              <a:t>A classification model on SAP HANA Cloud turns those features into a raw probability</a:t>
+            </a:r>
+          </a:p>
+        </p:txBody>
+      </p:sp>
+      <p:sp>
+        <p:nvSpPr>
+          <p:cNvPr id="16" name="Rounded Rectangle 15"/>
           <p:cNvSpPr/>
           <p:nvPr/>
         </p:nvSpPr>
         <p:spPr>
           <a:xfrm>
-            <a:off x="6172200" y="3246120"/>
-            <a:ext cx="5440680" cy="1463040"/>
+            <a:off x="548640" y="3246120"/>
+            <a:ext cx="3520440" cy="1481328"/>
           </a:xfrm>
           <a:prstGeom prst="roundRect">
             <a:avLst>
@@ -6621,22 +7472,20 @@
       </p:sp>
       <p:sp>
         <p:nvSpPr>
-          <p:cNvPr id="14" name="Rounded Rectangle 13"/>
+          <p:cNvPr id="17" name="Oval 16"/>
           <p:cNvSpPr/>
           <p:nvPr/>
         </p:nvSpPr>
         <p:spPr>
           <a:xfrm>
-            <a:off x="6446520" y="3447288"/>
-            <a:ext cx="2103120" cy="310896"/>
-          </a:xfrm>
-          <a:prstGeom prst="roundRect">
-            <a:avLst>
-              <a:gd name="adj" fmla="val 50000"/>
-            </a:avLst>
+            <a:off x="749808" y="3429000"/>
+            <a:ext cx="384048" cy="384048"/>
+          </a:xfrm>
+          <a:prstGeom prst="ellipse">
+            <a:avLst/>
           </a:prstGeom>
           <a:solidFill>
-            <a:srgbClr val="FFB300"/>
+            <a:srgbClr val="0070F2"/>
           </a:solidFill>
           <a:ln>
             <a:noFill/>
@@ -6658,32 +7507,32 @@
           </a:fontRef>
         </p:style>
         <p:txBody>
-          <a:bodyPr rtlCol="0" anchor="ctr" lIns="18288" rIns="18288" tIns="0" bIns="0"/>
+          <a:bodyPr rtlCol="0" anchor="ctr" lIns="0" rIns="0" tIns="0" bIns="0"/>
           <a:lstStyle/>
           <a:p>
             <a:pPr algn="ctr"/>
             <a:r>
-              <a:rPr sz="1150" b="1">
-                <a:solidFill>
-                  <a:srgbClr val="3B2A00"/>
-                </a:solidFill>
-                <a:latin typeface="Arial"/>
-              </a:rPr>
-              <a:t>AI-4 · Protect</a:t>
-            </a:r>
-          </a:p>
-        </p:txBody>
-      </p:sp>
-      <p:sp>
-        <p:nvSpPr>
-          <p:cNvPr id="15" name="TextBox 14"/>
+              <a:rPr sz="1500" b="1">
+                <a:solidFill>
+                  <a:srgbClr val="FFFFFF"/>
+                </a:solidFill>
+                <a:latin typeface="Arial"/>
+              </a:rPr>
+              <a:t>4</a:t>
+            </a:r>
+          </a:p>
+        </p:txBody>
+      </p:sp>
+      <p:sp>
+        <p:nvSpPr>
+          <p:cNvPr id="18" name="TextBox 17"/>
           <p:cNvSpPr txBox="1"/>
           <p:nvPr/>
         </p:nvSpPr>
         <p:spPr>
           <a:xfrm>
-            <a:off x="6446520" y="3867911"/>
-            <a:ext cx="4937760" cy="777240"/>
+            <a:off x="1261872" y="3465576"/>
+            <a:ext cx="2697480" cy="320040"/>
           </a:xfrm>
           <a:prstGeom prst="rect">
             <a:avLst/>
@@ -6696,33 +7545,418 @@
           </a:bodyPr>
           <a:lstStyle/>
           <a:p>
+            <a:pPr algn="l"/>
+            <a:r>
+              <a:rPr sz="1400" b="1">
+                <a:solidFill>
+                  <a:srgbClr val="1D2D3E"/>
+                </a:solidFill>
+                <a:latin typeface="Arial"/>
+              </a:rPr>
+              <a:t>Calibration</a:t>
+            </a:r>
+          </a:p>
+        </p:txBody>
+      </p:sp>
+      <p:sp>
+        <p:nvSpPr>
+          <p:cNvPr id="19" name="TextBox 18"/>
+          <p:cNvSpPr txBox="1"/>
+          <p:nvPr/>
+        </p:nvSpPr>
+        <p:spPr>
+          <a:xfrm>
+            <a:off x="804672" y="3849624"/>
+            <a:ext cx="3063240" cy="822960"/>
+          </a:xfrm>
+          <a:prstGeom prst="rect">
+            <a:avLst/>
+          </a:prstGeom>
+          <a:noFill/>
+        </p:spPr>
+        <p:txBody>
+          <a:bodyPr wrap="square" lIns="0" rIns="0" tIns="0" bIns="0">
+            <a:spAutoFit/>
+          </a:bodyPr>
+          <a:lstStyle/>
+          <a:p>
             <a:pPr algn="l">
               <a:lnSpc>
-                <a:spcPct val="112000"/>
+                <a:spcPct val="110000"/>
               </a:lnSpc>
             </a:pPr>
             <a:r>
-              <a:rPr sz="1200" b="0">
+              <a:rPr sz="1050" b="0">
                 <a:solidFill>
                   <a:srgbClr val="556B82"/>
                 </a:solidFill>
                 <a:latin typeface="Arial"/>
               </a:rPr>
-              <a:t>Payment-plan default prediction, document intelligence for assistance programs, exception triage</a:t>
-            </a:r>
-          </a:p>
-        </p:txBody>
-      </p:sp>
-      <p:sp>
-        <p:nvSpPr>
-          <p:cNvPr id="16" name="Rounded Rectangle 15"/>
+              <a:t>Adjusted so the number means what it says: of customers scored 87%, about 87% actually enroll</a:t>
+            </a:r>
+          </a:p>
+        </p:txBody>
+      </p:sp>
+      <p:sp>
+        <p:nvSpPr>
+          <p:cNvPr id="20" name="Rounded Rectangle 19"/>
           <p:cNvSpPr/>
           <p:nvPr/>
         </p:nvSpPr>
         <p:spPr>
           <a:xfrm>
-            <a:off x="548640" y="4937760"/>
-            <a:ext cx="11064240" cy="1234440"/>
+            <a:off x="4251960" y="3246120"/>
+            <a:ext cx="3520440" cy="1481328"/>
+          </a:xfrm>
+          <a:prstGeom prst="roundRect">
+            <a:avLst>
+              <a:gd name="adj" fmla="val 8000"/>
+            </a:avLst>
+          </a:prstGeom>
+          <a:solidFill>
+            <a:srgbClr val="F5F6F7"/>
+          </a:solidFill>
+          <a:ln w="9525">
+            <a:solidFill>
+              <a:srgbClr val="D9D9D9"/>
+            </a:solidFill>
+          </a:ln>
+          <a:effectLst/>
+        </p:spPr>
+        <p:style>
+          <a:lnRef idx="1">
+            <a:schemeClr val="accent1"/>
+          </a:lnRef>
+          <a:fillRef idx="3">
+            <a:schemeClr val="accent1"/>
+          </a:fillRef>
+          <a:effectRef idx="2">
+            <a:schemeClr val="accent1"/>
+          </a:effectRef>
+          <a:fontRef idx="minor">
+            <a:schemeClr val="lt1"/>
+          </a:fontRef>
+        </p:style>
+        <p:txBody>
+          <a:bodyPr rtlCol="0" anchor="ctr"/>
+          <a:lstStyle/>
+          <a:p>
+            <a:pPr algn="ctr"/>
+          </a:p>
+        </p:txBody>
+      </p:sp>
+      <p:sp>
+        <p:nvSpPr>
+          <p:cNvPr id="21" name="Oval 20"/>
+          <p:cNvSpPr/>
+          <p:nvPr/>
+        </p:nvSpPr>
+        <p:spPr>
+          <a:xfrm>
+            <a:off x="4453128" y="3429000"/>
+            <a:ext cx="384048" cy="384048"/>
+          </a:xfrm>
+          <a:prstGeom prst="ellipse">
+            <a:avLst/>
+          </a:prstGeom>
+          <a:solidFill>
+            <a:srgbClr val="0070F2"/>
+          </a:solidFill>
+          <a:ln>
+            <a:noFill/>
+          </a:ln>
+          <a:effectLst/>
+        </p:spPr>
+        <p:style>
+          <a:lnRef idx="1">
+            <a:schemeClr val="accent1"/>
+          </a:lnRef>
+          <a:fillRef idx="3">
+            <a:schemeClr val="accent1"/>
+          </a:fillRef>
+          <a:effectRef idx="2">
+            <a:schemeClr val="accent1"/>
+          </a:effectRef>
+          <a:fontRef idx="minor">
+            <a:schemeClr val="lt1"/>
+          </a:fontRef>
+        </p:style>
+        <p:txBody>
+          <a:bodyPr rtlCol="0" anchor="ctr" lIns="0" rIns="0" tIns="0" bIns="0"/>
+          <a:lstStyle/>
+          <a:p>
+            <a:pPr algn="ctr"/>
+            <a:r>
+              <a:rPr sz="1500" b="1">
+                <a:solidFill>
+                  <a:srgbClr val="FFFFFF"/>
+                </a:solidFill>
+                <a:latin typeface="Arial"/>
+              </a:rPr>
+              <a:t>5</a:t>
+            </a:r>
+          </a:p>
+        </p:txBody>
+      </p:sp>
+      <p:sp>
+        <p:nvSpPr>
+          <p:cNvPr id="22" name="TextBox 21"/>
+          <p:cNvSpPr txBox="1"/>
+          <p:nvPr/>
+        </p:nvSpPr>
+        <p:spPr>
+          <a:xfrm>
+            <a:off x="4965192" y="3465576"/>
+            <a:ext cx="2697480" cy="320040"/>
+          </a:xfrm>
+          <a:prstGeom prst="rect">
+            <a:avLst/>
+          </a:prstGeom>
+          <a:noFill/>
+        </p:spPr>
+        <p:txBody>
+          <a:bodyPr wrap="square" lIns="0" rIns="0" tIns="0" bIns="0">
+            <a:spAutoFit/>
+          </a:bodyPr>
+          <a:lstStyle/>
+          <a:p>
+            <a:pPr algn="l"/>
+            <a:r>
+              <a:rPr sz="1400" b="1">
+                <a:solidFill>
+                  <a:srgbClr val="1D2D3E"/>
+                </a:solidFill>
+                <a:latin typeface="Arial"/>
+              </a:rPr>
+              <a:t>Reason shown</a:t>
+            </a:r>
+          </a:p>
+        </p:txBody>
+      </p:sp>
+      <p:sp>
+        <p:nvSpPr>
+          <p:cNvPr id="23" name="TextBox 22"/>
+          <p:cNvSpPr txBox="1"/>
+          <p:nvPr/>
+        </p:nvSpPr>
+        <p:spPr>
+          <a:xfrm>
+            <a:off x="4507992" y="3849624"/>
+            <a:ext cx="3063240" cy="822960"/>
+          </a:xfrm>
+          <a:prstGeom prst="rect">
+            <a:avLst/>
+          </a:prstGeom>
+          <a:noFill/>
+        </p:spPr>
+        <p:txBody>
+          <a:bodyPr wrap="square" lIns="0" rIns="0" tIns="0" bIns="0">
+            <a:spAutoFit/>
+          </a:bodyPr>
+          <a:lstStyle/>
+          <a:p>
+            <a:pPr algn="l">
+              <a:lnSpc>
+                <a:spcPct val="110000"/>
+              </a:lnSpc>
+            </a:pPr>
+            <a:r>
+              <a:rPr sz="1050" b="0">
+                <a:solidFill>
+                  <a:srgbClr val="556B82"/>
+                </a:solidFill>
+                <a:latin typeface="Arial"/>
+              </a:rPr>
+              <a:t>The line under the badge comes from the model's top contributing factors — never free text</a:t>
+            </a:r>
+          </a:p>
+        </p:txBody>
+      </p:sp>
+      <p:sp>
+        <p:nvSpPr>
+          <p:cNvPr id="24" name="Rounded Rectangle 23"/>
+          <p:cNvSpPr/>
+          <p:nvPr/>
+        </p:nvSpPr>
+        <p:spPr>
+          <a:xfrm>
+            <a:off x="7955279" y="3246120"/>
+            <a:ext cx="3520440" cy="1481328"/>
+          </a:xfrm>
+          <a:prstGeom prst="roundRect">
+            <a:avLst>
+              <a:gd name="adj" fmla="val 8000"/>
+            </a:avLst>
+          </a:prstGeom>
+          <a:solidFill>
+            <a:srgbClr val="F5F6F7"/>
+          </a:solidFill>
+          <a:ln w="9525">
+            <a:solidFill>
+              <a:srgbClr val="D9D9D9"/>
+            </a:solidFill>
+          </a:ln>
+          <a:effectLst/>
+        </p:spPr>
+        <p:style>
+          <a:lnRef idx="1">
+            <a:schemeClr val="accent1"/>
+          </a:lnRef>
+          <a:fillRef idx="3">
+            <a:schemeClr val="accent1"/>
+          </a:fillRef>
+          <a:effectRef idx="2">
+            <a:schemeClr val="accent1"/>
+          </a:effectRef>
+          <a:fontRef idx="minor">
+            <a:schemeClr val="lt1"/>
+          </a:fontRef>
+        </p:style>
+        <p:txBody>
+          <a:bodyPr rtlCol="0" anchor="ctr"/>
+          <a:lstStyle/>
+          <a:p>
+            <a:pPr algn="ctr"/>
+          </a:p>
+        </p:txBody>
+      </p:sp>
+      <p:sp>
+        <p:nvSpPr>
+          <p:cNvPr id="25" name="Oval 24"/>
+          <p:cNvSpPr/>
+          <p:nvPr/>
+        </p:nvSpPr>
+        <p:spPr>
+          <a:xfrm>
+            <a:off x="8156448" y="3429000"/>
+            <a:ext cx="384048" cy="384048"/>
+          </a:xfrm>
+          <a:prstGeom prst="ellipse">
+            <a:avLst/>
+          </a:prstGeom>
+          <a:solidFill>
+            <a:srgbClr val="0070F2"/>
+          </a:solidFill>
+          <a:ln>
+            <a:noFill/>
+          </a:ln>
+          <a:effectLst/>
+        </p:spPr>
+        <p:style>
+          <a:lnRef idx="1">
+            <a:schemeClr val="accent1"/>
+          </a:lnRef>
+          <a:fillRef idx="3">
+            <a:schemeClr val="accent1"/>
+          </a:fillRef>
+          <a:effectRef idx="2">
+            <a:schemeClr val="accent1"/>
+          </a:effectRef>
+          <a:fontRef idx="minor">
+            <a:schemeClr val="lt1"/>
+          </a:fontRef>
+        </p:style>
+        <p:txBody>
+          <a:bodyPr rtlCol="0" anchor="ctr" lIns="0" rIns="0" tIns="0" bIns="0"/>
+          <a:lstStyle/>
+          <a:p>
+            <a:pPr algn="ctr"/>
+            <a:r>
+              <a:rPr sz="1500" b="1">
+                <a:solidFill>
+                  <a:srgbClr val="FFFFFF"/>
+                </a:solidFill>
+                <a:latin typeface="Arial"/>
+              </a:rPr>
+              <a:t>6</a:t>
+            </a:r>
+          </a:p>
+        </p:txBody>
+      </p:sp>
+      <p:sp>
+        <p:nvSpPr>
+          <p:cNvPr id="26" name="TextBox 25"/>
+          <p:cNvSpPr txBox="1"/>
+          <p:nvPr/>
+        </p:nvSpPr>
+        <p:spPr>
+          <a:xfrm>
+            <a:off x="8668511" y="3465576"/>
+            <a:ext cx="2697480" cy="320040"/>
+          </a:xfrm>
+          <a:prstGeom prst="rect">
+            <a:avLst/>
+          </a:prstGeom>
+          <a:noFill/>
+        </p:spPr>
+        <p:txBody>
+          <a:bodyPr wrap="square" lIns="0" rIns="0" tIns="0" bIns="0">
+            <a:spAutoFit/>
+          </a:bodyPr>
+          <a:lstStyle/>
+          <a:p>
+            <a:pPr algn="l"/>
+            <a:r>
+              <a:rPr sz="1400" b="1">
+                <a:solidFill>
+                  <a:srgbClr val="1D2D3E"/>
+                </a:solidFill>
+                <a:latin typeface="Arial"/>
+              </a:rPr>
+              <a:t>Ranking</a:t>
+            </a:r>
+          </a:p>
+        </p:txBody>
+      </p:sp>
+      <p:sp>
+        <p:nvSpPr>
+          <p:cNvPr id="27" name="TextBox 26"/>
+          <p:cNvSpPr txBox="1"/>
+          <p:nvPr/>
+        </p:nvSpPr>
+        <p:spPr>
+          <a:xfrm>
+            <a:off x="8211311" y="3849624"/>
+            <a:ext cx="3063240" cy="822960"/>
+          </a:xfrm>
+          <a:prstGeom prst="rect">
+            <a:avLst/>
+          </a:prstGeom>
+          <a:noFill/>
+        </p:spPr>
+        <p:txBody>
+          <a:bodyPr wrap="square" lIns="0" rIns="0" tIns="0" bIns="0">
+            <a:spAutoFit/>
+          </a:bodyPr>
+          <a:lstStyle/>
+          <a:p>
+            <a:pPr algn="l">
+              <a:lnSpc>
+                <a:spcPct val="110000"/>
+              </a:lnSpc>
+            </a:pPr>
+            <a:r>
+              <a:rPr sz="1050" b="0">
+                <a:solidFill>
+                  <a:srgbClr val="556B82"/>
+                </a:solidFill>
+                <a:latin typeface="Arial"/>
+              </a:rPr>
+              <a:t>Sort order weighs probability × program value — high-value programs can outrank easy wins</a:t>
+            </a:r>
+          </a:p>
+        </p:txBody>
+      </p:sp>
+      <p:sp>
+        <p:nvSpPr>
+          <p:cNvPr id="28" name="Rounded Rectangle 27"/>
+          <p:cNvSpPr/>
+          <p:nvPr/>
+        </p:nvSpPr>
+        <p:spPr>
+          <a:xfrm>
+            <a:off x="548640" y="5029200"/>
+            <a:ext cx="11064240" cy="1188720"/>
           </a:xfrm>
           <a:prstGeom prst="roundRect">
             <a:avLst>
@@ -6763,14 +7997,14 @@
       </p:sp>
       <p:sp>
         <p:nvSpPr>
-          <p:cNvPr id="17" name="TextBox 16"/>
+          <p:cNvPr id="29" name="TextBox 28"/>
           <p:cNvSpPr txBox="1"/>
           <p:nvPr/>
         </p:nvSpPr>
         <p:spPr>
           <a:xfrm>
-            <a:off x="822960" y="5120640"/>
-            <a:ext cx="10515600" cy="868680"/>
+            <a:off x="822960" y="5193792"/>
+            <a:ext cx="6949440" cy="868680"/>
           </a:xfrm>
           <a:prstGeom prst="rect">
             <a:avLst/>
@@ -6785,17 +8019,88 @@
           <a:p>
             <a:pPr algn="l">
               <a:lnSpc>
-                <a:spcPct val="115000"/>
+                <a:spcPct val="120000"/>
               </a:lnSpc>
             </a:pPr>
             <a:r>
-              <a:rPr sz="1300" b="0">
+              <a:rPr sz="1250" b="0">
                 <a:solidFill>
                   <a:srgbClr val="CADCFC"/>
                 </a:solidFill>
                 <a:latin typeface="Arial"/>
               </a:rPr>
-              <a:t>Governance: hard eligibility stays in auditable BRFplus decision tables — no model can enroll, reject or override. AI ranks, explains, predicts and drafts, always labeled, always with the agent in the loop.</a:t>
+              <a:t>Cold start: launches on weighted business rules, swaps to the trained model after 3–6 months of outcomes.</a:t>
+            </a:r>
+          </a:p>
+          <a:p>
+            <a:pPr algn="l">
+              <a:lnSpc>
+                <a:spcPct val="120000"/>
+              </a:lnSpc>
+            </a:pPr>
+            <a:r>
+              <a:rPr sz="1250" b="0">
+                <a:solidFill>
+                  <a:srgbClr val="CADCFC"/>
+                </a:solidFill>
+                <a:latin typeface="Arial"/>
+              </a:rPr>
+              <a:t>The model never decides eligibility — that stays in the BRFplus rules engine.</a:t>
+            </a:r>
+          </a:p>
+        </p:txBody>
+      </p:sp>
+      <p:sp>
+        <p:nvSpPr>
+          <p:cNvPr id="30" name="TextBox 29"/>
+          <p:cNvSpPr txBox="1"/>
+          <p:nvPr/>
+        </p:nvSpPr>
+        <p:spPr>
+          <a:xfrm>
+            <a:off x="8046720" y="5193792"/>
+            <a:ext cx="3291840" cy="868680"/>
+          </a:xfrm>
+          <a:prstGeom prst="rect">
+            <a:avLst/>
+          </a:prstGeom>
+          <a:noFill/>
+        </p:spPr>
+        <p:txBody>
+          <a:bodyPr wrap="square" lIns="0" rIns="0" tIns="0" bIns="0">
+            <a:spAutoFit/>
+          </a:bodyPr>
+          <a:lstStyle/>
+          <a:p>
+            <a:pPr algn="l">
+              <a:lnSpc>
+                <a:spcPct val="120000"/>
+              </a:lnSpc>
+            </a:pPr>
+            <a:r>
+              <a:rPr sz="1250" b="1">
+                <a:solidFill>
+                  <a:srgbClr val="FFB300"/>
+                </a:solidFill>
+                <a:latin typeface="Arial"/>
+              </a:rPr>
+              <a:t>Live in the demo:</a:t>
+            </a:r>
+          </a:p>
+          <a:p>
+            <a:pPr algn="l">
+              <a:lnSpc>
+                <a:spcPct val="120000"/>
+              </a:lnSpc>
+            </a:pPr>
+            <a:r>
+              <a:rPr sz="1250" b="1">
+                <a:solidFill>
+                  <a:srgbClr val="FFB300"/>
+                </a:solidFill>
+                <a:latin typeface="Arial"/>
+              </a:rPr>
+              <a:t>click any ✨ AI badge for this explanation</a:t>
             </a:r>
           </a:p>
         </p:txBody>

</xml_diff>

<commit_message>
Client deck: demo links updated to live org Pages URLs, AI/ML methodology page added to demo slide, closing slide URL updated
Co-Authored-By: Claude Fable 5 <noreply@anthropic.com>
</commit_message>
<xml_diff>
--- a/Enrollment Center/Enrollment Center - Client Presentation v1.0.pptx
+++ b/Enrollment Center/Enrollment Center - Client Presentation v1.0.pptx
@@ -4900,7 +4900,7 @@
           <a:noFill/>
         </p:spPr>
         <p:txBody>
-          <a:bodyPr wrap="square" anchor="t" lIns="0" rIns="0" tIns="0" bIns="0">
+          <a:bodyPr wrap="square" lIns="0" rIns="0" tIns="0" bIns="0">
             <a:spAutoFit/>
           </a:bodyPr>
           <a:lstStyle/>
@@ -4913,7 +4913,7 @@
                 </a:solidFill>
                 <a:latin typeface="Arial"/>
               </a:rPr>
-              <a:t>What the business gets</a:t>
+              <a:t>How the AI score is calculated</a:t>
             </a:r>
           </a:p>
         </p:txBody>
@@ -4935,7 +4935,7 @@
           <a:noFill/>
         </p:spPr>
         <p:txBody>
-          <a:bodyPr wrap="square" anchor="t" lIns="0" rIns="0" tIns="0" bIns="0">
+          <a:bodyPr wrap="square" lIns="0" rIns="0" tIns="0" bIns="0">
             <a:spAutoFit/>
           </a:bodyPr>
           <a:lstStyle/>
@@ -4948,7 +4948,7 @@
                 </a:solidFill>
                 <a:latin typeface="Arial"/>
               </a:rPr>
-              <a:t>Measured against the KPIs your call center already tracks</a:t>
+              <a:t>The percentage is a calibrated enrollment probability — the likelihood this customer enrolls if the agent offers the program</a:t>
             </a:r>
           </a:p>
         </p:txBody>
@@ -4961,8 +4961,8 @@
         </p:nvSpPr>
         <p:spPr>
           <a:xfrm>
-            <a:off x="548640" y="1691640"/>
-            <a:ext cx="5440680" cy="1280160"/>
+            <a:off x="548640" y="1600200"/>
+            <a:ext cx="3520440" cy="1481328"/>
           </a:xfrm>
           <a:prstGeom prst="roundRect">
             <a:avLst>
@@ -4970,7 +4970,7 @@
             </a:avLst>
           </a:prstGeom>
           <a:solidFill>
-            <a:srgbClr val="FFFFFF"/>
+            <a:srgbClr val="F5F6F7"/>
           </a:solidFill>
           <a:ln w="9525">
             <a:solidFill>
@@ -5003,35 +5003,53 @@
       </p:sp>
       <p:sp>
         <p:nvSpPr>
-          <p:cNvPr id="5" name="TextBox 4"/>
-          <p:cNvSpPr txBox="1"/>
-          <p:nvPr/>
-        </p:nvSpPr>
-        <p:spPr>
-          <a:xfrm>
-            <a:off x="868680" y="1892808"/>
-            <a:ext cx="1737360" cy="822960"/>
-          </a:xfrm>
-          <a:prstGeom prst="rect">
-            <a:avLst/>
-          </a:prstGeom>
-          <a:noFill/>
-        </p:spPr>
-        <p:txBody>
-          <a:bodyPr wrap="square" anchor="t" lIns="0" rIns="0" tIns="0" bIns="0">
-            <a:spAutoFit/>
-          </a:bodyPr>
-          <a:lstStyle/>
-          <a:p>
-            <a:pPr algn="l"/>
-            <a:r>
-              <a:rPr sz="3600" b="1">
-                <a:solidFill>
-                  <a:srgbClr val="0070F2"/>
-                </a:solidFill>
-                <a:latin typeface="Arial"/>
-              </a:rPr>
-              <a:t>&lt; 3 s</a:t>
+          <p:cNvPr id="5" name="Oval 4"/>
+          <p:cNvSpPr/>
+          <p:nvPr/>
+        </p:nvSpPr>
+        <p:spPr>
+          <a:xfrm>
+            <a:off x="749808" y="1783080"/>
+            <a:ext cx="384048" cy="384048"/>
+          </a:xfrm>
+          <a:prstGeom prst="ellipse">
+            <a:avLst/>
+          </a:prstGeom>
+          <a:solidFill>
+            <a:srgbClr val="0070F2"/>
+          </a:solidFill>
+          <a:ln>
+            <a:noFill/>
+          </a:ln>
+          <a:effectLst/>
+        </p:spPr>
+        <p:style>
+          <a:lnRef idx="1">
+            <a:schemeClr val="accent1"/>
+          </a:lnRef>
+          <a:fillRef idx="3">
+            <a:schemeClr val="accent1"/>
+          </a:fillRef>
+          <a:effectRef idx="2">
+            <a:schemeClr val="accent1"/>
+          </a:effectRef>
+          <a:fontRef idx="minor">
+            <a:schemeClr val="lt1"/>
+          </a:fontRef>
+        </p:style>
+        <p:txBody>
+          <a:bodyPr rtlCol="0" anchor="ctr" lIns="0" rIns="0" tIns="0" bIns="0"/>
+          <a:lstStyle/>
+          <a:p>
+            <a:pPr algn="ctr"/>
+            <a:r>
+              <a:rPr sz="1500" b="1">
+                <a:solidFill>
+                  <a:srgbClr val="FFFFFF"/>
+                </a:solidFill>
+                <a:latin typeface="Arial"/>
+              </a:rPr>
+              <a:t>1</a:t>
             </a:r>
           </a:p>
         </p:txBody>
@@ -5044,8 +5062,8 @@
         </p:nvSpPr>
         <p:spPr>
           <a:xfrm>
-            <a:off x="2697480" y="1947672"/>
-            <a:ext cx="3063240" cy="914400"/>
+            <a:off x="1261872" y="1819656"/>
+            <a:ext cx="2697480" cy="320040"/>
           </a:xfrm>
           <a:prstGeom prst="rect">
             <a:avLst/>
@@ -5053,7 +5071,42 @@
           <a:noFill/>
         </p:spPr>
         <p:txBody>
-          <a:bodyPr wrap="square" anchor="t" lIns="0" rIns="0" tIns="0" bIns="0">
+          <a:bodyPr wrap="square" lIns="0" rIns="0" tIns="0" bIns="0">
+            <a:spAutoFit/>
+          </a:bodyPr>
+          <a:lstStyle/>
+          <a:p>
+            <a:pPr algn="l"/>
+            <a:r>
+              <a:rPr sz="1400" b="1">
+                <a:solidFill>
+                  <a:srgbClr val="1D2D3E"/>
+                </a:solidFill>
+                <a:latin typeface="Arial"/>
+              </a:rPr>
+              <a:t>Training data</a:t>
+            </a:r>
+          </a:p>
+        </p:txBody>
+      </p:sp>
+      <p:sp>
+        <p:nvSpPr>
+          <p:cNvPr id="7" name="TextBox 6"/>
+          <p:cNvSpPr txBox="1"/>
+          <p:nvPr/>
+        </p:nvSpPr>
+        <p:spPr>
+          <a:xfrm>
+            <a:off x="804672" y="2203704"/>
+            <a:ext cx="3063240" cy="822960"/>
+          </a:xfrm>
+          <a:prstGeom prst="rect">
+            <a:avLst/>
+          </a:prstGeom>
+          <a:noFill/>
+        </p:spPr>
+        <p:txBody>
+          <a:bodyPr wrap="square" lIns="0" rIns="0" tIns="0" bIns="0">
             <a:spAutoFit/>
           </a:bodyPr>
           <a:lstStyle/>
@@ -5064,27 +5117,27 @@
               </a:lnSpc>
             </a:pPr>
             <a:r>
-              <a:rPr sz="1200" b="0">
+              <a:rPr sz="1050" b="0">
                 <a:solidFill>
                   <a:srgbClr val="556B82"/>
                 </a:solidFill>
                 <a:latin typeface="Arial"/>
               </a:rPr>
-              <a:t>from opening the Enrollment Center to a complete, eligibility-checked view</a:t>
-            </a:r>
-          </a:p>
-        </p:txBody>
-      </p:sp>
-      <p:sp>
-        <p:nvSpPr>
-          <p:cNvPr id="7" name="Rounded Rectangle 6"/>
+              <a:t>The system labels its own examples: every offer shown, plus the outcome — enrolled within 30 days or not</a:t>
+            </a:r>
+          </a:p>
+        </p:txBody>
+      </p:sp>
+      <p:sp>
+        <p:nvSpPr>
+          <p:cNvPr id="8" name="Rounded Rectangle 7"/>
           <p:cNvSpPr/>
           <p:nvPr/>
         </p:nvSpPr>
         <p:spPr>
           <a:xfrm>
-            <a:off x="6172200" y="1691640"/>
-            <a:ext cx="5440680" cy="1280160"/>
+            <a:off x="4251960" y="1600200"/>
+            <a:ext cx="3520440" cy="1481328"/>
           </a:xfrm>
           <a:prstGeom prst="roundRect">
             <a:avLst>
@@ -5092,7 +5145,7 @@
             </a:avLst>
           </a:prstGeom>
           <a:solidFill>
-            <a:srgbClr val="FFFFFF"/>
+            <a:srgbClr val="F5F6F7"/>
           </a:solidFill>
           <a:ln w="9525">
             <a:solidFill>
@@ -5125,14 +5178,67 @@
       </p:sp>
       <p:sp>
         <p:nvSpPr>
-          <p:cNvPr id="8" name="TextBox 7"/>
+          <p:cNvPr id="9" name="Oval 8"/>
+          <p:cNvSpPr/>
+          <p:nvPr/>
+        </p:nvSpPr>
+        <p:spPr>
+          <a:xfrm>
+            <a:off x="4453128" y="1783080"/>
+            <a:ext cx="384048" cy="384048"/>
+          </a:xfrm>
+          <a:prstGeom prst="ellipse">
+            <a:avLst/>
+          </a:prstGeom>
+          <a:solidFill>
+            <a:srgbClr val="0070F2"/>
+          </a:solidFill>
+          <a:ln>
+            <a:noFill/>
+          </a:ln>
+          <a:effectLst/>
+        </p:spPr>
+        <p:style>
+          <a:lnRef idx="1">
+            <a:schemeClr val="accent1"/>
+          </a:lnRef>
+          <a:fillRef idx="3">
+            <a:schemeClr val="accent1"/>
+          </a:fillRef>
+          <a:effectRef idx="2">
+            <a:schemeClr val="accent1"/>
+          </a:effectRef>
+          <a:fontRef idx="minor">
+            <a:schemeClr val="lt1"/>
+          </a:fontRef>
+        </p:style>
+        <p:txBody>
+          <a:bodyPr rtlCol="0" anchor="ctr" lIns="0" rIns="0" tIns="0" bIns="0"/>
+          <a:lstStyle/>
+          <a:p>
+            <a:pPr algn="ctr"/>
+            <a:r>
+              <a:rPr sz="1500" b="1">
+                <a:solidFill>
+                  <a:srgbClr val="FFFFFF"/>
+                </a:solidFill>
+                <a:latin typeface="Arial"/>
+              </a:rPr>
+              <a:t>2</a:t>
+            </a:r>
+          </a:p>
+        </p:txBody>
+      </p:sp>
+      <p:sp>
+        <p:nvSpPr>
+          <p:cNvPr id="10" name="TextBox 9"/>
           <p:cNvSpPr txBox="1"/>
           <p:nvPr/>
         </p:nvSpPr>
         <p:spPr>
           <a:xfrm>
-            <a:off x="6492240" y="1892808"/>
-            <a:ext cx="1737360" cy="822960"/>
+            <a:off x="4965192" y="1819656"/>
+            <a:ext cx="2697480" cy="320040"/>
           </a:xfrm>
           <a:prstGeom prst="rect">
             <a:avLst/>
@@ -5140,34 +5246,34 @@
           <a:noFill/>
         </p:spPr>
         <p:txBody>
-          <a:bodyPr wrap="square" anchor="t" lIns="0" rIns="0" tIns="0" bIns="0">
+          <a:bodyPr wrap="square" lIns="0" rIns="0" tIns="0" bIns="0">
             <a:spAutoFit/>
           </a:bodyPr>
           <a:lstStyle/>
           <a:p>
             <a:pPr algn="l"/>
             <a:r>
-              <a:rPr sz="3600" b="1">
-                <a:solidFill>
-                  <a:srgbClr val="0070F2"/>
-                </a:solidFill>
-                <a:latin typeface="Arial"/>
-              </a:rPr>
-              <a:t>1 call</a:t>
-            </a:r>
-          </a:p>
-        </p:txBody>
-      </p:sp>
-      <p:sp>
-        <p:nvSpPr>
-          <p:cNvPr id="9" name="TextBox 8"/>
+              <a:rPr sz="1400" b="1">
+                <a:solidFill>
+                  <a:srgbClr val="1D2D3E"/>
+                </a:solidFill>
+                <a:latin typeface="Arial"/>
+              </a:rPr>
+              <a:t>Features</a:t>
+            </a:r>
+          </a:p>
+        </p:txBody>
+      </p:sp>
+      <p:sp>
+        <p:nvSpPr>
+          <p:cNvPr id="11" name="TextBox 10"/>
           <p:cNvSpPr txBox="1"/>
           <p:nvPr/>
         </p:nvSpPr>
         <p:spPr>
           <a:xfrm>
-            <a:off x="8321040" y="1947672"/>
-            <a:ext cx="3063240" cy="914400"/>
+            <a:off x="4507992" y="2203704"/>
+            <a:ext cx="3063240" cy="822960"/>
           </a:xfrm>
           <a:prstGeom prst="rect">
             <a:avLst/>
@@ -5175,7 +5281,7 @@
           <a:noFill/>
         </p:spPr>
         <p:txBody>
-          <a:bodyPr wrap="square" anchor="t" lIns="0" rIns="0" tIns="0" bIns="0">
+          <a:bodyPr wrap="square" lIns="0" rIns="0" tIns="0" bIns="0">
             <a:spAutoFit/>
           </a:bodyPr>
           <a:lstStyle/>
@@ -5186,27 +5292,27 @@
               </a:lnSpc>
             </a:pPr>
             <a:r>
-              <a:rPr sz="1200" b="0">
+              <a:rPr sz="1050" b="0">
                 <a:solidFill>
                   <a:srgbClr val="556B82"/>
                 </a:solidFill>
                 <a:latin typeface="Arial"/>
               </a:rPr>
-              <a:t>evaluates all 28 programs across every contract account — no per-program prompts</a:t>
-            </a:r>
-          </a:p>
-        </p:txBody>
-      </p:sp>
-      <p:sp>
-        <p:nvSpPr>
-          <p:cNvPr id="10" name="Rounded Rectangle 9"/>
+              <a:t>The context already on screen: meter type and status, DER equipment, payment behavior, program history, usage</a:t>
+            </a:r>
+          </a:p>
+        </p:txBody>
+      </p:sp>
+      <p:sp>
+        <p:nvSpPr>
+          <p:cNvPr id="12" name="Rounded Rectangle 11"/>
           <p:cNvSpPr/>
           <p:nvPr/>
         </p:nvSpPr>
         <p:spPr>
           <a:xfrm>
-            <a:off x="548640" y="3108960"/>
-            <a:ext cx="5440680" cy="1280160"/>
+            <a:off x="7955279" y="1600200"/>
+            <a:ext cx="3520440" cy="1481328"/>
           </a:xfrm>
           <a:prstGeom prst="roundRect">
             <a:avLst>
@@ -5214,7 +5320,7 @@
             </a:avLst>
           </a:prstGeom>
           <a:solidFill>
-            <a:srgbClr val="FFFFFF"/>
+            <a:srgbClr val="F5F6F7"/>
           </a:solidFill>
           <a:ln w="9525">
             <a:solidFill>
@@ -5247,14 +5353,67 @@
       </p:sp>
       <p:sp>
         <p:nvSpPr>
-          <p:cNvPr id="11" name="TextBox 10"/>
+          <p:cNvPr id="13" name="Oval 12"/>
+          <p:cNvSpPr/>
+          <p:nvPr/>
+        </p:nvSpPr>
+        <p:spPr>
+          <a:xfrm>
+            <a:off x="8156448" y="1783080"/>
+            <a:ext cx="384048" cy="384048"/>
+          </a:xfrm>
+          <a:prstGeom prst="ellipse">
+            <a:avLst/>
+          </a:prstGeom>
+          <a:solidFill>
+            <a:srgbClr val="0070F2"/>
+          </a:solidFill>
+          <a:ln>
+            <a:noFill/>
+          </a:ln>
+          <a:effectLst/>
+        </p:spPr>
+        <p:style>
+          <a:lnRef idx="1">
+            <a:schemeClr val="accent1"/>
+          </a:lnRef>
+          <a:fillRef idx="3">
+            <a:schemeClr val="accent1"/>
+          </a:fillRef>
+          <a:effectRef idx="2">
+            <a:schemeClr val="accent1"/>
+          </a:effectRef>
+          <a:fontRef idx="minor">
+            <a:schemeClr val="lt1"/>
+          </a:fontRef>
+        </p:style>
+        <p:txBody>
+          <a:bodyPr rtlCol="0" anchor="ctr" lIns="0" rIns="0" tIns="0" bIns="0"/>
+          <a:lstStyle/>
+          <a:p>
+            <a:pPr algn="ctr"/>
+            <a:r>
+              <a:rPr sz="1500" b="1">
+                <a:solidFill>
+                  <a:srgbClr val="FFFFFF"/>
+                </a:solidFill>
+                <a:latin typeface="Arial"/>
+              </a:rPr>
+              <a:t>3</a:t>
+            </a:r>
+          </a:p>
+        </p:txBody>
+      </p:sp>
+      <p:sp>
+        <p:nvSpPr>
+          <p:cNvPr id="14" name="TextBox 13"/>
           <p:cNvSpPr txBox="1"/>
           <p:nvPr/>
         </p:nvSpPr>
         <p:spPr>
           <a:xfrm>
-            <a:off x="868680" y="3310128"/>
-            <a:ext cx="1737360" cy="822960"/>
+            <a:off x="8668511" y="1819656"/>
+            <a:ext cx="2697480" cy="320040"/>
           </a:xfrm>
           <a:prstGeom prst="rect">
             <a:avLst/>
@@ -5262,34 +5421,34 @@
           <a:noFill/>
         </p:spPr>
         <p:txBody>
-          <a:bodyPr wrap="square" anchor="t" lIns="0" rIns="0" tIns="0" bIns="0">
+          <a:bodyPr wrap="square" lIns="0" rIns="0" tIns="0" bIns="0">
             <a:spAutoFit/>
           </a:bodyPr>
           <a:lstStyle/>
           <a:p>
             <a:pPr algn="l"/>
             <a:r>
-              <a:rPr sz="3600" b="1">
-                <a:solidFill>
-                  <a:srgbClr val="0070F2"/>
-                </a:solidFill>
-                <a:latin typeface="Arial"/>
-              </a:rPr>
-              <a:t>0</a:t>
-            </a:r>
-          </a:p>
-        </p:txBody>
-      </p:sp>
-      <p:sp>
-        <p:nvSpPr>
-          <p:cNvPr id="12" name="TextBox 11"/>
+              <a:rPr sz="1400" b="1">
+                <a:solidFill>
+                  <a:srgbClr val="1D2D3E"/>
+                </a:solidFill>
+                <a:latin typeface="Arial"/>
+              </a:rPr>
+              <a:t>Model</a:t>
+            </a:r>
+          </a:p>
+        </p:txBody>
+      </p:sp>
+      <p:sp>
+        <p:nvSpPr>
+          <p:cNvPr id="15" name="TextBox 14"/>
           <p:cNvSpPr txBox="1"/>
           <p:nvPr/>
         </p:nvSpPr>
         <p:spPr>
           <a:xfrm>
-            <a:off x="2697480" y="3364991"/>
-            <a:ext cx="3063240" cy="914400"/>
+            <a:off x="8211311" y="2203704"/>
+            <a:ext cx="3063240" cy="822960"/>
           </a:xfrm>
           <a:prstGeom prst="rect">
             <a:avLst/>
@@ -5297,7 +5456,7 @@
           <a:noFill/>
         </p:spPr>
         <p:txBody>
-          <a:bodyPr wrap="square" anchor="t" lIns="0" rIns="0" tIns="0" bIns="0">
+          <a:bodyPr wrap="square" lIns="0" rIns="0" tIns="0" bIns="0">
             <a:spAutoFit/>
           </a:bodyPr>
           <a:lstStyle/>
@@ -5308,27 +5467,27 @@
               </a:lnSpc>
             </a:pPr>
             <a:r>
-              <a:rPr sz="1200" b="0">
+              <a:rPr sz="1050" b="0">
                 <a:solidFill>
                   <a:srgbClr val="556B82"/>
                 </a:solidFill>
                 <a:latin typeface="Arial"/>
               </a:rPr>
-              <a:t>modifications to the S/4HANA core — clean, upgrade-safe extension</a:t>
-            </a:r>
-          </a:p>
-        </p:txBody>
-      </p:sp>
-      <p:sp>
-        <p:nvSpPr>
-          <p:cNvPr id="13" name="Rounded Rectangle 12"/>
+              <a:t>A classification model on SAP HANA Cloud turns those features into a raw probability</a:t>
+            </a:r>
+          </a:p>
+        </p:txBody>
+      </p:sp>
+      <p:sp>
+        <p:nvSpPr>
+          <p:cNvPr id="16" name="Rounded Rectangle 15"/>
           <p:cNvSpPr/>
           <p:nvPr/>
         </p:nvSpPr>
         <p:spPr>
           <a:xfrm>
-            <a:off x="6172200" y="3108960"/>
-            <a:ext cx="5440680" cy="1280160"/>
+            <a:off x="548640" y="3246120"/>
+            <a:ext cx="3520440" cy="1481328"/>
           </a:xfrm>
           <a:prstGeom prst="roundRect">
             <a:avLst>
@@ -5336,7 +5495,7 @@
             </a:avLst>
           </a:prstGeom>
           <a:solidFill>
-            <a:srgbClr val="FFFFFF"/>
+            <a:srgbClr val="F5F6F7"/>
           </a:solidFill>
           <a:ln w="9525">
             <a:solidFill>
@@ -5369,14 +5528,67 @@
       </p:sp>
       <p:sp>
         <p:nvSpPr>
-          <p:cNvPr id="14" name="TextBox 13"/>
+          <p:cNvPr id="17" name="Oval 16"/>
+          <p:cNvSpPr/>
+          <p:nvPr/>
+        </p:nvSpPr>
+        <p:spPr>
+          <a:xfrm>
+            <a:off x="749808" y="3429000"/>
+            <a:ext cx="384048" cy="384048"/>
+          </a:xfrm>
+          <a:prstGeom prst="ellipse">
+            <a:avLst/>
+          </a:prstGeom>
+          <a:solidFill>
+            <a:srgbClr val="0070F2"/>
+          </a:solidFill>
+          <a:ln>
+            <a:noFill/>
+          </a:ln>
+          <a:effectLst/>
+        </p:spPr>
+        <p:style>
+          <a:lnRef idx="1">
+            <a:schemeClr val="accent1"/>
+          </a:lnRef>
+          <a:fillRef idx="3">
+            <a:schemeClr val="accent1"/>
+          </a:fillRef>
+          <a:effectRef idx="2">
+            <a:schemeClr val="accent1"/>
+          </a:effectRef>
+          <a:fontRef idx="minor">
+            <a:schemeClr val="lt1"/>
+          </a:fontRef>
+        </p:style>
+        <p:txBody>
+          <a:bodyPr rtlCol="0" anchor="ctr" lIns="0" rIns="0" tIns="0" bIns="0"/>
+          <a:lstStyle/>
+          <a:p>
+            <a:pPr algn="ctr"/>
+            <a:r>
+              <a:rPr sz="1500" b="1">
+                <a:solidFill>
+                  <a:srgbClr val="FFFFFF"/>
+                </a:solidFill>
+                <a:latin typeface="Arial"/>
+              </a:rPr>
+              <a:t>4</a:t>
+            </a:r>
+          </a:p>
+        </p:txBody>
+      </p:sp>
+      <p:sp>
+        <p:nvSpPr>
+          <p:cNvPr id="18" name="TextBox 17"/>
           <p:cNvSpPr txBox="1"/>
           <p:nvPr/>
         </p:nvSpPr>
         <p:spPr>
           <a:xfrm>
-            <a:off x="6492240" y="3310128"/>
-            <a:ext cx="1737360" cy="822960"/>
+            <a:off x="1261872" y="3465576"/>
+            <a:ext cx="2697480" cy="320040"/>
           </a:xfrm>
           <a:prstGeom prst="rect">
             <a:avLst/>
@@ -5384,34 +5596,34 @@
           <a:noFill/>
         </p:spPr>
         <p:txBody>
-          <a:bodyPr wrap="square" anchor="t" lIns="0" rIns="0" tIns="0" bIns="0">
+          <a:bodyPr wrap="square" lIns="0" rIns="0" tIns="0" bIns="0">
             <a:spAutoFit/>
           </a:bodyPr>
           <a:lstStyle/>
           <a:p>
             <a:pPr algn="l"/>
             <a:r>
-              <a:rPr sz="3600" b="1">
-                <a:solidFill>
-                  <a:srgbClr val="0070F2"/>
-                </a:solidFill>
-                <a:latin typeface="Arial"/>
-              </a:rPr>
-              <a:t>100 %</a:t>
-            </a:r>
-          </a:p>
-        </p:txBody>
-      </p:sp>
-      <p:sp>
-        <p:nvSpPr>
-          <p:cNvPr id="15" name="TextBox 14"/>
+              <a:rPr sz="1400" b="1">
+                <a:solidFill>
+                  <a:srgbClr val="1D2D3E"/>
+                </a:solidFill>
+                <a:latin typeface="Arial"/>
+              </a:rPr>
+              <a:t>Calibration</a:t>
+            </a:r>
+          </a:p>
+        </p:txBody>
+      </p:sp>
+      <p:sp>
+        <p:nvSpPr>
+          <p:cNvPr id="19" name="TextBox 18"/>
           <p:cNvSpPr txBox="1"/>
           <p:nvPr/>
         </p:nvSpPr>
         <p:spPr>
           <a:xfrm>
-            <a:off x="8321040" y="3364991"/>
-            <a:ext cx="3063240" cy="914400"/>
+            <a:off x="804672" y="3849624"/>
+            <a:ext cx="3063240" cy="822960"/>
           </a:xfrm>
           <a:prstGeom prst="rect">
             <a:avLst/>
@@ -5419,7 +5631,7 @@
           <a:noFill/>
         </p:spPr>
         <p:txBody>
-          <a:bodyPr wrap="square" anchor="t" lIns="0" rIns="0" tIns="0" bIns="0">
+          <a:bodyPr wrap="square" lIns="0" rIns="0" tIns="0" bIns="0">
             <a:spAutoFit/>
           </a:bodyPr>
           <a:lstStyle/>
@@ -5430,27 +5642,377 @@
               </a:lnSpc>
             </a:pPr>
             <a:r>
-              <a:rPr sz="1200" b="0">
+              <a:rPr sz="1050" b="0">
                 <a:solidFill>
                   <a:srgbClr val="556B82"/>
                 </a:solidFill>
                 <a:latin typeface="Arial"/>
               </a:rPr>
-              <a:t>of enrollments audited with eligibility basis, consent and actor</a:t>
-            </a:r>
-          </a:p>
-        </p:txBody>
-      </p:sp>
-      <p:sp>
-        <p:nvSpPr>
-          <p:cNvPr id="16" name="Rounded Rectangle 15"/>
+              <a:t>Adjusted so the number means what it says: of customers scored 87%, about 87% actually enroll</a:t>
+            </a:r>
+          </a:p>
+        </p:txBody>
+      </p:sp>
+      <p:sp>
+        <p:nvSpPr>
+          <p:cNvPr id="20" name="Rounded Rectangle 19"/>
           <p:cNvSpPr/>
           <p:nvPr/>
         </p:nvSpPr>
         <p:spPr>
           <a:xfrm>
-            <a:off x="548640" y="4617720"/>
-            <a:ext cx="11064240" cy="1554480"/>
+            <a:off x="4251960" y="3246120"/>
+            <a:ext cx="3520440" cy="1481328"/>
+          </a:xfrm>
+          <a:prstGeom prst="roundRect">
+            <a:avLst>
+              <a:gd name="adj" fmla="val 8000"/>
+            </a:avLst>
+          </a:prstGeom>
+          <a:solidFill>
+            <a:srgbClr val="F5F6F7"/>
+          </a:solidFill>
+          <a:ln w="9525">
+            <a:solidFill>
+              <a:srgbClr val="D9D9D9"/>
+            </a:solidFill>
+          </a:ln>
+          <a:effectLst/>
+        </p:spPr>
+        <p:style>
+          <a:lnRef idx="1">
+            <a:schemeClr val="accent1"/>
+          </a:lnRef>
+          <a:fillRef idx="3">
+            <a:schemeClr val="accent1"/>
+          </a:fillRef>
+          <a:effectRef idx="2">
+            <a:schemeClr val="accent1"/>
+          </a:effectRef>
+          <a:fontRef idx="minor">
+            <a:schemeClr val="lt1"/>
+          </a:fontRef>
+        </p:style>
+        <p:txBody>
+          <a:bodyPr rtlCol="0" anchor="ctr"/>
+          <a:lstStyle/>
+          <a:p>
+            <a:pPr algn="ctr"/>
+          </a:p>
+        </p:txBody>
+      </p:sp>
+      <p:sp>
+        <p:nvSpPr>
+          <p:cNvPr id="21" name="Oval 20"/>
+          <p:cNvSpPr/>
+          <p:nvPr/>
+        </p:nvSpPr>
+        <p:spPr>
+          <a:xfrm>
+            <a:off x="4453128" y="3429000"/>
+            <a:ext cx="384048" cy="384048"/>
+          </a:xfrm>
+          <a:prstGeom prst="ellipse">
+            <a:avLst/>
+          </a:prstGeom>
+          <a:solidFill>
+            <a:srgbClr val="0070F2"/>
+          </a:solidFill>
+          <a:ln>
+            <a:noFill/>
+          </a:ln>
+          <a:effectLst/>
+        </p:spPr>
+        <p:style>
+          <a:lnRef idx="1">
+            <a:schemeClr val="accent1"/>
+          </a:lnRef>
+          <a:fillRef idx="3">
+            <a:schemeClr val="accent1"/>
+          </a:fillRef>
+          <a:effectRef idx="2">
+            <a:schemeClr val="accent1"/>
+          </a:effectRef>
+          <a:fontRef idx="minor">
+            <a:schemeClr val="lt1"/>
+          </a:fontRef>
+        </p:style>
+        <p:txBody>
+          <a:bodyPr rtlCol="0" anchor="ctr" lIns="0" rIns="0" tIns="0" bIns="0"/>
+          <a:lstStyle/>
+          <a:p>
+            <a:pPr algn="ctr"/>
+            <a:r>
+              <a:rPr sz="1500" b="1">
+                <a:solidFill>
+                  <a:srgbClr val="FFFFFF"/>
+                </a:solidFill>
+                <a:latin typeface="Arial"/>
+              </a:rPr>
+              <a:t>5</a:t>
+            </a:r>
+          </a:p>
+        </p:txBody>
+      </p:sp>
+      <p:sp>
+        <p:nvSpPr>
+          <p:cNvPr id="22" name="TextBox 21"/>
+          <p:cNvSpPr txBox="1"/>
+          <p:nvPr/>
+        </p:nvSpPr>
+        <p:spPr>
+          <a:xfrm>
+            <a:off x="4965192" y="3465576"/>
+            <a:ext cx="2697480" cy="320040"/>
+          </a:xfrm>
+          <a:prstGeom prst="rect">
+            <a:avLst/>
+          </a:prstGeom>
+          <a:noFill/>
+        </p:spPr>
+        <p:txBody>
+          <a:bodyPr wrap="square" lIns="0" rIns="0" tIns="0" bIns="0">
+            <a:spAutoFit/>
+          </a:bodyPr>
+          <a:lstStyle/>
+          <a:p>
+            <a:pPr algn="l"/>
+            <a:r>
+              <a:rPr sz="1400" b="1">
+                <a:solidFill>
+                  <a:srgbClr val="1D2D3E"/>
+                </a:solidFill>
+                <a:latin typeface="Arial"/>
+              </a:rPr>
+              <a:t>Reason shown</a:t>
+            </a:r>
+          </a:p>
+        </p:txBody>
+      </p:sp>
+      <p:sp>
+        <p:nvSpPr>
+          <p:cNvPr id="23" name="TextBox 22"/>
+          <p:cNvSpPr txBox="1"/>
+          <p:nvPr/>
+        </p:nvSpPr>
+        <p:spPr>
+          <a:xfrm>
+            <a:off x="4507992" y="3849624"/>
+            <a:ext cx="3063240" cy="822960"/>
+          </a:xfrm>
+          <a:prstGeom prst="rect">
+            <a:avLst/>
+          </a:prstGeom>
+          <a:noFill/>
+        </p:spPr>
+        <p:txBody>
+          <a:bodyPr wrap="square" lIns="0" rIns="0" tIns="0" bIns="0">
+            <a:spAutoFit/>
+          </a:bodyPr>
+          <a:lstStyle/>
+          <a:p>
+            <a:pPr algn="l">
+              <a:lnSpc>
+                <a:spcPct val="110000"/>
+              </a:lnSpc>
+            </a:pPr>
+            <a:r>
+              <a:rPr sz="1050" b="0">
+                <a:solidFill>
+                  <a:srgbClr val="556B82"/>
+                </a:solidFill>
+                <a:latin typeface="Arial"/>
+              </a:rPr>
+              <a:t>The line under the badge comes from the model's top contributing factors — never free text</a:t>
+            </a:r>
+          </a:p>
+        </p:txBody>
+      </p:sp>
+      <p:sp>
+        <p:nvSpPr>
+          <p:cNvPr id="24" name="Rounded Rectangle 23"/>
+          <p:cNvSpPr/>
+          <p:nvPr/>
+        </p:nvSpPr>
+        <p:spPr>
+          <a:xfrm>
+            <a:off x="7955279" y="3246120"/>
+            <a:ext cx="3520440" cy="1481328"/>
+          </a:xfrm>
+          <a:prstGeom prst="roundRect">
+            <a:avLst>
+              <a:gd name="adj" fmla="val 8000"/>
+            </a:avLst>
+          </a:prstGeom>
+          <a:solidFill>
+            <a:srgbClr val="F5F6F7"/>
+          </a:solidFill>
+          <a:ln w="9525">
+            <a:solidFill>
+              <a:srgbClr val="D9D9D9"/>
+            </a:solidFill>
+          </a:ln>
+          <a:effectLst/>
+        </p:spPr>
+        <p:style>
+          <a:lnRef idx="1">
+            <a:schemeClr val="accent1"/>
+          </a:lnRef>
+          <a:fillRef idx="3">
+            <a:schemeClr val="accent1"/>
+          </a:fillRef>
+          <a:effectRef idx="2">
+            <a:schemeClr val="accent1"/>
+          </a:effectRef>
+          <a:fontRef idx="minor">
+            <a:schemeClr val="lt1"/>
+          </a:fontRef>
+        </p:style>
+        <p:txBody>
+          <a:bodyPr rtlCol="0" anchor="ctr"/>
+          <a:lstStyle/>
+          <a:p>
+            <a:pPr algn="ctr"/>
+          </a:p>
+        </p:txBody>
+      </p:sp>
+      <p:sp>
+        <p:nvSpPr>
+          <p:cNvPr id="25" name="Oval 24"/>
+          <p:cNvSpPr/>
+          <p:nvPr/>
+        </p:nvSpPr>
+        <p:spPr>
+          <a:xfrm>
+            <a:off x="8156448" y="3429000"/>
+            <a:ext cx="384048" cy="384048"/>
+          </a:xfrm>
+          <a:prstGeom prst="ellipse">
+            <a:avLst/>
+          </a:prstGeom>
+          <a:solidFill>
+            <a:srgbClr val="0070F2"/>
+          </a:solidFill>
+          <a:ln>
+            <a:noFill/>
+          </a:ln>
+          <a:effectLst/>
+        </p:spPr>
+        <p:style>
+          <a:lnRef idx="1">
+            <a:schemeClr val="accent1"/>
+          </a:lnRef>
+          <a:fillRef idx="3">
+            <a:schemeClr val="accent1"/>
+          </a:fillRef>
+          <a:effectRef idx="2">
+            <a:schemeClr val="accent1"/>
+          </a:effectRef>
+          <a:fontRef idx="minor">
+            <a:schemeClr val="lt1"/>
+          </a:fontRef>
+        </p:style>
+        <p:txBody>
+          <a:bodyPr rtlCol="0" anchor="ctr" lIns="0" rIns="0" tIns="0" bIns="0"/>
+          <a:lstStyle/>
+          <a:p>
+            <a:pPr algn="ctr"/>
+            <a:r>
+              <a:rPr sz="1500" b="1">
+                <a:solidFill>
+                  <a:srgbClr val="FFFFFF"/>
+                </a:solidFill>
+                <a:latin typeface="Arial"/>
+              </a:rPr>
+              <a:t>6</a:t>
+            </a:r>
+          </a:p>
+        </p:txBody>
+      </p:sp>
+      <p:sp>
+        <p:nvSpPr>
+          <p:cNvPr id="26" name="TextBox 25"/>
+          <p:cNvSpPr txBox="1"/>
+          <p:nvPr/>
+        </p:nvSpPr>
+        <p:spPr>
+          <a:xfrm>
+            <a:off x="8668511" y="3465576"/>
+            <a:ext cx="2697480" cy="320040"/>
+          </a:xfrm>
+          <a:prstGeom prst="rect">
+            <a:avLst/>
+          </a:prstGeom>
+          <a:noFill/>
+        </p:spPr>
+        <p:txBody>
+          <a:bodyPr wrap="square" lIns="0" rIns="0" tIns="0" bIns="0">
+            <a:spAutoFit/>
+          </a:bodyPr>
+          <a:lstStyle/>
+          <a:p>
+            <a:pPr algn="l"/>
+            <a:r>
+              <a:rPr sz="1400" b="1">
+                <a:solidFill>
+                  <a:srgbClr val="1D2D3E"/>
+                </a:solidFill>
+                <a:latin typeface="Arial"/>
+              </a:rPr>
+              <a:t>Ranking</a:t>
+            </a:r>
+          </a:p>
+        </p:txBody>
+      </p:sp>
+      <p:sp>
+        <p:nvSpPr>
+          <p:cNvPr id="27" name="TextBox 26"/>
+          <p:cNvSpPr txBox="1"/>
+          <p:nvPr/>
+        </p:nvSpPr>
+        <p:spPr>
+          <a:xfrm>
+            <a:off x="8211311" y="3849624"/>
+            <a:ext cx="3063240" cy="822960"/>
+          </a:xfrm>
+          <a:prstGeom prst="rect">
+            <a:avLst/>
+          </a:prstGeom>
+          <a:noFill/>
+        </p:spPr>
+        <p:txBody>
+          <a:bodyPr wrap="square" lIns="0" rIns="0" tIns="0" bIns="0">
+            <a:spAutoFit/>
+          </a:bodyPr>
+          <a:lstStyle/>
+          <a:p>
+            <a:pPr algn="l">
+              <a:lnSpc>
+                <a:spcPct val="110000"/>
+              </a:lnSpc>
+            </a:pPr>
+            <a:r>
+              <a:rPr sz="1050" b="0">
+                <a:solidFill>
+                  <a:srgbClr val="556B82"/>
+                </a:solidFill>
+                <a:latin typeface="Arial"/>
+              </a:rPr>
+              <a:t>Sort order weighs probability × program value — high-value programs can outrank easy wins</a:t>
+            </a:r>
+          </a:p>
+        </p:txBody>
+      </p:sp>
+      <p:sp>
+        <p:nvSpPr>
+          <p:cNvPr id="28" name="Rounded Rectangle 27"/>
+          <p:cNvSpPr/>
+          <p:nvPr/>
+        </p:nvSpPr>
+        <p:spPr>
+          <a:xfrm>
+            <a:off x="548640" y="5029200"/>
+            <a:ext cx="11064240" cy="1188720"/>
           </a:xfrm>
           <a:prstGeom prst="roundRect">
             <a:avLst>
@@ -5491,14 +6053,14 @@
       </p:sp>
       <p:sp>
         <p:nvSpPr>
-          <p:cNvPr id="17" name="TextBox 16"/>
+          <p:cNvPr id="29" name="TextBox 28"/>
           <p:cNvSpPr txBox="1"/>
           <p:nvPr/>
         </p:nvSpPr>
         <p:spPr>
           <a:xfrm>
-            <a:off x="822960" y="4828032"/>
-            <a:ext cx="10515600" cy="365760"/>
+            <a:off x="822960" y="5193792"/>
+            <a:ext cx="6949440" cy="868680"/>
           </a:xfrm>
           <a:prstGeom prst="rect">
             <a:avLst/>
@@ -5506,59 +6068,95 @@
           <a:noFill/>
         </p:spPr>
         <p:txBody>
-          <a:bodyPr wrap="square" anchor="t" lIns="0" rIns="0" tIns="0" bIns="0">
-            <a:spAutoFit/>
-          </a:bodyPr>
-          <a:lstStyle/>
-          <a:p>
-            <a:pPr algn="l"/>
-            <a:r>
-              <a:rPr sz="1400" b="1">
-                <a:solidFill>
-                  <a:srgbClr val="FFB300"/>
-                </a:solidFill>
-                <a:latin typeface="Arial"/>
-              </a:rPr>
-              <a:t>And the strategic payoff</a:t>
-            </a:r>
-          </a:p>
-        </p:txBody>
-      </p:sp>
-      <p:sp>
-        <p:nvSpPr>
-          <p:cNvPr id="18" name="TextBox 17"/>
-          <p:cNvSpPr txBox="1"/>
-          <p:nvPr/>
-        </p:nvSpPr>
-        <p:spPr>
-          <a:xfrm>
-            <a:off x="822960" y="5257800"/>
-            <a:ext cx="10515600" cy="822960"/>
-          </a:xfrm>
-          <a:prstGeom prst="rect">
-            <a:avLst/>
-          </a:prstGeom>
-          <a:noFill/>
-        </p:spPr>
-        <p:txBody>
-          <a:bodyPr wrap="square" anchor="t" lIns="0" rIns="0" tIns="0" bIns="0">
+          <a:bodyPr wrap="square" lIns="0" rIns="0" tIns="0" bIns="0">
             <a:spAutoFit/>
           </a:bodyPr>
           <a:lstStyle/>
           <a:p>
             <a:pPr algn="l">
               <a:lnSpc>
-                <a:spcPct val="115000"/>
+                <a:spcPct val="120000"/>
               </a:lnSpc>
             </a:pPr>
             <a:r>
-              <a:rPr sz="1300" b="0">
+              <a:rPr sz="1250" b="0">
                 <a:solidFill>
                   <a:srgbClr val="CADCFC"/>
                 </a:solidFill>
                 <a:latin typeface="Arial"/>
               </a:rPr>
-              <a:t>The same eligibility and enrollment services power your next channels — customer self-service, IVR, and the DER platform — without rebuilding. Agents launch it first; the architecture already serves all of them.</a:t>
+              <a:t>Cold start: launches on weighted business rules, swaps to the trained model after 3–6 months of outcomes.</a:t>
+            </a:r>
+          </a:p>
+          <a:p>
+            <a:pPr algn="l">
+              <a:lnSpc>
+                <a:spcPct val="120000"/>
+              </a:lnSpc>
+            </a:pPr>
+            <a:r>
+              <a:rPr sz="1250" b="0">
+                <a:solidFill>
+                  <a:srgbClr val="CADCFC"/>
+                </a:solidFill>
+                <a:latin typeface="Arial"/>
+              </a:rPr>
+              <a:t>The model never decides eligibility — that stays in the BRFplus rules engine.</a:t>
+            </a:r>
+          </a:p>
+        </p:txBody>
+      </p:sp>
+      <p:sp>
+        <p:nvSpPr>
+          <p:cNvPr id="30" name="TextBox 29"/>
+          <p:cNvSpPr txBox="1"/>
+          <p:nvPr/>
+        </p:nvSpPr>
+        <p:spPr>
+          <a:xfrm>
+            <a:off x="8046720" y="5193792"/>
+            <a:ext cx="3291840" cy="868680"/>
+          </a:xfrm>
+          <a:prstGeom prst="rect">
+            <a:avLst/>
+          </a:prstGeom>
+          <a:noFill/>
+        </p:spPr>
+        <p:txBody>
+          <a:bodyPr wrap="square" lIns="0" rIns="0" tIns="0" bIns="0">
+            <a:spAutoFit/>
+          </a:bodyPr>
+          <a:lstStyle/>
+          <a:p>
+            <a:pPr algn="l">
+              <a:lnSpc>
+                <a:spcPct val="120000"/>
+              </a:lnSpc>
+            </a:pPr>
+            <a:r>
+              <a:rPr sz="1250" b="1">
+                <a:solidFill>
+                  <a:srgbClr val="FFB300"/>
+                </a:solidFill>
+                <a:latin typeface="Arial"/>
+              </a:rPr>
+              <a:t>Live in the demo:</a:t>
+            </a:r>
+          </a:p>
+          <a:p>
+            <a:pPr algn="l">
+              <a:lnSpc>
+                <a:spcPct val="120000"/>
+              </a:lnSpc>
+            </a:pPr>
+            <a:r>
+              <a:rPr sz="1250" b="1">
+                <a:solidFill>
+                  <a:srgbClr val="FFB300"/>
+                </a:solidFill>
+                <a:latin typeface="Arial"/>
+              </a:rPr>
+              <a:t>click any ✨ AI badge for this explanation</a:t>
             </a:r>
           </a:p>
         </p:txBody>
@@ -5619,7 +6217,7 @@
                 </a:solidFill>
                 <a:latin typeface="Arial"/>
               </a:rPr>
-              <a:t>Delivery roadmap</a:t>
+              <a:t>What the business gets</a:t>
             </a:r>
           </a:p>
         </p:txBody>
@@ -5654,7 +6252,7 @@
                 </a:solidFill>
                 <a:latin typeface="Arial"/>
               </a:rPr>
-              <a:t>Design is complete and reviewed — build starts with a two-week proof</a:t>
+              <a:t>Measured against the KPIs your call center already tracks</a:t>
             </a:r>
           </a:p>
         </p:txBody>
@@ -5667,8 +6265,8 @@
         </p:nvSpPr>
         <p:spPr>
           <a:xfrm>
-            <a:off x="548640" y="1783080"/>
-            <a:ext cx="3611880" cy="2286000"/>
+            <a:off x="548640" y="1691640"/>
+            <a:ext cx="5440680" cy="1280160"/>
           </a:xfrm>
           <a:prstGeom prst="roundRect">
             <a:avLst>
@@ -5709,55 +6307,35 @@
       </p:sp>
       <p:sp>
         <p:nvSpPr>
-          <p:cNvPr id="5" name="Rounded Rectangle 4"/>
-          <p:cNvSpPr/>
-          <p:nvPr/>
-        </p:nvSpPr>
-        <p:spPr>
-          <a:xfrm>
-            <a:off x="777240" y="2011680"/>
-            <a:ext cx="1737360" cy="329184"/>
-          </a:xfrm>
-          <a:prstGeom prst="roundRect">
-            <a:avLst>
-              <a:gd name="adj" fmla="val 50000"/>
-            </a:avLst>
-          </a:prstGeom>
-          <a:solidFill>
-            <a:srgbClr val="F5F6F7"/>
-          </a:solidFill>
-          <a:ln>
-            <a:noFill/>
-          </a:ln>
-          <a:effectLst/>
-        </p:spPr>
-        <p:style>
-          <a:lnRef idx="1">
-            <a:schemeClr val="accent1"/>
-          </a:lnRef>
-          <a:fillRef idx="3">
-            <a:schemeClr val="accent1"/>
-          </a:fillRef>
-          <a:effectRef idx="2">
-            <a:schemeClr val="accent1"/>
-          </a:effectRef>
-          <a:fontRef idx="minor">
-            <a:schemeClr val="lt1"/>
-          </a:fontRef>
-        </p:style>
-        <p:txBody>
-          <a:bodyPr rtlCol="0" anchor="ctr" wrap="none" lIns="18288" rIns="18288" tIns="0" bIns="0"/>
-          <a:lstStyle/>
-          <a:p>
-            <a:pPr algn="ctr"/>
-            <a:r>
-              <a:rPr sz="1200" b="1">
-                <a:solidFill>
-                  <a:srgbClr val="556B82"/>
-                </a:solidFill>
-                <a:latin typeface="Arial"/>
-              </a:rPr>
-              <a:t>Spike — 2 weeks</a:t>
+          <p:cNvPr id="5" name="TextBox 4"/>
+          <p:cNvSpPr txBox="1"/>
+          <p:nvPr/>
+        </p:nvSpPr>
+        <p:spPr>
+          <a:xfrm>
+            <a:off x="868680" y="1892808"/>
+            <a:ext cx="1737360" cy="822960"/>
+          </a:xfrm>
+          <a:prstGeom prst="rect">
+            <a:avLst/>
+          </a:prstGeom>
+          <a:noFill/>
+        </p:spPr>
+        <p:txBody>
+          <a:bodyPr wrap="square" anchor="t" lIns="0" rIns="0" tIns="0" bIns="0">
+            <a:spAutoFit/>
+          </a:bodyPr>
+          <a:lstStyle/>
+          <a:p>
+            <a:pPr algn="l"/>
+            <a:r>
+              <a:rPr sz="3600" b="1">
+                <a:solidFill>
+                  <a:srgbClr val="0070F2"/>
+                </a:solidFill>
+                <a:latin typeface="Arial"/>
+              </a:rPr>
+              <a:t>&lt; 3 s</a:t>
             </a:r>
           </a:p>
         </p:txBody>
@@ -5770,8 +6348,8 @@
         </p:nvSpPr>
         <p:spPr>
           <a:xfrm>
-            <a:off x="777240" y="2514600"/>
-            <a:ext cx="3154680" cy="1188720"/>
+            <a:off x="2697480" y="1947672"/>
+            <a:ext cx="3063240" cy="914400"/>
           </a:xfrm>
           <a:prstGeom prst="rect">
             <a:avLst/>
@@ -5786,110 +6364,31 @@
           <a:p>
             <a:pPr algn="l">
               <a:lnSpc>
-                <a:spcPct val="115000"/>
+                <a:spcPct val="110000"/>
               </a:lnSpc>
             </a:pPr>
             <a:r>
-              <a:rPr sz="1150" b="0">
+              <a:rPr sz="1200" b="0">
                 <a:solidFill>
                   <a:srgbClr val="556B82"/>
                 </a:solidFill>
                 <a:latin typeface="Arial"/>
               </a:rPr>
-              <a:t>Prove SC V2 embedding (both access points) and principal propagation to S/4HANA</a:t>
-            </a:r>
-          </a:p>
-        </p:txBody>
-      </p:sp>
-      <p:sp>
-        <p:nvSpPr>
-          <p:cNvPr id="7" name="TextBox 6"/>
-          <p:cNvSpPr txBox="1"/>
-          <p:nvPr/>
-        </p:nvSpPr>
-        <p:spPr>
-          <a:xfrm>
-            <a:off x="777240" y="3657600"/>
-            <a:ext cx="3108960" cy="320040"/>
-          </a:xfrm>
-          <a:prstGeom prst="rect">
-            <a:avLst/>
-          </a:prstGeom>
-          <a:noFill/>
-        </p:spPr>
-        <p:txBody>
-          <a:bodyPr wrap="square" anchor="t" lIns="0" rIns="0" tIns="0" bIns="0">
-            <a:spAutoFit/>
-          </a:bodyPr>
-          <a:lstStyle/>
-          <a:p>
-            <a:pPr algn="l"/>
-            <a:r>
-              <a:rPr sz="1200" b="1">
-                <a:solidFill>
-                  <a:srgbClr val="1D2D3E"/>
-                </a:solidFill>
-                <a:latin typeface="Arial"/>
-              </a:rPr>
-              <a:t>Now</a:t>
-            </a:r>
-          </a:p>
-        </p:txBody>
-      </p:sp>
-      <p:sp>
-        <p:nvSpPr>
-          <p:cNvPr id="8" name="Right Arrow 7"/>
+              <a:t>from opening the Enrollment Center to a complete, eligibility-checked view</a:t>
+            </a:r>
+          </a:p>
+        </p:txBody>
+      </p:sp>
+      <p:sp>
+        <p:nvSpPr>
+          <p:cNvPr id="7" name="Rounded Rectangle 6"/>
           <p:cNvSpPr/>
           <p:nvPr/>
         </p:nvSpPr>
         <p:spPr>
           <a:xfrm>
-            <a:off x="4178808" y="2788920"/>
-            <a:ext cx="237744" cy="201168"/>
-          </a:xfrm>
-          <a:prstGeom prst="rightArrow">
-            <a:avLst/>
-          </a:prstGeom>
-          <a:solidFill>
-            <a:srgbClr val="556B82"/>
-          </a:solidFill>
-          <a:ln>
-            <a:noFill/>
-          </a:ln>
-          <a:effectLst/>
-        </p:spPr>
-        <p:style>
-          <a:lnRef idx="1">
-            <a:schemeClr val="accent1"/>
-          </a:lnRef>
-          <a:fillRef idx="3">
-            <a:schemeClr val="accent1"/>
-          </a:fillRef>
-          <a:effectRef idx="2">
-            <a:schemeClr val="accent1"/>
-          </a:effectRef>
-          <a:fontRef idx="minor">
-            <a:schemeClr val="lt1"/>
-          </a:fontRef>
-        </p:style>
-        <p:txBody>
-          <a:bodyPr rtlCol="0" anchor="ctr"/>
-          <a:lstStyle/>
-          <a:p>
-            <a:pPr algn="ctr"/>
-          </a:p>
-        </p:txBody>
-      </p:sp>
-      <p:sp>
-        <p:nvSpPr>
-          <p:cNvPr id="9" name="Rounded Rectangle 8"/>
-          <p:cNvSpPr/>
-          <p:nvPr/>
-        </p:nvSpPr>
-        <p:spPr>
-          <a:xfrm>
-            <a:off x="4379976" y="1783080"/>
-            <a:ext cx="3611880" cy="2286000"/>
+            <a:off x="6172200" y="1691640"/>
+            <a:ext cx="5440680" cy="1280160"/>
           </a:xfrm>
           <a:prstGeom prst="roundRect">
             <a:avLst>
@@ -5930,187 +6429,88 @@
       </p:sp>
       <p:sp>
         <p:nvSpPr>
+          <p:cNvPr id="8" name="TextBox 7"/>
+          <p:cNvSpPr txBox="1"/>
+          <p:nvPr/>
+        </p:nvSpPr>
+        <p:spPr>
+          <a:xfrm>
+            <a:off x="6492240" y="1892808"/>
+            <a:ext cx="1737360" cy="822960"/>
+          </a:xfrm>
+          <a:prstGeom prst="rect">
+            <a:avLst/>
+          </a:prstGeom>
+          <a:noFill/>
+        </p:spPr>
+        <p:txBody>
+          <a:bodyPr wrap="square" anchor="t" lIns="0" rIns="0" tIns="0" bIns="0">
+            <a:spAutoFit/>
+          </a:bodyPr>
+          <a:lstStyle/>
+          <a:p>
+            <a:pPr algn="l"/>
+            <a:r>
+              <a:rPr sz="3600" b="1">
+                <a:solidFill>
+                  <a:srgbClr val="0070F2"/>
+                </a:solidFill>
+                <a:latin typeface="Arial"/>
+              </a:rPr>
+              <a:t>1 call</a:t>
+            </a:r>
+          </a:p>
+        </p:txBody>
+      </p:sp>
+      <p:sp>
+        <p:nvSpPr>
+          <p:cNvPr id="9" name="TextBox 8"/>
+          <p:cNvSpPr txBox="1"/>
+          <p:nvPr/>
+        </p:nvSpPr>
+        <p:spPr>
+          <a:xfrm>
+            <a:off x="8321040" y="1947672"/>
+            <a:ext cx="3063240" cy="914400"/>
+          </a:xfrm>
+          <a:prstGeom prst="rect">
+            <a:avLst/>
+          </a:prstGeom>
+          <a:noFill/>
+        </p:spPr>
+        <p:txBody>
+          <a:bodyPr wrap="square" anchor="t" lIns="0" rIns="0" tIns="0" bIns="0">
+            <a:spAutoFit/>
+          </a:bodyPr>
+          <a:lstStyle/>
+          <a:p>
+            <a:pPr algn="l">
+              <a:lnSpc>
+                <a:spcPct val="110000"/>
+              </a:lnSpc>
+            </a:pPr>
+            <a:r>
+              <a:rPr sz="1200" b="0">
+                <a:solidFill>
+                  <a:srgbClr val="556B82"/>
+                </a:solidFill>
+                <a:latin typeface="Arial"/>
+              </a:rPr>
+              <a:t>evaluates all 28 programs across every contract account — no per-program prompts</a:t>
+            </a:r>
+          </a:p>
+        </p:txBody>
+      </p:sp>
+      <p:sp>
+        <p:nvSpPr>
           <p:cNvPr id="10" name="Rounded Rectangle 9"/>
           <p:cNvSpPr/>
           <p:nvPr/>
         </p:nvSpPr>
         <p:spPr>
           <a:xfrm>
-            <a:off x="4608576" y="2011680"/>
-            <a:ext cx="1737360" cy="329184"/>
-          </a:xfrm>
-          <a:prstGeom prst="roundRect">
-            <a:avLst>
-              <a:gd name="adj" fmla="val 50000"/>
-            </a:avLst>
-          </a:prstGeom>
-          <a:solidFill>
-            <a:srgbClr val="E3F0FF"/>
-          </a:solidFill>
-          <a:ln>
-            <a:noFill/>
-          </a:ln>
-          <a:effectLst/>
-        </p:spPr>
-        <p:style>
-          <a:lnRef idx="1">
-            <a:schemeClr val="accent1"/>
-          </a:lnRef>
-          <a:fillRef idx="3">
-            <a:schemeClr val="accent1"/>
-          </a:fillRef>
-          <a:effectRef idx="2">
-            <a:schemeClr val="accent1"/>
-          </a:effectRef>
-          <a:fontRef idx="minor">
-            <a:schemeClr val="lt1"/>
-          </a:fontRef>
-        </p:style>
-        <p:txBody>
-          <a:bodyPr rtlCol="0" anchor="ctr" wrap="none" lIns="18288" rIns="18288" tIns="0" bIns="0"/>
-          <a:lstStyle/>
-          <a:p>
-            <a:pPr algn="ctr"/>
-            <a:r>
-              <a:rPr sz="1200" b="1">
-                <a:solidFill>
-                  <a:srgbClr val="0057D2"/>
-                </a:solidFill>
-                <a:latin typeface="Arial"/>
-              </a:rPr>
-              <a:t>Increment 1</a:t>
-            </a:r>
-          </a:p>
-        </p:txBody>
-      </p:sp>
-      <p:sp>
-        <p:nvSpPr>
-          <p:cNvPr id="11" name="TextBox 10"/>
-          <p:cNvSpPr txBox="1"/>
-          <p:nvPr/>
-        </p:nvSpPr>
-        <p:spPr>
-          <a:xfrm>
-            <a:off x="4608576" y="2514600"/>
-            <a:ext cx="3154680" cy="1188720"/>
-          </a:xfrm>
-          <a:prstGeom prst="rect">
-            <a:avLst/>
-          </a:prstGeom>
-          <a:noFill/>
-        </p:spPr>
-        <p:txBody>
-          <a:bodyPr wrap="square" anchor="t" lIns="0" rIns="0" tIns="0" bIns="0">
-            <a:spAutoFit/>
-          </a:bodyPr>
-          <a:lstStyle/>
-          <a:p>
-            <a:pPr algn="l">
-              <a:lnSpc>
-                <a:spcPct val="115000"/>
-              </a:lnSpc>
-            </a:pPr>
-            <a:r>
-              <a:rPr sz="1150" b="0">
-                <a:solidFill>
-                  <a:srgbClr val="556B82"/>
-                </a:solidFill>
-                <a:latin typeface="Arial"/>
-              </a:rPr>
-              <a:t>Enrollment Center shell · context &amp; eligibility · first program end-to-end (CSDD) · SC V2 timeline</a:t>
-            </a:r>
-          </a:p>
-        </p:txBody>
-      </p:sp>
-      <p:sp>
-        <p:nvSpPr>
-          <p:cNvPr id="12" name="TextBox 11"/>
-          <p:cNvSpPr txBox="1"/>
-          <p:nvPr/>
-        </p:nvSpPr>
-        <p:spPr>
-          <a:xfrm>
-            <a:off x="4608576" y="3657600"/>
-            <a:ext cx="3108960" cy="320040"/>
-          </a:xfrm>
-          <a:prstGeom prst="rect">
-            <a:avLst/>
-          </a:prstGeom>
-          <a:noFill/>
-        </p:spPr>
-        <p:txBody>
-          <a:bodyPr wrap="square" anchor="t" lIns="0" rIns="0" tIns="0" bIns="0">
-            <a:spAutoFit/>
-          </a:bodyPr>
-          <a:lstStyle/>
-          <a:p>
-            <a:pPr algn="l"/>
-            <a:r>
-              <a:rPr sz="1200" b="1">
-                <a:solidFill>
-                  <a:srgbClr val="1D2D3E"/>
-                </a:solidFill>
-                <a:latin typeface="Arial"/>
-              </a:rPr>
-              <a:t>Wks 3–10</a:t>
-            </a:r>
-          </a:p>
-        </p:txBody>
-      </p:sp>
-      <p:sp>
-        <p:nvSpPr>
-          <p:cNvPr id="13" name="Right Arrow 12"/>
-          <p:cNvSpPr/>
-          <p:nvPr/>
-        </p:nvSpPr>
-        <p:spPr>
-          <a:xfrm>
-            <a:off x="8010144" y="2788920"/>
-            <a:ext cx="237744" cy="201168"/>
-          </a:xfrm>
-          <a:prstGeom prst="rightArrow">
-            <a:avLst/>
-          </a:prstGeom>
-          <a:solidFill>
-            <a:srgbClr val="556B82"/>
-          </a:solidFill>
-          <a:ln>
-            <a:noFill/>
-          </a:ln>
-          <a:effectLst/>
-        </p:spPr>
-        <p:style>
-          <a:lnRef idx="1">
-            <a:schemeClr val="accent1"/>
-          </a:lnRef>
-          <a:fillRef idx="3">
-            <a:schemeClr val="accent1"/>
-          </a:fillRef>
-          <a:effectRef idx="2">
-            <a:schemeClr val="accent1"/>
-          </a:effectRef>
-          <a:fontRef idx="minor">
-            <a:schemeClr val="lt1"/>
-          </a:fontRef>
-        </p:style>
-        <p:txBody>
-          <a:bodyPr rtlCol="0" anchor="ctr"/>
-          <a:lstStyle/>
-          <a:p>
-            <a:pPr algn="ctr"/>
-          </a:p>
-        </p:txBody>
-      </p:sp>
-      <p:sp>
-        <p:nvSpPr>
-          <p:cNvPr id="14" name="Rounded Rectangle 13"/>
-          <p:cNvSpPr/>
-          <p:nvPr/>
-        </p:nvSpPr>
-        <p:spPr>
-          <a:xfrm>
-            <a:off x="8211312" y="1783080"/>
-            <a:ext cx="3611880" cy="2286000"/>
+            <a:off x="548640" y="3108960"/>
+            <a:ext cx="5440680" cy="1280160"/>
           </a:xfrm>
           <a:prstGeom prst="roundRect">
             <a:avLst>
@@ -6151,6 +6551,910 @@
       </p:sp>
       <p:sp>
         <p:nvSpPr>
+          <p:cNvPr id="11" name="TextBox 10"/>
+          <p:cNvSpPr txBox="1"/>
+          <p:nvPr/>
+        </p:nvSpPr>
+        <p:spPr>
+          <a:xfrm>
+            <a:off x="868680" y="3310128"/>
+            <a:ext cx="1737360" cy="822960"/>
+          </a:xfrm>
+          <a:prstGeom prst="rect">
+            <a:avLst/>
+          </a:prstGeom>
+          <a:noFill/>
+        </p:spPr>
+        <p:txBody>
+          <a:bodyPr wrap="square" anchor="t" lIns="0" rIns="0" tIns="0" bIns="0">
+            <a:spAutoFit/>
+          </a:bodyPr>
+          <a:lstStyle/>
+          <a:p>
+            <a:pPr algn="l"/>
+            <a:r>
+              <a:rPr sz="3600" b="1">
+                <a:solidFill>
+                  <a:srgbClr val="0070F2"/>
+                </a:solidFill>
+                <a:latin typeface="Arial"/>
+              </a:rPr>
+              <a:t>0</a:t>
+            </a:r>
+          </a:p>
+        </p:txBody>
+      </p:sp>
+      <p:sp>
+        <p:nvSpPr>
+          <p:cNvPr id="12" name="TextBox 11"/>
+          <p:cNvSpPr txBox="1"/>
+          <p:nvPr/>
+        </p:nvSpPr>
+        <p:spPr>
+          <a:xfrm>
+            <a:off x="2697480" y="3364991"/>
+            <a:ext cx="3063240" cy="914400"/>
+          </a:xfrm>
+          <a:prstGeom prst="rect">
+            <a:avLst/>
+          </a:prstGeom>
+          <a:noFill/>
+        </p:spPr>
+        <p:txBody>
+          <a:bodyPr wrap="square" anchor="t" lIns="0" rIns="0" tIns="0" bIns="0">
+            <a:spAutoFit/>
+          </a:bodyPr>
+          <a:lstStyle/>
+          <a:p>
+            <a:pPr algn="l">
+              <a:lnSpc>
+                <a:spcPct val="110000"/>
+              </a:lnSpc>
+            </a:pPr>
+            <a:r>
+              <a:rPr sz="1200" b="0">
+                <a:solidFill>
+                  <a:srgbClr val="556B82"/>
+                </a:solidFill>
+                <a:latin typeface="Arial"/>
+              </a:rPr>
+              <a:t>modifications to the S/4HANA core — clean, upgrade-safe extension</a:t>
+            </a:r>
+          </a:p>
+        </p:txBody>
+      </p:sp>
+      <p:sp>
+        <p:nvSpPr>
+          <p:cNvPr id="13" name="Rounded Rectangle 12"/>
+          <p:cNvSpPr/>
+          <p:nvPr/>
+        </p:nvSpPr>
+        <p:spPr>
+          <a:xfrm>
+            <a:off x="6172200" y="3108960"/>
+            <a:ext cx="5440680" cy="1280160"/>
+          </a:xfrm>
+          <a:prstGeom prst="roundRect">
+            <a:avLst>
+              <a:gd name="adj" fmla="val 8000"/>
+            </a:avLst>
+          </a:prstGeom>
+          <a:solidFill>
+            <a:srgbClr val="FFFFFF"/>
+          </a:solidFill>
+          <a:ln w="9525">
+            <a:solidFill>
+              <a:srgbClr val="D9D9D9"/>
+            </a:solidFill>
+          </a:ln>
+          <a:effectLst/>
+        </p:spPr>
+        <p:style>
+          <a:lnRef idx="1">
+            <a:schemeClr val="accent1"/>
+          </a:lnRef>
+          <a:fillRef idx="3">
+            <a:schemeClr val="accent1"/>
+          </a:fillRef>
+          <a:effectRef idx="2">
+            <a:schemeClr val="accent1"/>
+          </a:effectRef>
+          <a:fontRef idx="minor">
+            <a:schemeClr val="lt1"/>
+          </a:fontRef>
+        </p:style>
+        <p:txBody>
+          <a:bodyPr rtlCol="0" anchor="ctr"/>
+          <a:lstStyle/>
+          <a:p>
+            <a:pPr algn="ctr"/>
+          </a:p>
+        </p:txBody>
+      </p:sp>
+      <p:sp>
+        <p:nvSpPr>
+          <p:cNvPr id="14" name="TextBox 13"/>
+          <p:cNvSpPr txBox="1"/>
+          <p:nvPr/>
+        </p:nvSpPr>
+        <p:spPr>
+          <a:xfrm>
+            <a:off x="6492240" y="3310128"/>
+            <a:ext cx="1737360" cy="822960"/>
+          </a:xfrm>
+          <a:prstGeom prst="rect">
+            <a:avLst/>
+          </a:prstGeom>
+          <a:noFill/>
+        </p:spPr>
+        <p:txBody>
+          <a:bodyPr wrap="square" anchor="t" lIns="0" rIns="0" tIns="0" bIns="0">
+            <a:spAutoFit/>
+          </a:bodyPr>
+          <a:lstStyle/>
+          <a:p>
+            <a:pPr algn="l"/>
+            <a:r>
+              <a:rPr sz="3600" b="1">
+                <a:solidFill>
+                  <a:srgbClr val="0070F2"/>
+                </a:solidFill>
+                <a:latin typeface="Arial"/>
+              </a:rPr>
+              <a:t>100 %</a:t>
+            </a:r>
+          </a:p>
+        </p:txBody>
+      </p:sp>
+      <p:sp>
+        <p:nvSpPr>
+          <p:cNvPr id="15" name="TextBox 14"/>
+          <p:cNvSpPr txBox="1"/>
+          <p:nvPr/>
+        </p:nvSpPr>
+        <p:spPr>
+          <a:xfrm>
+            <a:off x="8321040" y="3364991"/>
+            <a:ext cx="3063240" cy="914400"/>
+          </a:xfrm>
+          <a:prstGeom prst="rect">
+            <a:avLst/>
+          </a:prstGeom>
+          <a:noFill/>
+        </p:spPr>
+        <p:txBody>
+          <a:bodyPr wrap="square" anchor="t" lIns="0" rIns="0" tIns="0" bIns="0">
+            <a:spAutoFit/>
+          </a:bodyPr>
+          <a:lstStyle/>
+          <a:p>
+            <a:pPr algn="l">
+              <a:lnSpc>
+                <a:spcPct val="110000"/>
+              </a:lnSpc>
+            </a:pPr>
+            <a:r>
+              <a:rPr sz="1200" b="0">
+                <a:solidFill>
+                  <a:srgbClr val="556B82"/>
+                </a:solidFill>
+                <a:latin typeface="Arial"/>
+              </a:rPr>
+              <a:t>of enrollments audited with eligibility basis, consent and actor</a:t>
+            </a:r>
+          </a:p>
+        </p:txBody>
+      </p:sp>
+      <p:sp>
+        <p:nvSpPr>
+          <p:cNvPr id="16" name="Rounded Rectangle 15"/>
+          <p:cNvSpPr/>
+          <p:nvPr/>
+        </p:nvSpPr>
+        <p:spPr>
+          <a:xfrm>
+            <a:off x="548640" y="4617720"/>
+            <a:ext cx="11064240" cy="1554480"/>
+          </a:xfrm>
+          <a:prstGeom prst="roundRect">
+            <a:avLst>
+              <a:gd name="adj" fmla="val 8000"/>
+            </a:avLst>
+          </a:prstGeom>
+          <a:solidFill>
+            <a:srgbClr val="12233F"/>
+          </a:solidFill>
+          <a:ln w="9525">
+            <a:solidFill>
+              <a:srgbClr val="12233F"/>
+            </a:solidFill>
+          </a:ln>
+          <a:effectLst/>
+        </p:spPr>
+        <p:style>
+          <a:lnRef idx="1">
+            <a:schemeClr val="accent1"/>
+          </a:lnRef>
+          <a:fillRef idx="3">
+            <a:schemeClr val="accent1"/>
+          </a:fillRef>
+          <a:effectRef idx="2">
+            <a:schemeClr val="accent1"/>
+          </a:effectRef>
+          <a:fontRef idx="minor">
+            <a:schemeClr val="lt1"/>
+          </a:fontRef>
+        </p:style>
+        <p:txBody>
+          <a:bodyPr rtlCol="0" anchor="ctr"/>
+          <a:lstStyle/>
+          <a:p>
+            <a:pPr algn="ctr"/>
+          </a:p>
+        </p:txBody>
+      </p:sp>
+      <p:sp>
+        <p:nvSpPr>
+          <p:cNvPr id="17" name="TextBox 16"/>
+          <p:cNvSpPr txBox="1"/>
+          <p:nvPr/>
+        </p:nvSpPr>
+        <p:spPr>
+          <a:xfrm>
+            <a:off x="822960" y="4828032"/>
+            <a:ext cx="10515600" cy="365760"/>
+          </a:xfrm>
+          <a:prstGeom prst="rect">
+            <a:avLst/>
+          </a:prstGeom>
+          <a:noFill/>
+        </p:spPr>
+        <p:txBody>
+          <a:bodyPr wrap="square" anchor="t" lIns="0" rIns="0" tIns="0" bIns="0">
+            <a:spAutoFit/>
+          </a:bodyPr>
+          <a:lstStyle/>
+          <a:p>
+            <a:pPr algn="l"/>
+            <a:r>
+              <a:rPr sz="1400" b="1">
+                <a:solidFill>
+                  <a:srgbClr val="FFB300"/>
+                </a:solidFill>
+                <a:latin typeface="Arial"/>
+              </a:rPr>
+              <a:t>And the strategic payoff</a:t>
+            </a:r>
+          </a:p>
+        </p:txBody>
+      </p:sp>
+      <p:sp>
+        <p:nvSpPr>
+          <p:cNvPr id="18" name="TextBox 17"/>
+          <p:cNvSpPr txBox="1"/>
+          <p:nvPr/>
+        </p:nvSpPr>
+        <p:spPr>
+          <a:xfrm>
+            <a:off x="822960" y="5257800"/>
+            <a:ext cx="10515600" cy="822960"/>
+          </a:xfrm>
+          <a:prstGeom prst="rect">
+            <a:avLst/>
+          </a:prstGeom>
+          <a:noFill/>
+        </p:spPr>
+        <p:txBody>
+          <a:bodyPr wrap="square" anchor="t" lIns="0" rIns="0" tIns="0" bIns="0">
+            <a:spAutoFit/>
+          </a:bodyPr>
+          <a:lstStyle/>
+          <a:p>
+            <a:pPr algn="l">
+              <a:lnSpc>
+                <a:spcPct val="115000"/>
+              </a:lnSpc>
+            </a:pPr>
+            <a:r>
+              <a:rPr sz="1300" b="0">
+                <a:solidFill>
+                  <a:srgbClr val="CADCFC"/>
+                </a:solidFill>
+                <a:latin typeface="Arial"/>
+              </a:rPr>
+              <a:t>The same eligibility and enrollment services power your next channels — customer self-service, IVR, and the DER platform — without rebuilding. Agents launch it first; the architecture already serves all of them.</a:t>
+            </a:r>
+          </a:p>
+        </p:txBody>
+      </p:sp>
+    </p:spTree>
+  </p:cSld>
+  <p:clrMapOvr>
+    <a:masterClrMapping/>
+  </p:clrMapOvr>
+</p:sld>
+</file>
+
+<file path=ppt/slides/slide14.xml><?xml version="1.0" encoding="utf-8"?>
+<p:sld xmlns:a="http://schemas.openxmlformats.org/drawingml/2006/main" xmlns:p="http://schemas.openxmlformats.org/presentationml/2006/main" xmlns:r="http://schemas.openxmlformats.org/officeDocument/2006/relationships">
+  <p:cSld>
+    <p:bg>
+      <p:bgPr>
+        <a:solidFill>
+          <a:srgbClr val="FFFFFF"/>
+        </a:solidFill>
+        <a:effectLst/>
+      </p:bgPr>
+    </p:bg>
+    <p:spTree>
+      <p:nvGrpSpPr>
+        <p:cNvPr id="1" name=""/>
+        <p:cNvGrpSpPr/>
+        <p:nvPr/>
+      </p:nvGrpSpPr>
+      <p:grpSpPr/>
+      <p:sp>
+        <p:nvSpPr>
+          <p:cNvPr id="2" name="TextBox 1"/>
+          <p:cNvSpPr txBox="1"/>
+          <p:nvPr/>
+        </p:nvSpPr>
+        <p:spPr>
+          <a:xfrm>
+            <a:off x="548640" y="347472"/>
+            <a:ext cx="11064240" cy="685800"/>
+          </a:xfrm>
+          <a:prstGeom prst="rect">
+            <a:avLst/>
+          </a:prstGeom>
+          <a:noFill/>
+        </p:spPr>
+        <p:txBody>
+          <a:bodyPr wrap="square" anchor="t" lIns="0" rIns="0" tIns="0" bIns="0">
+            <a:spAutoFit/>
+          </a:bodyPr>
+          <a:lstStyle/>
+          <a:p>
+            <a:pPr algn="l"/>
+            <a:r>
+              <a:rPr sz="3000" b="1">
+                <a:solidFill>
+                  <a:srgbClr val="1D2D3E"/>
+                </a:solidFill>
+                <a:latin typeface="Arial"/>
+              </a:rPr>
+              <a:t>Delivery roadmap</a:t>
+            </a:r>
+          </a:p>
+        </p:txBody>
+      </p:sp>
+      <p:sp>
+        <p:nvSpPr>
+          <p:cNvPr id="3" name="TextBox 2"/>
+          <p:cNvSpPr txBox="1"/>
+          <p:nvPr/>
+        </p:nvSpPr>
+        <p:spPr>
+          <a:xfrm>
+            <a:off x="548640" y="932688"/>
+            <a:ext cx="11064240" cy="365760"/>
+          </a:xfrm>
+          <a:prstGeom prst="rect">
+            <a:avLst/>
+          </a:prstGeom>
+          <a:noFill/>
+        </p:spPr>
+        <p:txBody>
+          <a:bodyPr wrap="square" anchor="t" lIns="0" rIns="0" tIns="0" bIns="0">
+            <a:spAutoFit/>
+          </a:bodyPr>
+          <a:lstStyle/>
+          <a:p>
+            <a:pPr algn="l"/>
+            <a:r>
+              <a:rPr sz="1400" b="0">
+                <a:solidFill>
+                  <a:srgbClr val="556B82"/>
+                </a:solidFill>
+                <a:latin typeface="Arial"/>
+              </a:rPr>
+              <a:t>Design is complete and reviewed — build starts with a two-week proof</a:t>
+            </a:r>
+          </a:p>
+        </p:txBody>
+      </p:sp>
+      <p:sp>
+        <p:nvSpPr>
+          <p:cNvPr id="4" name="Rounded Rectangle 3"/>
+          <p:cNvSpPr/>
+          <p:nvPr/>
+        </p:nvSpPr>
+        <p:spPr>
+          <a:xfrm>
+            <a:off x="548640" y="1783080"/>
+            <a:ext cx="3611880" cy="2286000"/>
+          </a:xfrm>
+          <a:prstGeom prst="roundRect">
+            <a:avLst>
+              <a:gd name="adj" fmla="val 8000"/>
+            </a:avLst>
+          </a:prstGeom>
+          <a:solidFill>
+            <a:srgbClr val="FFFFFF"/>
+          </a:solidFill>
+          <a:ln w="9525">
+            <a:solidFill>
+              <a:srgbClr val="D9D9D9"/>
+            </a:solidFill>
+          </a:ln>
+          <a:effectLst/>
+        </p:spPr>
+        <p:style>
+          <a:lnRef idx="1">
+            <a:schemeClr val="accent1"/>
+          </a:lnRef>
+          <a:fillRef idx="3">
+            <a:schemeClr val="accent1"/>
+          </a:fillRef>
+          <a:effectRef idx="2">
+            <a:schemeClr val="accent1"/>
+          </a:effectRef>
+          <a:fontRef idx="minor">
+            <a:schemeClr val="lt1"/>
+          </a:fontRef>
+        </p:style>
+        <p:txBody>
+          <a:bodyPr rtlCol="0" anchor="ctr"/>
+          <a:lstStyle/>
+          <a:p>
+            <a:pPr algn="ctr"/>
+          </a:p>
+        </p:txBody>
+      </p:sp>
+      <p:sp>
+        <p:nvSpPr>
+          <p:cNvPr id="5" name="Rounded Rectangle 4"/>
+          <p:cNvSpPr/>
+          <p:nvPr/>
+        </p:nvSpPr>
+        <p:spPr>
+          <a:xfrm>
+            <a:off x="777240" y="2011680"/>
+            <a:ext cx="1737360" cy="329184"/>
+          </a:xfrm>
+          <a:prstGeom prst="roundRect">
+            <a:avLst>
+              <a:gd name="adj" fmla="val 50000"/>
+            </a:avLst>
+          </a:prstGeom>
+          <a:solidFill>
+            <a:srgbClr val="F5F6F7"/>
+          </a:solidFill>
+          <a:ln>
+            <a:noFill/>
+          </a:ln>
+          <a:effectLst/>
+        </p:spPr>
+        <p:style>
+          <a:lnRef idx="1">
+            <a:schemeClr val="accent1"/>
+          </a:lnRef>
+          <a:fillRef idx="3">
+            <a:schemeClr val="accent1"/>
+          </a:fillRef>
+          <a:effectRef idx="2">
+            <a:schemeClr val="accent1"/>
+          </a:effectRef>
+          <a:fontRef idx="minor">
+            <a:schemeClr val="lt1"/>
+          </a:fontRef>
+        </p:style>
+        <p:txBody>
+          <a:bodyPr rtlCol="0" anchor="ctr" wrap="none" lIns="18288" rIns="18288" tIns="0" bIns="0"/>
+          <a:lstStyle/>
+          <a:p>
+            <a:pPr algn="ctr"/>
+            <a:r>
+              <a:rPr sz="1200" b="1">
+                <a:solidFill>
+                  <a:srgbClr val="556B82"/>
+                </a:solidFill>
+                <a:latin typeface="Arial"/>
+              </a:rPr>
+              <a:t>Spike — 2 weeks</a:t>
+            </a:r>
+          </a:p>
+        </p:txBody>
+      </p:sp>
+      <p:sp>
+        <p:nvSpPr>
+          <p:cNvPr id="6" name="TextBox 5"/>
+          <p:cNvSpPr txBox="1"/>
+          <p:nvPr/>
+        </p:nvSpPr>
+        <p:spPr>
+          <a:xfrm>
+            <a:off x="777240" y="2514600"/>
+            <a:ext cx="3154680" cy="1188720"/>
+          </a:xfrm>
+          <a:prstGeom prst="rect">
+            <a:avLst/>
+          </a:prstGeom>
+          <a:noFill/>
+        </p:spPr>
+        <p:txBody>
+          <a:bodyPr wrap="square" anchor="t" lIns="0" rIns="0" tIns="0" bIns="0">
+            <a:spAutoFit/>
+          </a:bodyPr>
+          <a:lstStyle/>
+          <a:p>
+            <a:pPr algn="l">
+              <a:lnSpc>
+                <a:spcPct val="115000"/>
+              </a:lnSpc>
+            </a:pPr>
+            <a:r>
+              <a:rPr sz="1150" b="0">
+                <a:solidFill>
+                  <a:srgbClr val="556B82"/>
+                </a:solidFill>
+                <a:latin typeface="Arial"/>
+              </a:rPr>
+              <a:t>Prove SC V2 embedding (both access points) and principal propagation to S/4HANA</a:t>
+            </a:r>
+          </a:p>
+        </p:txBody>
+      </p:sp>
+      <p:sp>
+        <p:nvSpPr>
+          <p:cNvPr id="7" name="TextBox 6"/>
+          <p:cNvSpPr txBox="1"/>
+          <p:nvPr/>
+        </p:nvSpPr>
+        <p:spPr>
+          <a:xfrm>
+            <a:off x="777240" y="3657600"/>
+            <a:ext cx="3108960" cy="320040"/>
+          </a:xfrm>
+          <a:prstGeom prst="rect">
+            <a:avLst/>
+          </a:prstGeom>
+          <a:noFill/>
+        </p:spPr>
+        <p:txBody>
+          <a:bodyPr wrap="square" anchor="t" lIns="0" rIns="0" tIns="0" bIns="0">
+            <a:spAutoFit/>
+          </a:bodyPr>
+          <a:lstStyle/>
+          <a:p>
+            <a:pPr algn="l"/>
+            <a:r>
+              <a:rPr sz="1200" b="1">
+                <a:solidFill>
+                  <a:srgbClr val="1D2D3E"/>
+                </a:solidFill>
+                <a:latin typeface="Arial"/>
+              </a:rPr>
+              <a:t>Now</a:t>
+            </a:r>
+          </a:p>
+        </p:txBody>
+      </p:sp>
+      <p:sp>
+        <p:nvSpPr>
+          <p:cNvPr id="8" name="Right Arrow 7"/>
+          <p:cNvSpPr/>
+          <p:nvPr/>
+        </p:nvSpPr>
+        <p:spPr>
+          <a:xfrm>
+            <a:off x="4178808" y="2788920"/>
+            <a:ext cx="237744" cy="201168"/>
+          </a:xfrm>
+          <a:prstGeom prst="rightArrow">
+            <a:avLst/>
+          </a:prstGeom>
+          <a:solidFill>
+            <a:srgbClr val="556B82"/>
+          </a:solidFill>
+          <a:ln>
+            <a:noFill/>
+          </a:ln>
+          <a:effectLst/>
+        </p:spPr>
+        <p:style>
+          <a:lnRef idx="1">
+            <a:schemeClr val="accent1"/>
+          </a:lnRef>
+          <a:fillRef idx="3">
+            <a:schemeClr val="accent1"/>
+          </a:fillRef>
+          <a:effectRef idx="2">
+            <a:schemeClr val="accent1"/>
+          </a:effectRef>
+          <a:fontRef idx="minor">
+            <a:schemeClr val="lt1"/>
+          </a:fontRef>
+        </p:style>
+        <p:txBody>
+          <a:bodyPr rtlCol="0" anchor="ctr"/>
+          <a:lstStyle/>
+          <a:p>
+            <a:pPr algn="ctr"/>
+          </a:p>
+        </p:txBody>
+      </p:sp>
+      <p:sp>
+        <p:nvSpPr>
+          <p:cNvPr id="9" name="Rounded Rectangle 8"/>
+          <p:cNvSpPr/>
+          <p:nvPr/>
+        </p:nvSpPr>
+        <p:spPr>
+          <a:xfrm>
+            <a:off x="4379976" y="1783080"/>
+            <a:ext cx="3611880" cy="2286000"/>
+          </a:xfrm>
+          <a:prstGeom prst="roundRect">
+            <a:avLst>
+              <a:gd name="adj" fmla="val 8000"/>
+            </a:avLst>
+          </a:prstGeom>
+          <a:solidFill>
+            <a:srgbClr val="FFFFFF"/>
+          </a:solidFill>
+          <a:ln w="9525">
+            <a:solidFill>
+              <a:srgbClr val="D9D9D9"/>
+            </a:solidFill>
+          </a:ln>
+          <a:effectLst/>
+        </p:spPr>
+        <p:style>
+          <a:lnRef idx="1">
+            <a:schemeClr val="accent1"/>
+          </a:lnRef>
+          <a:fillRef idx="3">
+            <a:schemeClr val="accent1"/>
+          </a:fillRef>
+          <a:effectRef idx="2">
+            <a:schemeClr val="accent1"/>
+          </a:effectRef>
+          <a:fontRef idx="minor">
+            <a:schemeClr val="lt1"/>
+          </a:fontRef>
+        </p:style>
+        <p:txBody>
+          <a:bodyPr rtlCol="0" anchor="ctr"/>
+          <a:lstStyle/>
+          <a:p>
+            <a:pPr algn="ctr"/>
+          </a:p>
+        </p:txBody>
+      </p:sp>
+      <p:sp>
+        <p:nvSpPr>
+          <p:cNvPr id="10" name="Rounded Rectangle 9"/>
+          <p:cNvSpPr/>
+          <p:nvPr/>
+        </p:nvSpPr>
+        <p:spPr>
+          <a:xfrm>
+            <a:off x="4608576" y="2011680"/>
+            <a:ext cx="1737360" cy="329184"/>
+          </a:xfrm>
+          <a:prstGeom prst="roundRect">
+            <a:avLst>
+              <a:gd name="adj" fmla="val 50000"/>
+            </a:avLst>
+          </a:prstGeom>
+          <a:solidFill>
+            <a:srgbClr val="E3F0FF"/>
+          </a:solidFill>
+          <a:ln>
+            <a:noFill/>
+          </a:ln>
+          <a:effectLst/>
+        </p:spPr>
+        <p:style>
+          <a:lnRef idx="1">
+            <a:schemeClr val="accent1"/>
+          </a:lnRef>
+          <a:fillRef idx="3">
+            <a:schemeClr val="accent1"/>
+          </a:fillRef>
+          <a:effectRef idx="2">
+            <a:schemeClr val="accent1"/>
+          </a:effectRef>
+          <a:fontRef idx="minor">
+            <a:schemeClr val="lt1"/>
+          </a:fontRef>
+        </p:style>
+        <p:txBody>
+          <a:bodyPr rtlCol="0" anchor="ctr" wrap="none" lIns="18288" rIns="18288" tIns="0" bIns="0"/>
+          <a:lstStyle/>
+          <a:p>
+            <a:pPr algn="ctr"/>
+            <a:r>
+              <a:rPr sz="1200" b="1">
+                <a:solidFill>
+                  <a:srgbClr val="0057D2"/>
+                </a:solidFill>
+                <a:latin typeface="Arial"/>
+              </a:rPr>
+              <a:t>Increment 1</a:t>
+            </a:r>
+          </a:p>
+        </p:txBody>
+      </p:sp>
+      <p:sp>
+        <p:nvSpPr>
+          <p:cNvPr id="11" name="TextBox 10"/>
+          <p:cNvSpPr txBox="1"/>
+          <p:nvPr/>
+        </p:nvSpPr>
+        <p:spPr>
+          <a:xfrm>
+            <a:off x="4608576" y="2514600"/>
+            <a:ext cx="3154680" cy="1188720"/>
+          </a:xfrm>
+          <a:prstGeom prst="rect">
+            <a:avLst/>
+          </a:prstGeom>
+          <a:noFill/>
+        </p:spPr>
+        <p:txBody>
+          <a:bodyPr wrap="square" anchor="t" lIns="0" rIns="0" tIns="0" bIns="0">
+            <a:spAutoFit/>
+          </a:bodyPr>
+          <a:lstStyle/>
+          <a:p>
+            <a:pPr algn="l">
+              <a:lnSpc>
+                <a:spcPct val="115000"/>
+              </a:lnSpc>
+            </a:pPr>
+            <a:r>
+              <a:rPr sz="1150" b="0">
+                <a:solidFill>
+                  <a:srgbClr val="556B82"/>
+                </a:solidFill>
+                <a:latin typeface="Arial"/>
+              </a:rPr>
+              <a:t>Enrollment Center shell · context &amp; eligibility · first program end-to-end (CSDD) · SC V2 timeline</a:t>
+            </a:r>
+          </a:p>
+        </p:txBody>
+      </p:sp>
+      <p:sp>
+        <p:nvSpPr>
+          <p:cNvPr id="12" name="TextBox 11"/>
+          <p:cNvSpPr txBox="1"/>
+          <p:nvPr/>
+        </p:nvSpPr>
+        <p:spPr>
+          <a:xfrm>
+            <a:off x="4608576" y="3657600"/>
+            <a:ext cx="3108960" cy="320040"/>
+          </a:xfrm>
+          <a:prstGeom prst="rect">
+            <a:avLst/>
+          </a:prstGeom>
+          <a:noFill/>
+        </p:spPr>
+        <p:txBody>
+          <a:bodyPr wrap="square" anchor="t" lIns="0" rIns="0" tIns="0" bIns="0">
+            <a:spAutoFit/>
+          </a:bodyPr>
+          <a:lstStyle/>
+          <a:p>
+            <a:pPr algn="l"/>
+            <a:r>
+              <a:rPr sz="1200" b="1">
+                <a:solidFill>
+                  <a:srgbClr val="1D2D3E"/>
+                </a:solidFill>
+                <a:latin typeface="Arial"/>
+              </a:rPr>
+              <a:t>Wks 3–10</a:t>
+            </a:r>
+          </a:p>
+        </p:txBody>
+      </p:sp>
+      <p:sp>
+        <p:nvSpPr>
+          <p:cNvPr id="13" name="Right Arrow 12"/>
+          <p:cNvSpPr/>
+          <p:nvPr/>
+        </p:nvSpPr>
+        <p:spPr>
+          <a:xfrm>
+            <a:off x="8010144" y="2788920"/>
+            <a:ext cx="237744" cy="201168"/>
+          </a:xfrm>
+          <a:prstGeom prst="rightArrow">
+            <a:avLst/>
+          </a:prstGeom>
+          <a:solidFill>
+            <a:srgbClr val="556B82"/>
+          </a:solidFill>
+          <a:ln>
+            <a:noFill/>
+          </a:ln>
+          <a:effectLst/>
+        </p:spPr>
+        <p:style>
+          <a:lnRef idx="1">
+            <a:schemeClr val="accent1"/>
+          </a:lnRef>
+          <a:fillRef idx="3">
+            <a:schemeClr val="accent1"/>
+          </a:fillRef>
+          <a:effectRef idx="2">
+            <a:schemeClr val="accent1"/>
+          </a:effectRef>
+          <a:fontRef idx="minor">
+            <a:schemeClr val="lt1"/>
+          </a:fontRef>
+        </p:style>
+        <p:txBody>
+          <a:bodyPr rtlCol="0" anchor="ctr"/>
+          <a:lstStyle/>
+          <a:p>
+            <a:pPr algn="ctr"/>
+          </a:p>
+        </p:txBody>
+      </p:sp>
+      <p:sp>
+        <p:nvSpPr>
+          <p:cNvPr id="14" name="Rounded Rectangle 13"/>
+          <p:cNvSpPr/>
+          <p:nvPr/>
+        </p:nvSpPr>
+        <p:spPr>
+          <a:xfrm>
+            <a:off x="8211312" y="1783080"/>
+            <a:ext cx="3611880" cy="2286000"/>
+          </a:xfrm>
+          <a:prstGeom prst="roundRect">
+            <a:avLst>
+              <a:gd name="adj" fmla="val 8000"/>
+            </a:avLst>
+          </a:prstGeom>
+          <a:solidFill>
+            <a:srgbClr val="FFFFFF"/>
+          </a:solidFill>
+          <a:ln w="9525">
+            <a:solidFill>
+              <a:srgbClr val="D9D9D9"/>
+            </a:solidFill>
+          </a:ln>
+          <a:effectLst/>
+        </p:spPr>
+        <p:style>
+          <a:lnRef idx="1">
+            <a:schemeClr val="accent1"/>
+          </a:lnRef>
+          <a:fillRef idx="3">
+            <a:schemeClr val="accent1"/>
+          </a:fillRef>
+          <a:effectRef idx="2">
+            <a:schemeClr val="accent1"/>
+          </a:effectRef>
+          <a:fontRef idx="minor">
+            <a:schemeClr val="lt1"/>
+          </a:fontRef>
+        </p:style>
+        <p:txBody>
+          <a:bodyPr rtlCol="0" anchor="ctr"/>
+          <a:lstStyle/>
+          <a:p>
+            <a:pPr algn="ctr"/>
+          </a:p>
+        </p:txBody>
+      </p:sp>
+      <p:sp>
+        <p:nvSpPr>
           <p:cNvPr id="15" name="Rounded Rectangle 14"/>
           <p:cNvSpPr/>
           <p:nvPr/>
@@ -6408,7 +7712,7 @@
 </p:sld>
 </file>
 
-<file path=ppt/slides/slide14.xml><?xml version="1.0" encoding="utf-8"?>
+<file path=ppt/slides/slide15.xml><?xml version="1.0" encoding="utf-8"?>
 <p:sld xmlns:a="http://schemas.openxmlformats.org/drawingml/2006/main" xmlns:p="http://schemas.openxmlformats.org/presentationml/2006/main" xmlns:r="http://schemas.openxmlformats.org/officeDocument/2006/relationships">
   <p:cSld>
     <p:bg>
@@ -6790,1317 +8094,13 @@
           <a:p>
             <a:pPr algn="l"/>
             <a:r>
-              <a:rPr sz="1200" b="0">
+              <a:rPr sz="1100" b="0">
                 <a:solidFill>
                   <a:srgbClr val="CADCFC"/>
                 </a:solidFill>
                 <a:latin typeface="Arial"/>
               </a:rPr>
-              <a:t>Demo: demo.svgbs.com   ·   Full design set available for review</a:t>
-            </a:r>
-          </a:p>
-        </p:txBody>
-      </p:sp>
-    </p:spTree>
-  </p:cSld>
-  <p:clrMapOvr>
-    <a:masterClrMapping/>
-  </p:clrMapOvr>
-</p:sld>
-</file>
-
-<file path=ppt/slides/slide15.xml><?xml version="1.0" encoding="utf-8"?>
-<p:sld xmlns:a="http://schemas.openxmlformats.org/drawingml/2006/main" xmlns:p="http://schemas.openxmlformats.org/presentationml/2006/main" xmlns:r="http://schemas.openxmlformats.org/officeDocument/2006/relationships">
-  <p:cSld>
-    <p:bg>
-      <p:bgPr>
-        <a:solidFill>
-          <a:srgbClr val="FFFFFF"/>
-        </a:solidFill>
-        <a:effectLst/>
-      </p:bgPr>
-    </p:bg>
-    <p:spTree>
-      <p:nvGrpSpPr>
-        <p:cNvPr id="1" name=""/>
-        <p:cNvGrpSpPr/>
-        <p:nvPr/>
-      </p:nvGrpSpPr>
-      <p:grpSpPr/>
-      <p:sp>
-        <p:nvSpPr>
-          <p:cNvPr id="2" name="TextBox 1"/>
-          <p:cNvSpPr txBox="1"/>
-          <p:nvPr/>
-        </p:nvSpPr>
-        <p:spPr>
-          <a:xfrm>
-            <a:off x="548640" y="347472"/>
-            <a:ext cx="11064240" cy="685800"/>
-          </a:xfrm>
-          <a:prstGeom prst="rect">
-            <a:avLst/>
-          </a:prstGeom>
-          <a:noFill/>
-        </p:spPr>
-        <p:txBody>
-          <a:bodyPr wrap="square" lIns="0" rIns="0" tIns="0" bIns="0">
-            <a:spAutoFit/>
-          </a:bodyPr>
-          <a:lstStyle/>
-          <a:p>
-            <a:pPr algn="l"/>
-            <a:r>
-              <a:rPr sz="3000" b="1">
-                <a:solidFill>
-                  <a:srgbClr val="1D2D3E"/>
-                </a:solidFill>
-                <a:latin typeface="Arial"/>
-              </a:rPr>
-              <a:t>How the AI score is calculated</a:t>
-            </a:r>
-          </a:p>
-        </p:txBody>
-      </p:sp>
-      <p:sp>
-        <p:nvSpPr>
-          <p:cNvPr id="3" name="TextBox 2"/>
-          <p:cNvSpPr txBox="1"/>
-          <p:nvPr/>
-        </p:nvSpPr>
-        <p:spPr>
-          <a:xfrm>
-            <a:off x="548640" y="932688"/>
-            <a:ext cx="11064240" cy="365760"/>
-          </a:xfrm>
-          <a:prstGeom prst="rect">
-            <a:avLst/>
-          </a:prstGeom>
-          <a:noFill/>
-        </p:spPr>
-        <p:txBody>
-          <a:bodyPr wrap="square" lIns="0" rIns="0" tIns="0" bIns="0">
-            <a:spAutoFit/>
-          </a:bodyPr>
-          <a:lstStyle/>
-          <a:p>
-            <a:pPr algn="l"/>
-            <a:r>
-              <a:rPr sz="1400" b="0">
-                <a:solidFill>
-                  <a:srgbClr val="556B82"/>
-                </a:solidFill>
-                <a:latin typeface="Arial"/>
-              </a:rPr>
-              <a:t>The percentage is a calibrated enrollment probability — the likelihood this customer enrolls if the agent offers the program</a:t>
-            </a:r>
-          </a:p>
-        </p:txBody>
-      </p:sp>
-      <p:sp>
-        <p:nvSpPr>
-          <p:cNvPr id="4" name="Rounded Rectangle 3"/>
-          <p:cNvSpPr/>
-          <p:nvPr/>
-        </p:nvSpPr>
-        <p:spPr>
-          <a:xfrm>
-            <a:off x="548640" y="1600200"/>
-            <a:ext cx="3520440" cy="1481328"/>
-          </a:xfrm>
-          <a:prstGeom prst="roundRect">
-            <a:avLst>
-              <a:gd name="adj" fmla="val 8000"/>
-            </a:avLst>
-          </a:prstGeom>
-          <a:solidFill>
-            <a:srgbClr val="F5F6F7"/>
-          </a:solidFill>
-          <a:ln w="9525">
-            <a:solidFill>
-              <a:srgbClr val="D9D9D9"/>
-            </a:solidFill>
-          </a:ln>
-          <a:effectLst/>
-        </p:spPr>
-        <p:style>
-          <a:lnRef idx="1">
-            <a:schemeClr val="accent1"/>
-          </a:lnRef>
-          <a:fillRef idx="3">
-            <a:schemeClr val="accent1"/>
-          </a:fillRef>
-          <a:effectRef idx="2">
-            <a:schemeClr val="accent1"/>
-          </a:effectRef>
-          <a:fontRef idx="minor">
-            <a:schemeClr val="lt1"/>
-          </a:fontRef>
-        </p:style>
-        <p:txBody>
-          <a:bodyPr rtlCol="0" anchor="ctr"/>
-          <a:lstStyle/>
-          <a:p>
-            <a:pPr algn="ctr"/>
-          </a:p>
-        </p:txBody>
-      </p:sp>
-      <p:sp>
-        <p:nvSpPr>
-          <p:cNvPr id="5" name="Oval 4"/>
-          <p:cNvSpPr/>
-          <p:nvPr/>
-        </p:nvSpPr>
-        <p:spPr>
-          <a:xfrm>
-            <a:off x="749808" y="1783080"/>
-            <a:ext cx="384048" cy="384048"/>
-          </a:xfrm>
-          <a:prstGeom prst="ellipse">
-            <a:avLst/>
-          </a:prstGeom>
-          <a:solidFill>
-            <a:srgbClr val="0070F2"/>
-          </a:solidFill>
-          <a:ln>
-            <a:noFill/>
-          </a:ln>
-          <a:effectLst/>
-        </p:spPr>
-        <p:style>
-          <a:lnRef idx="1">
-            <a:schemeClr val="accent1"/>
-          </a:lnRef>
-          <a:fillRef idx="3">
-            <a:schemeClr val="accent1"/>
-          </a:fillRef>
-          <a:effectRef idx="2">
-            <a:schemeClr val="accent1"/>
-          </a:effectRef>
-          <a:fontRef idx="minor">
-            <a:schemeClr val="lt1"/>
-          </a:fontRef>
-        </p:style>
-        <p:txBody>
-          <a:bodyPr rtlCol="0" anchor="ctr" lIns="0" rIns="0" tIns="0" bIns="0"/>
-          <a:lstStyle/>
-          <a:p>
-            <a:pPr algn="ctr"/>
-            <a:r>
-              <a:rPr sz="1500" b="1">
-                <a:solidFill>
-                  <a:srgbClr val="FFFFFF"/>
-                </a:solidFill>
-                <a:latin typeface="Arial"/>
-              </a:rPr>
-              <a:t>1</a:t>
-            </a:r>
-          </a:p>
-        </p:txBody>
-      </p:sp>
-      <p:sp>
-        <p:nvSpPr>
-          <p:cNvPr id="6" name="TextBox 5"/>
-          <p:cNvSpPr txBox="1"/>
-          <p:nvPr/>
-        </p:nvSpPr>
-        <p:spPr>
-          <a:xfrm>
-            <a:off x="1261872" y="1819656"/>
-            <a:ext cx="2697480" cy="320040"/>
-          </a:xfrm>
-          <a:prstGeom prst="rect">
-            <a:avLst/>
-          </a:prstGeom>
-          <a:noFill/>
-        </p:spPr>
-        <p:txBody>
-          <a:bodyPr wrap="square" lIns="0" rIns="0" tIns="0" bIns="0">
-            <a:spAutoFit/>
-          </a:bodyPr>
-          <a:lstStyle/>
-          <a:p>
-            <a:pPr algn="l"/>
-            <a:r>
-              <a:rPr sz="1400" b="1">
-                <a:solidFill>
-                  <a:srgbClr val="1D2D3E"/>
-                </a:solidFill>
-                <a:latin typeface="Arial"/>
-              </a:rPr>
-              <a:t>Training data</a:t>
-            </a:r>
-          </a:p>
-        </p:txBody>
-      </p:sp>
-      <p:sp>
-        <p:nvSpPr>
-          <p:cNvPr id="7" name="TextBox 6"/>
-          <p:cNvSpPr txBox="1"/>
-          <p:nvPr/>
-        </p:nvSpPr>
-        <p:spPr>
-          <a:xfrm>
-            <a:off x="804672" y="2203704"/>
-            <a:ext cx="3063240" cy="822960"/>
-          </a:xfrm>
-          <a:prstGeom prst="rect">
-            <a:avLst/>
-          </a:prstGeom>
-          <a:noFill/>
-        </p:spPr>
-        <p:txBody>
-          <a:bodyPr wrap="square" lIns="0" rIns="0" tIns="0" bIns="0">
-            <a:spAutoFit/>
-          </a:bodyPr>
-          <a:lstStyle/>
-          <a:p>
-            <a:pPr algn="l">
-              <a:lnSpc>
-                <a:spcPct val="110000"/>
-              </a:lnSpc>
-            </a:pPr>
-            <a:r>
-              <a:rPr sz="1050" b="0">
-                <a:solidFill>
-                  <a:srgbClr val="556B82"/>
-                </a:solidFill>
-                <a:latin typeface="Arial"/>
-              </a:rPr>
-              <a:t>The system labels its own examples: every offer shown, plus the outcome — enrolled within 30 days or not</a:t>
-            </a:r>
-          </a:p>
-        </p:txBody>
-      </p:sp>
-      <p:sp>
-        <p:nvSpPr>
-          <p:cNvPr id="8" name="Rounded Rectangle 7"/>
-          <p:cNvSpPr/>
-          <p:nvPr/>
-        </p:nvSpPr>
-        <p:spPr>
-          <a:xfrm>
-            <a:off x="4251960" y="1600200"/>
-            <a:ext cx="3520440" cy="1481328"/>
-          </a:xfrm>
-          <a:prstGeom prst="roundRect">
-            <a:avLst>
-              <a:gd name="adj" fmla="val 8000"/>
-            </a:avLst>
-          </a:prstGeom>
-          <a:solidFill>
-            <a:srgbClr val="F5F6F7"/>
-          </a:solidFill>
-          <a:ln w="9525">
-            <a:solidFill>
-              <a:srgbClr val="D9D9D9"/>
-            </a:solidFill>
-          </a:ln>
-          <a:effectLst/>
-        </p:spPr>
-        <p:style>
-          <a:lnRef idx="1">
-            <a:schemeClr val="accent1"/>
-          </a:lnRef>
-          <a:fillRef idx="3">
-            <a:schemeClr val="accent1"/>
-          </a:fillRef>
-          <a:effectRef idx="2">
-            <a:schemeClr val="accent1"/>
-          </a:effectRef>
-          <a:fontRef idx="minor">
-            <a:schemeClr val="lt1"/>
-          </a:fontRef>
-        </p:style>
-        <p:txBody>
-          <a:bodyPr rtlCol="0" anchor="ctr"/>
-          <a:lstStyle/>
-          <a:p>
-            <a:pPr algn="ctr"/>
-          </a:p>
-        </p:txBody>
-      </p:sp>
-      <p:sp>
-        <p:nvSpPr>
-          <p:cNvPr id="9" name="Oval 8"/>
-          <p:cNvSpPr/>
-          <p:nvPr/>
-        </p:nvSpPr>
-        <p:spPr>
-          <a:xfrm>
-            <a:off x="4453128" y="1783080"/>
-            <a:ext cx="384048" cy="384048"/>
-          </a:xfrm>
-          <a:prstGeom prst="ellipse">
-            <a:avLst/>
-          </a:prstGeom>
-          <a:solidFill>
-            <a:srgbClr val="0070F2"/>
-          </a:solidFill>
-          <a:ln>
-            <a:noFill/>
-          </a:ln>
-          <a:effectLst/>
-        </p:spPr>
-        <p:style>
-          <a:lnRef idx="1">
-            <a:schemeClr val="accent1"/>
-          </a:lnRef>
-          <a:fillRef idx="3">
-            <a:schemeClr val="accent1"/>
-          </a:fillRef>
-          <a:effectRef idx="2">
-            <a:schemeClr val="accent1"/>
-          </a:effectRef>
-          <a:fontRef idx="minor">
-            <a:schemeClr val="lt1"/>
-          </a:fontRef>
-        </p:style>
-        <p:txBody>
-          <a:bodyPr rtlCol="0" anchor="ctr" lIns="0" rIns="0" tIns="0" bIns="0"/>
-          <a:lstStyle/>
-          <a:p>
-            <a:pPr algn="ctr"/>
-            <a:r>
-              <a:rPr sz="1500" b="1">
-                <a:solidFill>
-                  <a:srgbClr val="FFFFFF"/>
-                </a:solidFill>
-                <a:latin typeface="Arial"/>
-              </a:rPr>
-              <a:t>2</a:t>
-            </a:r>
-          </a:p>
-        </p:txBody>
-      </p:sp>
-      <p:sp>
-        <p:nvSpPr>
-          <p:cNvPr id="10" name="TextBox 9"/>
-          <p:cNvSpPr txBox="1"/>
-          <p:nvPr/>
-        </p:nvSpPr>
-        <p:spPr>
-          <a:xfrm>
-            <a:off x="4965192" y="1819656"/>
-            <a:ext cx="2697480" cy="320040"/>
-          </a:xfrm>
-          <a:prstGeom prst="rect">
-            <a:avLst/>
-          </a:prstGeom>
-          <a:noFill/>
-        </p:spPr>
-        <p:txBody>
-          <a:bodyPr wrap="square" lIns="0" rIns="0" tIns="0" bIns="0">
-            <a:spAutoFit/>
-          </a:bodyPr>
-          <a:lstStyle/>
-          <a:p>
-            <a:pPr algn="l"/>
-            <a:r>
-              <a:rPr sz="1400" b="1">
-                <a:solidFill>
-                  <a:srgbClr val="1D2D3E"/>
-                </a:solidFill>
-                <a:latin typeface="Arial"/>
-              </a:rPr>
-              <a:t>Features</a:t>
-            </a:r>
-          </a:p>
-        </p:txBody>
-      </p:sp>
-      <p:sp>
-        <p:nvSpPr>
-          <p:cNvPr id="11" name="TextBox 10"/>
-          <p:cNvSpPr txBox="1"/>
-          <p:nvPr/>
-        </p:nvSpPr>
-        <p:spPr>
-          <a:xfrm>
-            <a:off x="4507992" y="2203704"/>
-            <a:ext cx="3063240" cy="822960"/>
-          </a:xfrm>
-          <a:prstGeom prst="rect">
-            <a:avLst/>
-          </a:prstGeom>
-          <a:noFill/>
-        </p:spPr>
-        <p:txBody>
-          <a:bodyPr wrap="square" lIns="0" rIns="0" tIns="0" bIns="0">
-            <a:spAutoFit/>
-          </a:bodyPr>
-          <a:lstStyle/>
-          <a:p>
-            <a:pPr algn="l">
-              <a:lnSpc>
-                <a:spcPct val="110000"/>
-              </a:lnSpc>
-            </a:pPr>
-            <a:r>
-              <a:rPr sz="1050" b="0">
-                <a:solidFill>
-                  <a:srgbClr val="556B82"/>
-                </a:solidFill>
-                <a:latin typeface="Arial"/>
-              </a:rPr>
-              <a:t>The context already on screen: meter type and status, DER equipment, payment behavior, program history, usage</a:t>
-            </a:r>
-          </a:p>
-        </p:txBody>
-      </p:sp>
-      <p:sp>
-        <p:nvSpPr>
-          <p:cNvPr id="12" name="Rounded Rectangle 11"/>
-          <p:cNvSpPr/>
-          <p:nvPr/>
-        </p:nvSpPr>
-        <p:spPr>
-          <a:xfrm>
-            <a:off x="7955279" y="1600200"/>
-            <a:ext cx="3520440" cy="1481328"/>
-          </a:xfrm>
-          <a:prstGeom prst="roundRect">
-            <a:avLst>
-              <a:gd name="adj" fmla="val 8000"/>
-            </a:avLst>
-          </a:prstGeom>
-          <a:solidFill>
-            <a:srgbClr val="F5F6F7"/>
-          </a:solidFill>
-          <a:ln w="9525">
-            <a:solidFill>
-              <a:srgbClr val="D9D9D9"/>
-            </a:solidFill>
-          </a:ln>
-          <a:effectLst/>
-        </p:spPr>
-        <p:style>
-          <a:lnRef idx="1">
-            <a:schemeClr val="accent1"/>
-          </a:lnRef>
-          <a:fillRef idx="3">
-            <a:schemeClr val="accent1"/>
-          </a:fillRef>
-          <a:effectRef idx="2">
-            <a:schemeClr val="accent1"/>
-          </a:effectRef>
-          <a:fontRef idx="minor">
-            <a:schemeClr val="lt1"/>
-          </a:fontRef>
-        </p:style>
-        <p:txBody>
-          <a:bodyPr rtlCol="0" anchor="ctr"/>
-          <a:lstStyle/>
-          <a:p>
-            <a:pPr algn="ctr"/>
-          </a:p>
-        </p:txBody>
-      </p:sp>
-      <p:sp>
-        <p:nvSpPr>
-          <p:cNvPr id="13" name="Oval 12"/>
-          <p:cNvSpPr/>
-          <p:nvPr/>
-        </p:nvSpPr>
-        <p:spPr>
-          <a:xfrm>
-            <a:off x="8156448" y="1783080"/>
-            <a:ext cx="384048" cy="384048"/>
-          </a:xfrm>
-          <a:prstGeom prst="ellipse">
-            <a:avLst/>
-          </a:prstGeom>
-          <a:solidFill>
-            <a:srgbClr val="0070F2"/>
-          </a:solidFill>
-          <a:ln>
-            <a:noFill/>
-          </a:ln>
-          <a:effectLst/>
-        </p:spPr>
-        <p:style>
-          <a:lnRef idx="1">
-            <a:schemeClr val="accent1"/>
-          </a:lnRef>
-          <a:fillRef idx="3">
-            <a:schemeClr val="accent1"/>
-          </a:fillRef>
-          <a:effectRef idx="2">
-            <a:schemeClr val="accent1"/>
-          </a:effectRef>
-          <a:fontRef idx="minor">
-            <a:schemeClr val="lt1"/>
-          </a:fontRef>
-        </p:style>
-        <p:txBody>
-          <a:bodyPr rtlCol="0" anchor="ctr" lIns="0" rIns="0" tIns="0" bIns="0"/>
-          <a:lstStyle/>
-          <a:p>
-            <a:pPr algn="ctr"/>
-            <a:r>
-              <a:rPr sz="1500" b="1">
-                <a:solidFill>
-                  <a:srgbClr val="FFFFFF"/>
-                </a:solidFill>
-                <a:latin typeface="Arial"/>
-              </a:rPr>
-              <a:t>3</a:t>
-            </a:r>
-          </a:p>
-        </p:txBody>
-      </p:sp>
-      <p:sp>
-        <p:nvSpPr>
-          <p:cNvPr id="14" name="TextBox 13"/>
-          <p:cNvSpPr txBox="1"/>
-          <p:nvPr/>
-        </p:nvSpPr>
-        <p:spPr>
-          <a:xfrm>
-            <a:off x="8668511" y="1819656"/>
-            <a:ext cx="2697480" cy="320040"/>
-          </a:xfrm>
-          <a:prstGeom prst="rect">
-            <a:avLst/>
-          </a:prstGeom>
-          <a:noFill/>
-        </p:spPr>
-        <p:txBody>
-          <a:bodyPr wrap="square" lIns="0" rIns="0" tIns="0" bIns="0">
-            <a:spAutoFit/>
-          </a:bodyPr>
-          <a:lstStyle/>
-          <a:p>
-            <a:pPr algn="l"/>
-            <a:r>
-              <a:rPr sz="1400" b="1">
-                <a:solidFill>
-                  <a:srgbClr val="1D2D3E"/>
-                </a:solidFill>
-                <a:latin typeface="Arial"/>
-              </a:rPr>
-              <a:t>Model</a:t>
-            </a:r>
-          </a:p>
-        </p:txBody>
-      </p:sp>
-      <p:sp>
-        <p:nvSpPr>
-          <p:cNvPr id="15" name="TextBox 14"/>
-          <p:cNvSpPr txBox="1"/>
-          <p:nvPr/>
-        </p:nvSpPr>
-        <p:spPr>
-          <a:xfrm>
-            <a:off x="8211311" y="2203704"/>
-            <a:ext cx="3063240" cy="822960"/>
-          </a:xfrm>
-          <a:prstGeom prst="rect">
-            <a:avLst/>
-          </a:prstGeom>
-          <a:noFill/>
-        </p:spPr>
-        <p:txBody>
-          <a:bodyPr wrap="square" lIns="0" rIns="0" tIns="0" bIns="0">
-            <a:spAutoFit/>
-          </a:bodyPr>
-          <a:lstStyle/>
-          <a:p>
-            <a:pPr algn="l">
-              <a:lnSpc>
-                <a:spcPct val="110000"/>
-              </a:lnSpc>
-            </a:pPr>
-            <a:r>
-              <a:rPr sz="1050" b="0">
-                <a:solidFill>
-                  <a:srgbClr val="556B82"/>
-                </a:solidFill>
-                <a:latin typeface="Arial"/>
-              </a:rPr>
-              <a:t>A classification model on SAP HANA Cloud turns those features into a raw probability</a:t>
-            </a:r>
-          </a:p>
-        </p:txBody>
-      </p:sp>
-      <p:sp>
-        <p:nvSpPr>
-          <p:cNvPr id="16" name="Rounded Rectangle 15"/>
-          <p:cNvSpPr/>
-          <p:nvPr/>
-        </p:nvSpPr>
-        <p:spPr>
-          <a:xfrm>
-            <a:off x="548640" y="3246120"/>
-            <a:ext cx="3520440" cy="1481328"/>
-          </a:xfrm>
-          <a:prstGeom prst="roundRect">
-            <a:avLst>
-              <a:gd name="adj" fmla="val 8000"/>
-            </a:avLst>
-          </a:prstGeom>
-          <a:solidFill>
-            <a:srgbClr val="F5F6F7"/>
-          </a:solidFill>
-          <a:ln w="9525">
-            <a:solidFill>
-              <a:srgbClr val="D9D9D9"/>
-            </a:solidFill>
-          </a:ln>
-          <a:effectLst/>
-        </p:spPr>
-        <p:style>
-          <a:lnRef idx="1">
-            <a:schemeClr val="accent1"/>
-          </a:lnRef>
-          <a:fillRef idx="3">
-            <a:schemeClr val="accent1"/>
-          </a:fillRef>
-          <a:effectRef idx="2">
-            <a:schemeClr val="accent1"/>
-          </a:effectRef>
-          <a:fontRef idx="minor">
-            <a:schemeClr val="lt1"/>
-          </a:fontRef>
-        </p:style>
-        <p:txBody>
-          <a:bodyPr rtlCol="0" anchor="ctr"/>
-          <a:lstStyle/>
-          <a:p>
-            <a:pPr algn="ctr"/>
-          </a:p>
-        </p:txBody>
-      </p:sp>
-      <p:sp>
-        <p:nvSpPr>
-          <p:cNvPr id="17" name="Oval 16"/>
-          <p:cNvSpPr/>
-          <p:nvPr/>
-        </p:nvSpPr>
-        <p:spPr>
-          <a:xfrm>
-            <a:off x="749808" y="3429000"/>
-            <a:ext cx="384048" cy="384048"/>
-          </a:xfrm>
-          <a:prstGeom prst="ellipse">
-            <a:avLst/>
-          </a:prstGeom>
-          <a:solidFill>
-            <a:srgbClr val="0070F2"/>
-          </a:solidFill>
-          <a:ln>
-            <a:noFill/>
-          </a:ln>
-          <a:effectLst/>
-        </p:spPr>
-        <p:style>
-          <a:lnRef idx="1">
-            <a:schemeClr val="accent1"/>
-          </a:lnRef>
-          <a:fillRef idx="3">
-            <a:schemeClr val="accent1"/>
-          </a:fillRef>
-          <a:effectRef idx="2">
-            <a:schemeClr val="accent1"/>
-          </a:effectRef>
-          <a:fontRef idx="minor">
-            <a:schemeClr val="lt1"/>
-          </a:fontRef>
-        </p:style>
-        <p:txBody>
-          <a:bodyPr rtlCol="0" anchor="ctr" lIns="0" rIns="0" tIns="0" bIns="0"/>
-          <a:lstStyle/>
-          <a:p>
-            <a:pPr algn="ctr"/>
-            <a:r>
-              <a:rPr sz="1500" b="1">
-                <a:solidFill>
-                  <a:srgbClr val="FFFFFF"/>
-                </a:solidFill>
-                <a:latin typeface="Arial"/>
-              </a:rPr>
-              <a:t>4</a:t>
-            </a:r>
-          </a:p>
-        </p:txBody>
-      </p:sp>
-      <p:sp>
-        <p:nvSpPr>
-          <p:cNvPr id="18" name="TextBox 17"/>
-          <p:cNvSpPr txBox="1"/>
-          <p:nvPr/>
-        </p:nvSpPr>
-        <p:spPr>
-          <a:xfrm>
-            <a:off x="1261872" y="3465576"/>
-            <a:ext cx="2697480" cy="320040"/>
-          </a:xfrm>
-          <a:prstGeom prst="rect">
-            <a:avLst/>
-          </a:prstGeom>
-          <a:noFill/>
-        </p:spPr>
-        <p:txBody>
-          <a:bodyPr wrap="square" lIns="0" rIns="0" tIns="0" bIns="0">
-            <a:spAutoFit/>
-          </a:bodyPr>
-          <a:lstStyle/>
-          <a:p>
-            <a:pPr algn="l"/>
-            <a:r>
-              <a:rPr sz="1400" b="1">
-                <a:solidFill>
-                  <a:srgbClr val="1D2D3E"/>
-                </a:solidFill>
-                <a:latin typeface="Arial"/>
-              </a:rPr>
-              <a:t>Calibration</a:t>
-            </a:r>
-          </a:p>
-        </p:txBody>
-      </p:sp>
-      <p:sp>
-        <p:nvSpPr>
-          <p:cNvPr id="19" name="TextBox 18"/>
-          <p:cNvSpPr txBox="1"/>
-          <p:nvPr/>
-        </p:nvSpPr>
-        <p:spPr>
-          <a:xfrm>
-            <a:off x="804672" y="3849624"/>
-            <a:ext cx="3063240" cy="822960"/>
-          </a:xfrm>
-          <a:prstGeom prst="rect">
-            <a:avLst/>
-          </a:prstGeom>
-          <a:noFill/>
-        </p:spPr>
-        <p:txBody>
-          <a:bodyPr wrap="square" lIns="0" rIns="0" tIns="0" bIns="0">
-            <a:spAutoFit/>
-          </a:bodyPr>
-          <a:lstStyle/>
-          <a:p>
-            <a:pPr algn="l">
-              <a:lnSpc>
-                <a:spcPct val="110000"/>
-              </a:lnSpc>
-            </a:pPr>
-            <a:r>
-              <a:rPr sz="1050" b="0">
-                <a:solidFill>
-                  <a:srgbClr val="556B82"/>
-                </a:solidFill>
-                <a:latin typeface="Arial"/>
-              </a:rPr>
-              <a:t>Adjusted so the number means what it says: of customers scored 87%, about 87% actually enroll</a:t>
-            </a:r>
-          </a:p>
-        </p:txBody>
-      </p:sp>
-      <p:sp>
-        <p:nvSpPr>
-          <p:cNvPr id="20" name="Rounded Rectangle 19"/>
-          <p:cNvSpPr/>
-          <p:nvPr/>
-        </p:nvSpPr>
-        <p:spPr>
-          <a:xfrm>
-            <a:off x="4251960" y="3246120"/>
-            <a:ext cx="3520440" cy="1481328"/>
-          </a:xfrm>
-          <a:prstGeom prst="roundRect">
-            <a:avLst>
-              <a:gd name="adj" fmla="val 8000"/>
-            </a:avLst>
-          </a:prstGeom>
-          <a:solidFill>
-            <a:srgbClr val="F5F6F7"/>
-          </a:solidFill>
-          <a:ln w="9525">
-            <a:solidFill>
-              <a:srgbClr val="D9D9D9"/>
-            </a:solidFill>
-          </a:ln>
-          <a:effectLst/>
-        </p:spPr>
-        <p:style>
-          <a:lnRef idx="1">
-            <a:schemeClr val="accent1"/>
-          </a:lnRef>
-          <a:fillRef idx="3">
-            <a:schemeClr val="accent1"/>
-          </a:fillRef>
-          <a:effectRef idx="2">
-            <a:schemeClr val="accent1"/>
-          </a:effectRef>
-          <a:fontRef idx="minor">
-            <a:schemeClr val="lt1"/>
-          </a:fontRef>
-        </p:style>
-        <p:txBody>
-          <a:bodyPr rtlCol="0" anchor="ctr"/>
-          <a:lstStyle/>
-          <a:p>
-            <a:pPr algn="ctr"/>
-          </a:p>
-        </p:txBody>
-      </p:sp>
-      <p:sp>
-        <p:nvSpPr>
-          <p:cNvPr id="21" name="Oval 20"/>
-          <p:cNvSpPr/>
-          <p:nvPr/>
-        </p:nvSpPr>
-        <p:spPr>
-          <a:xfrm>
-            <a:off x="4453128" y="3429000"/>
-            <a:ext cx="384048" cy="384048"/>
-          </a:xfrm>
-          <a:prstGeom prst="ellipse">
-            <a:avLst/>
-          </a:prstGeom>
-          <a:solidFill>
-            <a:srgbClr val="0070F2"/>
-          </a:solidFill>
-          <a:ln>
-            <a:noFill/>
-          </a:ln>
-          <a:effectLst/>
-        </p:spPr>
-        <p:style>
-          <a:lnRef idx="1">
-            <a:schemeClr val="accent1"/>
-          </a:lnRef>
-          <a:fillRef idx="3">
-            <a:schemeClr val="accent1"/>
-          </a:fillRef>
-          <a:effectRef idx="2">
-            <a:schemeClr val="accent1"/>
-          </a:effectRef>
-          <a:fontRef idx="minor">
-            <a:schemeClr val="lt1"/>
-          </a:fontRef>
-        </p:style>
-        <p:txBody>
-          <a:bodyPr rtlCol="0" anchor="ctr" lIns="0" rIns="0" tIns="0" bIns="0"/>
-          <a:lstStyle/>
-          <a:p>
-            <a:pPr algn="ctr"/>
-            <a:r>
-              <a:rPr sz="1500" b="1">
-                <a:solidFill>
-                  <a:srgbClr val="FFFFFF"/>
-                </a:solidFill>
-                <a:latin typeface="Arial"/>
-              </a:rPr>
-              <a:t>5</a:t>
-            </a:r>
-          </a:p>
-        </p:txBody>
-      </p:sp>
-      <p:sp>
-        <p:nvSpPr>
-          <p:cNvPr id="22" name="TextBox 21"/>
-          <p:cNvSpPr txBox="1"/>
-          <p:nvPr/>
-        </p:nvSpPr>
-        <p:spPr>
-          <a:xfrm>
-            <a:off x="4965192" y="3465576"/>
-            <a:ext cx="2697480" cy="320040"/>
-          </a:xfrm>
-          <a:prstGeom prst="rect">
-            <a:avLst/>
-          </a:prstGeom>
-          <a:noFill/>
-        </p:spPr>
-        <p:txBody>
-          <a:bodyPr wrap="square" lIns="0" rIns="0" tIns="0" bIns="0">
-            <a:spAutoFit/>
-          </a:bodyPr>
-          <a:lstStyle/>
-          <a:p>
-            <a:pPr algn="l"/>
-            <a:r>
-              <a:rPr sz="1400" b="1">
-                <a:solidFill>
-                  <a:srgbClr val="1D2D3E"/>
-                </a:solidFill>
-                <a:latin typeface="Arial"/>
-              </a:rPr>
-              <a:t>Reason shown</a:t>
-            </a:r>
-          </a:p>
-        </p:txBody>
-      </p:sp>
-      <p:sp>
-        <p:nvSpPr>
-          <p:cNvPr id="23" name="TextBox 22"/>
-          <p:cNvSpPr txBox="1"/>
-          <p:nvPr/>
-        </p:nvSpPr>
-        <p:spPr>
-          <a:xfrm>
-            <a:off x="4507992" y="3849624"/>
-            <a:ext cx="3063240" cy="822960"/>
-          </a:xfrm>
-          <a:prstGeom prst="rect">
-            <a:avLst/>
-          </a:prstGeom>
-          <a:noFill/>
-        </p:spPr>
-        <p:txBody>
-          <a:bodyPr wrap="square" lIns="0" rIns="0" tIns="0" bIns="0">
-            <a:spAutoFit/>
-          </a:bodyPr>
-          <a:lstStyle/>
-          <a:p>
-            <a:pPr algn="l">
-              <a:lnSpc>
-                <a:spcPct val="110000"/>
-              </a:lnSpc>
-            </a:pPr>
-            <a:r>
-              <a:rPr sz="1050" b="0">
-                <a:solidFill>
-                  <a:srgbClr val="556B82"/>
-                </a:solidFill>
-                <a:latin typeface="Arial"/>
-              </a:rPr>
-              <a:t>The line under the badge comes from the model's top contributing factors — never free text</a:t>
-            </a:r>
-          </a:p>
-        </p:txBody>
-      </p:sp>
-      <p:sp>
-        <p:nvSpPr>
-          <p:cNvPr id="24" name="Rounded Rectangle 23"/>
-          <p:cNvSpPr/>
-          <p:nvPr/>
-        </p:nvSpPr>
-        <p:spPr>
-          <a:xfrm>
-            <a:off x="7955279" y="3246120"/>
-            <a:ext cx="3520440" cy="1481328"/>
-          </a:xfrm>
-          <a:prstGeom prst="roundRect">
-            <a:avLst>
-              <a:gd name="adj" fmla="val 8000"/>
-            </a:avLst>
-          </a:prstGeom>
-          <a:solidFill>
-            <a:srgbClr val="F5F6F7"/>
-          </a:solidFill>
-          <a:ln w="9525">
-            <a:solidFill>
-              <a:srgbClr val="D9D9D9"/>
-            </a:solidFill>
-          </a:ln>
-          <a:effectLst/>
-        </p:spPr>
-        <p:style>
-          <a:lnRef idx="1">
-            <a:schemeClr val="accent1"/>
-          </a:lnRef>
-          <a:fillRef idx="3">
-            <a:schemeClr val="accent1"/>
-          </a:fillRef>
-          <a:effectRef idx="2">
-            <a:schemeClr val="accent1"/>
-          </a:effectRef>
-          <a:fontRef idx="minor">
-            <a:schemeClr val="lt1"/>
-          </a:fontRef>
-        </p:style>
-        <p:txBody>
-          <a:bodyPr rtlCol="0" anchor="ctr"/>
-          <a:lstStyle/>
-          <a:p>
-            <a:pPr algn="ctr"/>
-          </a:p>
-        </p:txBody>
-      </p:sp>
-      <p:sp>
-        <p:nvSpPr>
-          <p:cNvPr id="25" name="Oval 24"/>
-          <p:cNvSpPr/>
-          <p:nvPr/>
-        </p:nvSpPr>
-        <p:spPr>
-          <a:xfrm>
-            <a:off x="8156448" y="3429000"/>
-            <a:ext cx="384048" cy="384048"/>
-          </a:xfrm>
-          <a:prstGeom prst="ellipse">
-            <a:avLst/>
-          </a:prstGeom>
-          <a:solidFill>
-            <a:srgbClr val="0070F2"/>
-          </a:solidFill>
-          <a:ln>
-            <a:noFill/>
-          </a:ln>
-          <a:effectLst/>
-        </p:spPr>
-        <p:style>
-          <a:lnRef idx="1">
-            <a:schemeClr val="accent1"/>
-          </a:lnRef>
-          <a:fillRef idx="3">
-            <a:schemeClr val="accent1"/>
-          </a:fillRef>
-          <a:effectRef idx="2">
-            <a:schemeClr val="accent1"/>
-          </a:effectRef>
-          <a:fontRef idx="minor">
-            <a:schemeClr val="lt1"/>
-          </a:fontRef>
-        </p:style>
-        <p:txBody>
-          <a:bodyPr rtlCol="0" anchor="ctr" lIns="0" rIns="0" tIns="0" bIns="0"/>
-          <a:lstStyle/>
-          <a:p>
-            <a:pPr algn="ctr"/>
-            <a:r>
-              <a:rPr sz="1500" b="1">
-                <a:solidFill>
-                  <a:srgbClr val="FFFFFF"/>
-                </a:solidFill>
-                <a:latin typeface="Arial"/>
-              </a:rPr>
-              <a:t>6</a:t>
-            </a:r>
-          </a:p>
-        </p:txBody>
-      </p:sp>
-      <p:sp>
-        <p:nvSpPr>
-          <p:cNvPr id="26" name="TextBox 25"/>
-          <p:cNvSpPr txBox="1"/>
-          <p:nvPr/>
-        </p:nvSpPr>
-        <p:spPr>
-          <a:xfrm>
-            <a:off x="8668511" y="3465576"/>
-            <a:ext cx="2697480" cy="320040"/>
-          </a:xfrm>
-          <a:prstGeom prst="rect">
-            <a:avLst/>
-          </a:prstGeom>
-          <a:noFill/>
-        </p:spPr>
-        <p:txBody>
-          <a:bodyPr wrap="square" lIns="0" rIns="0" tIns="0" bIns="0">
-            <a:spAutoFit/>
-          </a:bodyPr>
-          <a:lstStyle/>
-          <a:p>
-            <a:pPr algn="l"/>
-            <a:r>
-              <a:rPr sz="1400" b="1">
-                <a:solidFill>
-                  <a:srgbClr val="1D2D3E"/>
-                </a:solidFill>
-                <a:latin typeface="Arial"/>
-              </a:rPr>
-              <a:t>Ranking</a:t>
-            </a:r>
-          </a:p>
-        </p:txBody>
-      </p:sp>
-      <p:sp>
-        <p:nvSpPr>
-          <p:cNvPr id="27" name="TextBox 26"/>
-          <p:cNvSpPr txBox="1"/>
-          <p:nvPr/>
-        </p:nvSpPr>
-        <p:spPr>
-          <a:xfrm>
-            <a:off x="8211311" y="3849624"/>
-            <a:ext cx="3063240" cy="822960"/>
-          </a:xfrm>
-          <a:prstGeom prst="rect">
-            <a:avLst/>
-          </a:prstGeom>
-          <a:noFill/>
-        </p:spPr>
-        <p:txBody>
-          <a:bodyPr wrap="square" lIns="0" rIns="0" tIns="0" bIns="0">
-            <a:spAutoFit/>
-          </a:bodyPr>
-          <a:lstStyle/>
-          <a:p>
-            <a:pPr algn="l">
-              <a:lnSpc>
-                <a:spcPct val="110000"/>
-              </a:lnSpc>
-            </a:pPr>
-            <a:r>
-              <a:rPr sz="1050" b="0">
-                <a:solidFill>
-                  <a:srgbClr val="556B82"/>
-                </a:solidFill>
-                <a:latin typeface="Arial"/>
-              </a:rPr>
-              <a:t>Sort order weighs probability × program value — high-value programs can outrank easy wins</a:t>
-            </a:r>
-          </a:p>
-        </p:txBody>
-      </p:sp>
-      <p:sp>
-        <p:nvSpPr>
-          <p:cNvPr id="28" name="Rounded Rectangle 27"/>
-          <p:cNvSpPr/>
-          <p:nvPr/>
-        </p:nvSpPr>
-        <p:spPr>
-          <a:xfrm>
-            <a:off x="548640" y="5029200"/>
-            <a:ext cx="11064240" cy="1188720"/>
-          </a:xfrm>
-          <a:prstGeom prst="roundRect">
-            <a:avLst>
-              <a:gd name="adj" fmla="val 8000"/>
-            </a:avLst>
-          </a:prstGeom>
-          <a:solidFill>
-            <a:srgbClr val="12233F"/>
-          </a:solidFill>
-          <a:ln w="9525">
-            <a:solidFill>
-              <a:srgbClr val="12233F"/>
-            </a:solidFill>
-          </a:ln>
-          <a:effectLst/>
-        </p:spPr>
-        <p:style>
-          <a:lnRef idx="1">
-            <a:schemeClr val="accent1"/>
-          </a:lnRef>
-          <a:fillRef idx="3">
-            <a:schemeClr val="accent1"/>
-          </a:fillRef>
-          <a:effectRef idx="2">
-            <a:schemeClr val="accent1"/>
-          </a:effectRef>
-          <a:fontRef idx="minor">
-            <a:schemeClr val="lt1"/>
-          </a:fontRef>
-        </p:style>
-        <p:txBody>
-          <a:bodyPr rtlCol="0" anchor="ctr"/>
-          <a:lstStyle/>
-          <a:p>
-            <a:pPr algn="ctr"/>
-          </a:p>
-        </p:txBody>
-      </p:sp>
-      <p:sp>
-        <p:nvSpPr>
-          <p:cNvPr id="29" name="TextBox 28"/>
-          <p:cNvSpPr txBox="1"/>
-          <p:nvPr/>
-        </p:nvSpPr>
-        <p:spPr>
-          <a:xfrm>
-            <a:off x="822960" y="5193792"/>
-            <a:ext cx="6949440" cy="868680"/>
-          </a:xfrm>
-          <a:prstGeom prst="rect">
-            <a:avLst/>
-          </a:prstGeom>
-          <a:noFill/>
-        </p:spPr>
-        <p:txBody>
-          <a:bodyPr wrap="square" lIns="0" rIns="0" tIns="0" bIns="0">
-            <a:spAutoFit/>
-          </a:bodyPr>
-          <a:lstStyle/>
-          <a:p>
-            <a:pPr algn="l">
-              <a:lnSpc>
-                <a:spcPct val="120000"/>
-              </a:lnSpc>
-            </a:pPr>
-            <a:r>
-              <a:rPr sz="1250" b="0">
-                <a:solidFill>
-                  <a:srgbClr val="CADCFC"/>
-                </a:solidFill>
-                <a:latin typeface="Arial"/>
-              </a:rPr>
-              <a:t>Cold start: launches on weighted business rules, swaps to the trained model after 3–6 months of outcomes.</a:t>
-            </a:r>
-          </a:p>
-          <a:p>
-            <a:pPr algn="l">
-              <a:lnSpc>
-                <a:spcPct val="120000"/>
-              </a:lnSpc>
-            </a:pPr>
-            <a:r>
-              <a:rPr sz="1250" b="0">
-                <a:solidFill>
-                  <a:srgbClr val="CADCFC"/>
-                </a:solidFill>
-                <a:latin typeface="Arial"/>
-              </a:rPr>
-              <a:t>The model never decides eligibility — that stays in the BRFplus rules engine.</a:t>
-            </a:r>
-          </a:p>
-        </p:txBody>
-      </p:sp>
-      <p:sp>
-        <p:nvSpPr>
-          <p:cNvPr id="30" name="TextBox 29"/>
-          <p:cNvSpPr txBox="1"/>
-          <p:nvPr/>
-        </p:nvSpPr>
-        <p:spPr>
-          <a:xfrm>
-            <a:off x="8046720" y="5193792"/>
-            <a:ext cx="3291840" cy="868680"/>
-          </a:xfrm>
-          <a:prstGeom prst="rect">
-            <a:avLst/>
-          </a:prstGeom>
-          <a:noFill/>
-        </p:spPr>
-        <p:txBody>
-          <a:bodyPr wrap="square" lIns="0" rIns="0" tIns="0" bIns="0">
-            <a:spAutoFit/>
-          </a:bodyPr>
-          <a:lstStyle/>
-          <a:p>
-            <a:pPr algn="l">
-              <a:lnSpc>
-                <a:spcPct val="120000"/>
-              </a:lnSpc>
-            </a:pPr>
-            <a:r>
-              <a:rPr sz="1250" b="1">
-                <a:solidFill>
-                  <a:srgbClr val="FFB300"/>
-                </a:solidFill>
-                <a:latin typeface="Arial"/>
-              </a:rPr>
-              <a:t>Live in the demo:</a:t>
-            </a:r>
-          </a:p>
-          <a:p>
-            <a:pPr algn="l">
-              <a:lnSpc>
-                <a:spcPct val="120000"/>
-              </a:lnSpc>
-            </a:pPr>
-            <a:r>
-              <a:rPr sz="1250" b="1">
-                <a:solidFill>
-                  <a:srgbClr val="FFB300"/>
-                </a:solidFill>
-                <a:latin typeface="Arial"/>
-              </a:rPr>
-              <a:t>click any ✨ AI badge for this explanation</a:t>
+              <a:t>Demo: sri-varahi-global-business-services-llc.github.io/enrollment-center-demo  (soon: demo.svgbs.com)   ·   Full design set available for review</a:t>
             </a:r>
           </a:p>
         </p:txBody>
@@ -10126,13 +10126,13 @@
           <a:p>
             <a:pPr algn="l"/>
             <a:r>
-              <a:rPr sz="1150" b="1">
+              <a:rPr sz="950" b="1">
                 <a:solidFill>
                   <a:srgbClr val="FFB300"/>
                 </a:solidFill>
                 <a:latin typeface="Arial"/>
               </a:rPr>
-              <a:t>demo.svgbs.com  (pending DNS; live: sri-varahi-global-business-services-llc.github.io/enrollment-center-demo)</a:t>
+              <a:t>sri-varahi-global-business-services-llc.github.io/enrollment-center-demo/</a:t>
             </a:r>
           </a:p>
         </p:txBody>
@@ -10285,7 +10285,7 @@
                 </a:solidFill>
                 <a:latin typeface="Arial"/>
               </a:rPr>
-              <a:t>demo.svgbs.com/workcenter.html</a:t>
+              <a:t>…/enrollment-center-demo/workcenter.html</a:t>
             </a:r>
           </a:p>
         </p:txBody>
@@ -10438,7 +10438,7 @@
                 </a:solidFill>
                 <a:latin typeface="Arial"/>
               </a:rPr>
-              <a:t>demo.svgbs.com/movein.html</a:t>
+              <a:t>…/enrollment-center-demo/movein.html</a:t>
             </a:r>
           </a:p>
         </p:txBody>
@@ -10962,6 +10962,49 @@
                 <a:latin typeface="Arial"/>
               </a:rPr>
               <a:t>see parked requests fulfill</a:t>
+            </a:r>
+          </a:p>
+        </p:txBody>
+      </p:sp>
+      <p:sp>
+        <p:nvSpPr>
+          <p:cNvPr id="26" name="TextBox 25"/>
+          <p:cNvSpPr txBox="1"/>
+          <p:nvPr/>
+        </p:nvSpPr>
+        <p:spPr>
+          <a:xfrm>
+            <a:off x="548640" y="6053328"/>
+            <a:ext cx="11064240" cy="365760"/>
+          </a:xfrm>
+          <a:prstGeom prst="rect">
+            <a:avLst/>
+          </a:prstGeom>
+          <a:noFill/>
+        </p:spPr>
+        <p:txBody>
+          <a:bodyPr wrap="square" lIns="0" rIns="0" tIns="0" bIns="0">
+            <a:spAutoFit/>
+          </a:bodyPr>
+          <a:lstStyle/>
+          <a:p>
+            <a:r>
+              <a:rPr sz="1150" b="1">
+                <a:solidFill>
+                  <a:srgbClr val="FFB300"/>
+                </a:solidFill>
+                <a:latin typeface="Arial"/>
+              </a:rPr>
+              <a:t>✨ AI/ML methodology page: …/enrollment-center-demo/ai-roadmap.html</a:t>
+            </a:r>
+            <a:r>
+              <a:rPr sz="1100">
+                <a:solidFill>
+                  <a:srgbClr val="CADCFC"/>
+                </a:solidFill>
+                <a:latin typeface="Arial"/>
+              </a:rPr>
+              <a:t>    ·    custom domain demo.svgbs.com activates once DNS lands</a:t>
             </a:r>
           </a:p>
         </p:txBody>

</xml_diff>